<commit_message>
Sync report, slides, and README to the post-audit numbers
Both docs/AutoTender-VN_Report_IEEE.docx and docs/AutoTender-VN_Slides.pptx
still had the retrieval/embedding numbers from before the RAG pipeline
audit (rerank caching, candidate truncation, embedding truncation fixes).
Updated every affected table, chart, and inline figure to the current
reports/retrieval_metrics.json and reports/embedding_comparison.json,
and added a new report subsection (V-B) and slide (12) walking through
the 3 bugs found and their measured before/after impact -- including the
honest mixed result (Recall@5 dipped slightly post-fix on the 46-query
set) rather than only reporting the numbers that improved. README.md's
architecture diagram still said 38 hand-labeled queries; corrected to 46.

Co-Authored-By: Claude Sonnet 5 <noreply@anthropic.com>
</commit_message>
<xml_diff>
--- a/docs/AutoTender-VN_Slides.pptx
+++ b/docs/AutoTender-VN_Slides.pptx
@@ -20,9 +20,10 @@
     <p:sldId id="268" r:id="rId14"/>
     <p:sldId id="269" r:id="rId15"/>
     <p:sldId id="270" r:id="rId16"/>
+    <p:sldId id="271" r:id="rId17"/>
   </p:sldIdLst>
   <p:notesMasterIdLst>
-    <p:notesMasterId r:id="rId17"/>
+    <p:notesMasterId r:id="rId18"/>
   </p:notesMasterIdLst>
   <p:sldSz cx="12192000" cy="6858000"/>
   <p:notesSz cx="6858000" cy="12192000"/>
@@ -232,10 +233,10 @@
                 <c:formatCode>General</c:formatCode>
                 <c:ptCount val="2"/>
                 <c:pt idx="0">
-                  <c:v>0.1595</c:v>
+                  <c:v>0.1836</c:v>
                 </c:pt>
                 <c:pt idx="1">
-                  <c:v>0.1477</c:v>
+                  <c:v>0.1674</c:v>
                 </c:pt>
               </c:numCache>
             </c:numRef>
@@ -481,7 +482,7 @@
                   <c:v>0.674</c:v>
                 </c:pt>
                 <c:pt idx="3">
-                  <c:v>0.804</c:v>
+                  <c:v>0.761</c:v>
                 </c:pt>
               </c:numCache>
             </c:numRef>
@@ -564,13 +565,13 @@
                   <c:v>0.385</c:v>
                 </c:pt>
                 <c:pt idx="1">
-                  <c:v>0.543</c:v>
+                  <c:v>0.546</c:v>
                 </c:pt>
                 <c:pt idx="2">
-                  <c:v>0.507</c:v>
+                  <c:v>0.537</c:v>
                 </c:pt>
                 <c:pt idx="3">
-                  <c:v>0.611</c:v>
+                  <c:v>0.587</c:v>
                 </c:pt>
               </c:numCache>
             </c:numRef>
@@ -653,13 +654,13 @@
                   <c:v>0.426</c:v>
                 </c:pt>
                 <c:pt idx="1">
-                  <c:v>0.575</c:v>
+                  <c:v>0.58</c:v>
                 </c:pt>
                 <c:pt idx="2">
-                  <c:v>0.541</c:v>
+                  <c:v>0.564</c:v>
                 </c:pt>
                 <c:pt idx="3">
-                  <c:v>0.656</c:v>
+                  <c:v>0.627</c:v>
                 </c:pt>
               </c:numCache>
             </c:numRef>
@@ -1776,6 +1777,94 @@
             <a:fld id="{F7021451-1387-4CA6-816F-3879F97B5CBC}" type="slidenum">
               <a:rPr lang="en-US"/>
               <a:t>15</a:t>
+            </a:fld>
+            <a:endParaRPr lang="en-US"/>
+          </a:p>
+        </p:txBody>
+      </p:sp>
+    </p:spTree>
+    <p:extLst>
+      <p:ext uri="{BB962C8B-B14F-4D97-AF65-F5344CB8AC3E}">
+        <p14:creationId xmlns:p14="http://schemas.microsoft.com/office/powerpoint/2010/main" val="1024086991"/>
+      </p:ext>
+    </p:extLst>
+  </p:cSld>
+  <p:clrMapOvr>
+    <a:masterClrMapping/>
+  </p:clrMapOvr>
+</p:notes>
+</file>
+
+<file path=ppt/notesSlides/notesSlide16.xml><?xml version="1.0" encoding="utf-8"?>
+<p:notes xmlns:a="http://schemas.openxmlformats.org/drawingml/2006/main" xmlns:r="http://schemas.openxmlformats.org/officeDocument/2006/relationships" xmlns:p="http://schemas.openxmlformats.org/presentationml/2006/main">
+  <p:cSld>
+    <p:spTree>
+      <p:nvGrpSpPr>
+        <p:cNvPr id="1" name=""/>
+        <p:cNvGrpSpPr/>
+        <p:nvPr/>
+      </p:nvGrpSpPr>
+      <p:grpSpPr>
+        <a:xfrm>
+          <a:off x="0" y="0"/>
+          <a:ext cx="0" cy="0"/>
+          <a:chOff x="0" y="0"/>
+          <a:chExt cx="0" cy="0"/>
+        </a:xfrm>
+      </p:grpSpPr>
+      <p:sp>
+        <p:nvSpPr>
+          <p:cNvPr id="2" name="Slide Image Placeholder 1"/>
+          <p:cNvSpPr>
+            <a:spLocks noGrp="1" noRot="1" noChangeAspect="1"/>
+          </p:cNvSpPr>
+          <p:nvPr>
+            <p:ph type="sldImg"/>
+          </p:nvPr>
+        </p:nvSpPr>
+        <p:spPr/>
+      </p:sp>
+      <p:sp>
+        <p:nvSpPr>
+          <p:cNvPr id="3" name="Notes Placeholder 2"/>
+          <p:cNvSpPr>
+            <a:spLocks noGrp="1"/>
+          </p:cNvSpPr>
+          <p:nvPr>
+            <p:ph type="body" idx="1"/>
+          </p:nvPr>
+        </p:nvSpPr>
+        <p:spPr/>
+        <p:txBody>
+          <a:bodyPr/>
+          <a:lstStyle/>
+          <a:p>
+            <a:r>
+              <a:rPr lang="en-US" dirty="0"/>
+              <a:t/>
+            </a:r>
+            <a:endParaRPr lang="en-US" dirty="0"/>
+          </a:p>
+        </p:txBody>
+      </p:sp>
+      <p:sp>
+        <p:nvSpPr>
+          <p:cNvPr id="4" name="Slide Number Placeholder 3"/>
+          <p:cNvSpPr>
+            <a:spLocks noGrp="1"/>
+          </p:cNvSpPr>
+          <p:nvPr>
+            <p:ph type="sldNum" sz="quarter" idx="10"/>
+          </p:nvPr>
+        </p:nvSpPr>
+        <p:spPr/>
+        <p:txBody>
+          <a:bodyPr/>
+          <a:lstStyle/>
+          <a:p>
+            <a:fld id="{F7021451-1387-4CA6-816F-3879F97B5CBC}" type="slidenum">
+              <a:rPr lang="en-US"/>
+              <a:t>16</a:t>
             </a:fld>
             <a:endParaRPr lang="en-US"/>
           </a:p>
@@ -3735,7 +3824,7 @@
                 <a:ea typeface="Calibri" pitchFamily="34" charset="-122"/>
                 <a:cs typeface="Calibri" pitchFamily="34" charset="-120"/>
               </a:rPr>
-              <a:t>Rerank cross-encoder cải thiện mạnh nhất trên mọi chỉ số — chi phí ~19.7s/câu so với ~0.06–0.3s không rerank.</a:t>
+              <a:t>Rerank cross-encoder cải thiện nhiều nhất trên mọi chỉ số — chi phí ~7.6s/câu (đã giảm 61% sau khi sửa lỗi hiệu năng — slide sau) so với ~0.06–0.3s không rerank.</a:t>
             </a:r>
             <a:endParaRPr lang="en-US" sz="1200" dirty="0"/>
           </a:p>
@@ -3791,6 +3880,887 @@
 <file path=ppt/slides/slide12.xml><?xml version="1.0" encoding="utf-8"?>
 <p:sld xmlns:a="http://schemas.openxmlformats.org/drawingml/2006/main" xmlns:r="http://schemas.openxmlformats.org/officeDocument/2006/relationships" xmlns:p="http://schemas.openxmlformats.org/presentationml/2006/main">
   <p:cSld name="Slide 12">
+    <p:bg>
+      <p:bgPr>
+        <a:solidFill>
+          <a:srgbClr val="F2F0E9"/>
+        </a:solidFill>
+      </p:bgPr>
+    </p:bg>
+    <p:spTree>
+      <p:nvGrpSpPr>
+        <p:cNvPr id="1" name=""/>
+        <p:cNvGrpSpPr/>
+        <p:nvPr/>
+      </p:nvGrpSpPr>
+      <p:grpSpPr>
+        <a:xfrm>
+          <a:off x="0" y="0"/>
+          <a:ext cx="0" cy="0"/>
+          <a:chOff x="0" y="0"/>
+          <a:chExt cx="0" cy="0"/>
+        </a:xfrm>
+      </p:grpSpPr>
+      <p:sp>
+        <p:nvSpPr>
+          <p:cNvPr id="2" name="Text 0"/>
+          <p:cNvSpPr/>
+          <p:nvPr/>
+        </p:nvSpPr>
+        <p:spPr>
+          <a:xfrm>
+            <a:off x="548640" y="365760"/>
+            <a:ext cx="7315200" cy="365760"/>
+          </a:xfrm>
+          <a:prstGeom prst="rect">
+            <a:avLst/>
+          </a:prstGeom>
+          <a:noFill/>
+          <a:ln/>
+        </p:spPr>
+        <p:txBody>
+          <a:bodyPr wrap="square" rtlCol="0" anchor="ctr"/>
+          <a:lstStyle/>
+          <a:p>
+            <a:pPr indent="0" marL="0">
+              <a:buNone/>
+            </a:pPr>
+            <a:r>
+              <a:rPr lang="en-US" sz="1200" b="1" spc="200" kern="0" dirty="0">
+                <a:solidFill>
+                  <a:srgbClr val="2B6E62"/>
+                </a:solidFill>
+                <a:latin typeface="Calibri" pitchFamily="34" charset="0"/>
+                <a:ea typeface="Calibri" pitchFamily="34" charset="-122"/>
+                <a:cs typeface="Calibri" pitchFamily="34" charset="-120"/>
+              </a:rPr>
+              <a:t>RÀ SOÁT KỸ THUẬT PIPELINE</a:t>
+            </a:r>
+            <a:endParaRPr lang="en-US" sz="1200" dirty="0"/>
+          </a:p>
+        </p:txBody>
+      </p:sp>
+      <p:sp>
+        <p:nvSpPr>
+          <p:cNvPr id="3" name="Text 1"/>
+          <p:cNvSpPr/>
+          <p:nvPr/>
+        </p:nvSpPr>
+        <p:spPr>
+          <a:xfrm>
+            <a:off x="548640" y="685800"/>
+            <a:ext cx="11064240" cy="822960"/>
+          </a:xfrm>
+          <a:prstGeom prst="rect">
+            <a:avLst/>
+          </a:prstGeom>
+          <a:noFill/>
+          <a:ln/>
+        </p:spPr>
+        <p:txBody>
+          <a:bodyPr wrap="square" rtlCol="0" anchor="ctr"/>
+          <a:lstStyle/>
+          <a:p>
+            <a:pPr algn="l" indent="0" marL="0">
+              <a:buNone/>
+            </a:pPr>
+            <a:r>
+              <a:rPr lang="en-US" sz="3200" b="1" dirty="0">
+                <a:solidFill>
+                  <a:srgbClr val="17212B"/>
+                </a:solidFill>
+                <a:latin typeface="Cambria" pitchFamily="34" charset="0"/>
+                <a:ea typeface="Cambria" pitchFamily="34" charset="-122"/>
+                <a:cs typeface="Cambria" pitchFamily="34" charset="-120"/>
+              </a:rPr>
+              <a:t>3 lỗi thật phát hiện khi rà soát code — không chỉ đọc tài liệu</a:t>
+            </a:r>
+            <a:endParaRPr lang="en-US" sz="3200" dirty="0"/>
+          </a:p>
+        </p:txBody>
+      </p:sp>
+      <p:sp>
+        <p:nvSpPr>
+          <p:cNvPr id="4" name="Shape 2"/>
+          <p:cNvSpPr/>
+          <p:nvPr/>
+        </p:nvSpPr>
+        <p:spPr>
+          <a:xfrm>
+            <a:off x="548640" y="2148840"/>
+            <a:ext cx="10881360" cy="1234440"/>
+          </a:xfrm>
+          <a:prstGeom prst="roundRect">
+            <a:avLst>
+              <a:gd name="adj" fmla="val 5926"/>
+            </a:avLst>
+          </a:prstGeom>
+          <a:solidFill>
+            <a:srgbClr val="FFFFFF"/>
+          </a:solidFill>
+          <a:ln/>
+          <a:effectLst>
+            <a:outerShdw sx="100000" sy="100000" kx="0" ky="0" algn="bl" rotWithShape="0" blurRad="76200" dist="25400" dir="5400000">
+              <a:srgbClr val="000000">
+                <a:alpha val="12000"/>
+              </a:srgbClr>
+            </a:outerShdw>
+          </a:effectLst>
+        </p:spPr>
+      </p:sp>
+      <p:sp>
+        <p:nvSpPr>
+          <p:cNvPr id="5" name="Shape 3"/>
+          <p:cNvSpPr/>
+          <p:nvPr/>
+        </p:nvSpPr>
+        <p:spPr>
+          <a:xfrm>
+            <a:off x="822960" y="2404872"/>
+            <a:ext cx="685800" cy="685800"/>
+          </a:xfrm>
+          <a:prstGeom prst="ellipse">
+            <a:avLst/>
+          </a:prstGeom>
+          <a:solidFill>
+            <a:srgbClr val="B8863B"/>
+          </a:solidFill>
+          <a:ln/>
+        </p:spPr>
+      </p:sp>
+      <p:sp>
+        <p:nvSpPr>
+          <p:cNvPr id="6" name="Text 4"/>
+          <p:cNvSpPr/>
+          <p:nvPr/>
+        </p:nvSpPr>
+        <p:spPr>
+          <a:xfrm>
+            <a:off x="822960" y="2404872"/>
+            <a:ext cx="685800" cy="685800"/>
+          </a:xfrm>
+          <a:prstGeom prst="rect">
+            <a:avLst/>
+          </a:prstGeom>
+          <a:noFill/>
+          <a:ln/>
+        </p:spPr>
+        <p:txBody>
+          <a:bodyPr wrap="square" rtlCol="0" anchor="ctr"/>
+          <a:lstStyle/>
+          <a:p>
+            <a:pPr algn="ctr" indent="0" marL="0">
+              <a:buNone/>
+            </a:pPr>
+            <a:r>
+              <a:rPr lang="en-US" sz="2600" b="1" dirty="0">
+                <a:solidFill>
+                  <a:srgbClr val="FFFFFF"/>
+                </a:solidFill>
+                <a:latin typeface="Cambria" pitchFamily="34" charset="0"/>
+                <a:ea typeface="Cambria" pitchFamily="34" charset="-122"/>
+                <a:cs typeface="Cambria" pitchFamily="34" charset="-120"/>
+              </a:rPr>
+              <a:t>1</a:t>
+            </a:r>
+            <a:endParaRPr lang="en-US" sz="2600" dirty="0"/>
+          </a:p>
+        </p:txBody>
+      </p:sp>
+      <p:sp>
+        <p:nvSpPr>
+          <p:cNvPr id="7" name="Text 5"/>
+          <p:cNvSpPr/>
+          <p:nvPr/>
+        </p:nvSpPr>
+        <p:spPr>
+          <a:xfrm>
+            <a:off x="1828800" y="2258568"/>
+            <a:ext cx="6126480" cy="365760"/>
+          </a:xfrm>
+          <a:prstGeom prst="rect">
+            <a:avLst/>
+          </a:prstGeom>
+          <a:noFill/>
+          <a:ln/>
+        </p:spPr>
+        <p:txBody>
+          <a:bodyPr wrap="square" rtlCol="0" anchor="ctr"/>
+          <a:lstStyle/>
+          <a:p>
+            <a:pPr indent="0" marL="0">
+              <a:buNone/>
+            </a:pPr>
+            <a:r>
+              <a:rPr lang="en-US" sz="1450" b="1" dirty="0">
+                <a:solidFill>
+                  <a:srgbClr val="17212B"/>
+                </a:solidFill>
+                <a:latin typeface="Cambria" pitchFamily="34" charset="0"/>
+                <a:ea typeface="Cambria" pitchFamily="34" charset="-122"/>
+                <a:cs typeface="Cambria" pitchFamily="34" charset="-120"/>
+              </a:rPr>
+              <a:t>Rerank tải lại model mỗi lượt gọi</a:t>
+            </a:r>
+            <a:endParaRPr lang="en-US" sz="1450" dirty="0"/>
+          </a:p>
+        </p:txBody>
+      </p:sp>
+      <p:sp>
+        <p:nvSpPr>
+          <p:cNvPr id="8" name="Text 6"/>
+          <p:cNvSpPr/>
+          <p:nvPr/>
+        </p:nvSpPr>
+        <p:spPr>
+          <a:xfrm>
+            <a:off x="1828800" y="2624328"/>
+            <a:ext cx="6126480" cy="685800"/>
+          </a:xfrm>
+          <a:prstGeom prst="rect">
+            <a:avLst/>
+          </a:prstGeom>
+          <a:noFill/>
+          <a:ln/>
+        </p:spPr>
+        <p:txBody>
+          <a:bodyPr wrap="square" rtlCol="0" anchor="ctr"/>
+          <a:lstStyle/>
+          <a:p>
+            <a:pPr indent="0" marL="0">
+              <a:lnSpc>
+                <a:spcPts val="1400"/>
+              </a:lnSpc>
+              <a:buNone/>
+            </a:pPr>
+            <a:r>
+              <a:rPr lang="en-US" sz="1100" dirty="0">
+                <a:solidFill>
+                  <a:srgbClr val="5B6672"/>
+                </a:solidFill>
+                <a:latin typeface="Calibri" pitchFamily="34" charset="0"/>
+                <a:ea typeface="Calibri" pitchFamily="34" charset="-122"/>
+                <a:cs typeface="Calibri" pitchFamily="34" charset="-120"/>
+              </a:rPr>
+              <a:t>CrossEncoder khởi tạo lại từ đầu mỗi lần — đo thực tế ~6-7s lãng phí/câu. Thêm cache theo tên model.</a:t>
+            </a:r>
+            <a:endParaRPr lang="en-US" sz="1100" dirty="0"/>
+          </a:p>
+        </p:txBody>
+      </p:sp>
+      <p:sp>
+        <p:nvSpPr>
+          <p:cNvPr id="9" name="Text 7"/>
+          <p:cNvSpPr/>
+          <p:nvPr/>
+        </p:nvSpPr>
+        <p:spPr>
+          <a:xfrm>
+            <a:off x="8138160" y="2286000"/>
+            <a:ext cx="3063240" cy="960120"/>
+          </a:xfrm>
+          <a:prstGeom prst="rect">
+            <a:avLst/>
+          </a:prstGeom>
+          <a:noFill/>
+          <a:ln/>
+        </p:spPr>
+        <p:txBody>
+          <a:bodyPr wrap="square" rtlCol="0" anchor="ctr"/>
+          <a:lstStyle/>
+          <a:p>
+            <a:pPr algn="ctr" indent="0" marL="0">
+              <a:lnSpc>
+                <a:spcPts val="1500"/>
+              </a:lnSpc>
+              <a:buNone/>
+            </a:pPr>
+            <a:r>
+              <a:rPr lang="en-US" sz="1200" b="1" dirty="0">
+                <a:solidFill>
+                  <a:srgbClr val="2B6E62"/>
+                </a:solidFill>
+                <a:latin typeface="Calibri" pitchFamily="34" charset="0"/>
+                <a:ea typeface="Calibri" pitchFamily="34" charset="-122"/>
+                <a:cs typeface="Calibri" pitchFamily="34" charset="-120"/>
+              </a:rPr>
+              <a:t>-57% thời gian rerank</a:t>
+            </a:r>
+            <a:endParaRPr lang="en-US" sz="1200" dirty="0"/>
+          </a:p>
+          <a:p>
+            <a:pPr algn="ctr" indent="0" marL="0">
+              <a:lnSpc>
+                <a:spcPts val="1500"/>
+              </a:lnSpc>
+              <a:buNone/>
+            </a:pPr>
+            <a:r>
+              <a:rPr lang="en-US" sz="1200" b="1" dirty="0">
+                <a:solidFill>
+                  <a:srgbClr val="2B6E62"/>
+                </a:solidFill>
+                <a:latin typeface="Calibri" pitchFamily="34" charset="0"/>
+                <a:ea typeface="Calibri" pitchFamily="34" charset="-122"/>
+                <a:cs typeface="Calibri" pitchFamily="34" charset="-120"/>
+              </a:rPr>
+              <a:t>(908s → 391s / 46 câu)</a:t>
+            </a:r>
+            <a:endParaRPr lang="en-US" sz="1200" dirty="0"/>
+          </a:p>
+        </p:txBody>
+      </p:sp>
+      <p:sp>
+        <p:nvSpPr>
+          <p:cNvPr id="10" name="Shape 8"/>
+          <p:cNvSpPr/>
+          <p:nvPr/>
+        </p:nvSpPr>
+        <p:spPr>
+          <a:xfrm>
+            <a:off x="548640" y="3566160"/>
+            <a:ext cx="10881360" cy="1234440"/>
+          </a:xfrm>
+          <a:prstGeom prst="roundRect">
+            <a:avLst>
+              <a:gd name="adj" fmla="val 5926"/>
+            </a:avLst>
+          </a:prstGeom>
+          <a:solidFill>
+            <a:srgbClr val="FFFFFF"/>
+          </a:solidFill>
+          <a:ln/>
+          <a:effectLst>
+            <a:outerShdw sx="100000" sy="100000" kx="0" ky="0" algn="bl" rotWithShape="0" blurRad="76200" dist="25400" dir="5400000">
+              <a:srgbClr val="000000">
+                <a:alpha val="12000"/>
+              </a:srgbClr>
+            </a:outerShdw>
+          </a:effectLst>
+        </p:spPr>
+      </p:sp>
+      <p:sp>
+        <p:nvSpPr>
+          <p:cNvPr id="11" name="Shape 9"/>
+          <p:cNvSpPr/>
+          <p:nvPr/>
+        </p:nvSpPr>
+        <p:spPr>
+          <a:xfrm>
+            <a:off x="822960" y="3822192"/>
+            <a:ext cx="685800" cy="685800"/>
+          </a:xfrm>
+          <a:prstGeom prst="ellipse">
+            <a:avLst/>
+          </a:prstGeom>
+          <a:solidFill>
+            <a:srgbClr val="B8863B"/>
+          </a:solidFill>
+          <a:ln/>
+        </p:spPr>
+      </p:sp>
+      <p:sp>
+        <p:nvSpPr>
+          <p:cNvPr id="12" name="Text 10"/>
+          <p:cNvSpPr/>
+          <p:nvPr/>
+        </p:nvSpPr>
+        <p:spPr>
+          <a:xfrm>
+            <a:off x="822960" y="3822192"/>
+            <a:ext cx="685800" cy="685800"/>
+          </a:xfrm>
+          <a:prstGeom prst="rect">
+            <a:avLst/>
+          </a:prstGeom>
+          <a:noFill/>
+          <a:ln/>
+        </p:spPr>
+        <p:txBody>
+          <a:bodyPr wrap="square" rtlCol="0" anchor="ctr"/>
+          <a:lstStyle/>
+          <a:p>
+            <a:pPr algn="ctr" indent="0" marL="0">
+              <a:buNone/>
+            </a:pPr>
+            <a:r>
+              <a:rPr lang="en-US" sz="2600" b="1" dirty="0">
+                <a:solidFill>
+                  <a:srgbClr val="FFFFFF"/>
+                </a:solidFill>
+                <a:latin typeface="Cambria" pitchFamily="34" charset="0"/>
+                <a:ea typeface="Cambria" pitchFamily="34" charset="-122"/>
+                <a:cs typeface="Cambria" pitchFamily="34" charset="-120"/>
+              </a:rPr>
+              <a:t>2</a:t>
+            </a:r>
+            <a:endParaRPr lang="en-US" sz="2600" dirty="0"/>
+          </a:p>
+        </p:txBody>
+      </p:sp>
+      <p:sp>
+        <p:nvSpPr>
+          <p:cNvPr id="13" name="Text 11"/>
+          <p:cNvSpPr/>
+          <p:nvPr/>
+        </p:nvSpPr>
+        <p:spPr>
+          <a:xfrm>
+            <a:off x="1828800" y="3675888"/>
+            <a:ext cx="6126480" cy="365760"/>
+          </a:xfrm>
+          <a:prstGeom prst="rect">
+            <a:avLst/>
+          </a:prstGeom>
+          <a:noFill/>
+          <a:ln/>
+        </p:spPr>
+        <p:txBody>
+          <a:bodyPr wrap="square" rtlCol="0" anchor="ctr"/>
+          <a:lstStyle/>
+          <a:p>
+            <a:pPr indent="0" marL="0">
+              <a:buNone/>
+            </a:pPr>
+            <a:r>
+              <a:rPr lang="en-US" sz="1450" b="1" dirty="0">
+                <a:solidFill>
+                  <a:srgbClr val="17212B"/>
+                </a:solidFill>
+                <a:latin typeface="Cambria" pitchFamily="34" charset="0"/>
+                <a:ea typeface="Cambria" pitchFamily="34" charset="-122"/>
+                <a:cs typeface="Cambria" pitchFamily="34" charset="-120"/>
+              </a:rPr>
+              <a:t>Đưa dư ứng viên vào rerank</a:t>
+            </a:r>
+            <a:endParaRPr lang="en-US" sz="1450" dirty="0"/>
+          </a:p>
+        </p:txBody>
+      </p:sp>
+      <p:sp>
+        <p:nvSpPr>
+          <p:cNvPr id="14" name="Text 12"/>
+          <p:cNvSpPr/>
+          <p:nvPr/>
+        </p:nvSpPr>
+        <p:spPr>
+          <a:xfrm>
+            <a:off x="1828800" y="4041648"/>
+            <a:ext cx="6126480" cy="685800"/>
+          </a:xfrm>
+          <a:prstGeom prst="rect">
+            <a:avLst/>
+          </a:prstGeom>
+          <a:noFill/>
+          <a:ln/>
+        </p:spPr>
+        <p:txBody>
+          <a:bodyPr wrap="square" rtlCol="0" anchor="ctr"/>
+          <a:lstStyle/>
+          <a:p>
+            <a:pPr indent="0" marL="0">
+              <a:lnSpc>
+                <a:spcPts val="1400"/>
+              </a:lnSpc>
+              <a:buNone/>
+            </a:pPr>
+            <a:r>
+              <a:rPr lang="en-US" sz="1100" dirty="0">
+                <a:solidFill>
+                  <a:srgbClr val="5B6672"/>
+                </a:solidFill>
+                <a:latin typeface="Calibri" pitchFamily="34" charset="0"/>
+                <a:ea typeface="Calibri" pitchFamily="34" charset="-122"/>
+                <a:cs typeface="Calibri" pitchFamily="34" charset="-120"/>
+              </a:rPr>
+              <a:t>Hợp nhất RRF trả về tới 82 ứng viên thay vì 50 đã khai báo trước khi rerank — tăng 64% khối lượng tính.</a:t>
+            </a:r>
+            <a:endParaRPr lang="en-US" sz="1100" dirty="0"/>
+          </a:p>
+        </p:txBody>
+      </p:sp>
+      <p:sp>
+        <p:nvSpPr>
+          <p:cNvPr id="15" name="Text 13"/>
+          <p:cNvSpPr/>
+          <p:nvPr/>
+        </p:nvSpPr>
+        <p:spPr>
+          <a:xfrm>
+            <a:off x="8138160" y="3703320"/>
+            <a:ext cx="3063240" cy="960120"/>
+          </a:xfrm>
+          <a:prstGeom prst="rect">
+            <a:avLst/>
+          </a:prstGeom>
+          <a:noFill/>
+          <a:ln/>
+        </p:spPr>
+        <p:txBody>
+          <a:bodyPr wrap="square" rtlCol="0" anchor="ctr"/>
+          <a:lstStyle/>
+          <a:p>
+            <a:pPr algn="ctr" indent="0" marL="0">
+              <a:lnSpc>
+                <a:spcPts val="1500"/>
+              </a:lnSpc>
+              <a:buNone/>
+            </a:pPr>
+            <a:r>
+              <a:rPr lang="en-US" sz="1200" b="1" dirty="0">
+                <a:solidFill>
+                  <a:srgbClr val="2B6E62"/>
+                </a:solidFill>
+                <a:latin typeface="Calibri" pitchFamily="34" charset="0"/>
+                <a:ea typeface="Calibri" pitchFamily="34" charset="-122"/>
+                <a:cs typeface="Calibri" pitchFamily="34" charset="-120"/>
+              </a:rPr>
+              <a:t>Cắt đúng candidate_k</a:t>
+            </a:r>
+            <a:endParaRPr lang="en-US" sz="1200" dirty="0"/>
+          </a:p>
+          <a:p>
+            <a:pPr algn="ctr" indent="0" marL="0">
+              <a:lnSpc>
+                <a:spcPts val="1500"/>
+              </a:lnSpc>
+              <a:buNone/>
+            </a:pPr>
+            <a:r>
+              <a:rPr lang="en-US" sz="1200" b="1" dirty="0">
+                <a:solidFill>
+                  <a:srgbClr val="2B6E62"/>
+                </a:solidFill>
+                <a:latin typeface="Calibri" pitchFamily="34" charset="0"/>
+                <a:ea typeface="Calibri" pitchFamily="34" charset="-122"/>
+                <a:cs typeface="Calibri" pitchFamily="34" charset="-120"/>
+              </a:rPr>
+              <a:t>trước khi rerank</a:t>
+            </a:r>
+            <a:endParaRPr lang="en-US" sz="1200" dirty="0"/>
+          </a:p>
+        </p:txBody>
+      </p:sp>
+      <p:sp>
+        <p:nvSpPr>
+          <p:cNvPr id="16" name="Shape 14"/>
+          <p:cNvSpPr/>
+          <p:nvPr/>
+        </p:nvSpPr>
+        <p:spPr>
+          <a:xfrm>
+            <a:off x="548640" y="4983480"/>
+            <a:ext cx="10881360" cy="1234440"/>
+          </a:xfrm>
+          <a:prstGeom prst="roundRect">
+            <a:avLst>
+              <a:gd name="adj" fmla="val 5926"/>
+            </a:avLst>
+          </a:prstGeom>
+          <a:solidFill>
+            <a:srgbClr val="FFFFFF"/>
+          </a:solidFill>
+          <a:ln/>
+          <a:effectLst>
+            <a:outerShdw sx="100000" sy="100000" kx="0" ky="0" algn="bl" rotWithShape="0" blurRad="76200" dist="25400" dir="5400000">
+              <a:srgbClr val="000000">
+                <a:alpha val="12000"/>
+              </a:srgbClr>
+            </a:outerShdw>
+          </a:effectLst>
+        </p:spPr>
+      </p:sp>
+      <p:sp>
+        <p:nvSpPr>
+          <p:cNvPr id="17" name="Shape 15"/>
+          <p:cNvSpPr/>
+          <p:nvPr/>
+        </p:nvSpPr>
+        <p:spPr>
+          <a:xfrm>
+            <a:off x="822960" y="5239512"/>
+            <a:ext cx="685800" cy="685800"/>
+          </a:xfrm>
+          <a:prstGeom prst="ellipse">
+            <a:avLst/>
+          </a:prstGeom>
+          <a:solidFill>
+            <a:srgbClr val="B8863B"/>
+          </a:solidFill>
+          <a:ln/>
+        </p:spPr>
+      </p:sp>
+      <p:sp>
+        <p:nvSpPr>
+          <p:cNvPr id="18" name="Text 16"/>
+          <p:cNvSpPr/>
+          <p:nvPr/>
+        </p:nvSpPr>
+        <p:spPr>
+          <a:xfrm>
+            <a:off x="822960" y="5239512"/>
+            <a:ext cx="685800" cy="685800"/>
+          </a:xfrm>
+          <a:prstGeom prst="rect">
+            <a:avLst/>
+          </a:prstGeom>
+          <a:noFill/>
+          <a:ln/>
+        </p:spPr>
+        <p:txBody>
+          <a:bodyPr wrap="square" rtlCol="0" anchor="ctr"/>
+          <a:lstStyle/>
+          <a:p>
+            <a:pPr algn="ctr" indent="0" marL="0">
+              <a:buNone/>
+            </a:pPr>
+            <a:r>
+              <a:rPr lang="en-US" sz="2600" b="1" dirty="0">
+                <a:solidFill>
+                  <a:srgbClr val="FFFFFF"/>
+                </a:solidFill>
+                <a:latin typeface="Cambria" pitchFamily="34" charset="0"/>
+                <a:ea typeface="Cambria" pitchFamily="34" charset="-122"/>
+                <a:cs typeface="Cambria" pitchFamily="34" charset="-120"/>
+              </a:rPr>
+              <a:t>3</a:t>
+            </a:r>
+            <a:endParaRPr lang="en-US" sz="2600" dirty="0"/>
+          </a:p>
+        </p:txBody>
+      </p:sp>
+      <p:sp>
+        <p:nvSpPr>
+          <p:cNvPr id="19" name="Text 17"/>
+          <p:cNvSpPr/>
+          <p:nvPr/>
+        </p:nvSpPr>
+        <p:spPr>
+          <a:xfrm>
+            <a:off x="1828800" y="5093208"/>
+            <a:ext cx="6126480" cy="365760"/>
+          </a:xfrm>
+          <a:prstGeom prst="rect">
+            <a:avLst/>
+          </a:prstGeom>
+          <a:noFill/>
+          <a:ln/>
+        </p:spPr>
+        <p:txBody>
+          <a:bodyPr wrap="square" rtlCol="0" anchor="ctr"/>
+          <a:lstStyle/>
+          <a:p>
+            <a:pPr indent="0" marL="0">
+              <a:buNone/>
+            </a:pPr>
+            <a:r>
+              <a:rPr lang="en-US" sz="1450" b="1" dirty="0">
+                <a:solidFill>
+                  <a:srgbClr val="17212B"/>
+                </a:solidFill>
+                <a:latin typeface="Cambria" pitchFamily="34" charset="0"/>
+                <a:ea typeface="Cambria" pitchFamily="34" charset="-122"/>
+                <a:cs typeface="Cambria" pitchFamily="34" charset="-120"/>
+              </a:rPr>
+              <a:t>65% chunk bị cắt âm thầm khi embed</a:t>
+            </a:r>
+            <a:endParaRPr lang="en-US" sz="1450" dirty="0"/>
+          </a:p>
+        </p:txBody>
+      </p:sp>
+      <p:sp>
+        <p:nvSpPr>
+          <p:cNvPr id="20" name="Text 18"/>
+          <p:cNvSpPr/>
+          <p:nvPr/>
+        </p:nvSpPr>
+        <p:spPr>
+          <a:xfrm>
+            <a:off x="1828800" y="5458968"/>
+            <a:ext cx="6126480" cy="685800"/>
+          </a:xfrm>
+          <a:prstGeom prst="rect">
+            <a:avLst/>
+          </a:prstGeom>
+          <a:noFill/>
+          <a:ln/>
+        </p:spPr>
+        <p:txBody>
+          <a:bodyPr wrap="square" rtlCol="0" anchor="ctr"/>
+          <a:lstStyle/>
+          <a:p>
+            <a:pPr indent="0" marL="0">
+              <a:lnSpc>
+                <a:spcPts val="1400"/>
+              </a:lnSpc>
+              <a:buNone/>
+            </a:pPr>
+            <a:r>
+              <a:rPr lang="en-US" sz="1100" dirty="0">
+                <a:solidFill>
+                  <a:srgbClr val="5B6672"/>
+                </a:solidFill>
+                <a:latin typeface="Calibri" pitchFamily="34" charset="0"/>
+                <a:ea typeface="Calibri" pitchFamily="34" charset="-122"/>
+                <a:cs typeface="Calibri" pitchFamily="34" charset="-120"/>
+              </a:rPr>
+              <a:t>vietnamese-bi-encoder giới hạn KIẾN TRÚC 256 token, nhưng 447/684 chunk dài hơn — SentenceTransformer.encode() cắt phần sau, không báo lỗi.</a:t>
+            </a:r>
+            <a:endParaRPr lang="en-US" sz="1100" dirty="0"/>
+          </a:p>
+        </p:txBody>
+      </p:sp>
+      <p:sp>
+        <p:nvSpPr>
+          <p:cNvPr id="21" name="Text 19"/>
+          <p:cNvSpPr/>
+          <p:nvPr/>
+        </p:nvSpPr>
+        <p:spPr>
+          <a:xfrm>
+            <a:off x="8138160" y="5120640"/>
+            <a:ext cx="3063240" cy="960120"/>
+          </a:xfrm>
+          <a:prstGeom prst="rect">
+            <a:avLst/>
+          </a:prstGeom>
+          <a:noFill/>
+          <a:ln/>
+        </p:spPr>
+        <p:txBody>
+          <a:bodyPr wrap="square" rtlCol="0" anchor="ctr"/>
+          <a:lstStyle/>
+          <a:p>
+            <a:pPr algn="ctr" indent="0" marL="0">
+              <a:lnSpc>
+                <a:spcPts val="1500"/>
+              </a:lnSpc>
+              <a:buNone/>
+            </a:pPr>
+            <a:r>
+              <a:rPr lang="en-US" sz="1200" b="1" dirty="0">
+                <a:solidFill>
+                  <a:srgbClr val="2B6E62"/>
+                </a:solidFill>
+                <a:latin typeface="Calibri" pitchFamily="34" charset="0"/>
+                <a:ea typeface="Calibri" pitchFamily="34" charset="-122"/>
+                <a:cs typeface="Calibri" pitchFamily="34" charset="-120"/>
+              </a:rPr>
+              <a:t>Độ tách biệt embedding</a:t>
+            </a:r>
+            <a:endParaRPr lang="en-US" sz="1200" dirty="0"/>
+          </a:p>
+          <a:p>
+            <a:pPr algn="ctr" indent="0" marL="0">
+              <a:lnSpc>
+                <a:spcPts val="1500"/>
+              </a:lnSpc>
+              <a:buNone/>
+            </a:pPr>
+            <a:r>
+              <a:rPr lang="en-US" sz="1200" b="1" dirty="0">
+                <a:solidFill>
+                  <a:srgbClr val="2B6E62"/>
+                </a:solidFill>
+                <a:latin typeface="Calibri" pitchFamily="34" charset="0"/>
+                <a:ea typeface="Calibri" pitchFamily="34" charset="-122"/>
+                <a:cs typeface="Calibri" pitchFamily="34" charset="-120"/>
+              </a:rPr>
+              <a:t>+13% đến +15%</a:t>
+            </a:r>
+            <a:endParaRPr lang="en-US" sz="1200" dirty="0"/>
+          </a:p>
+        </p:txBody>
+      </p:sp>
+      <p:sp>
+        <p:nvSpPr>
+          <p:cNvPr id="22" name="Text 20"/>
+          <p:cNvSpPr/>
+          <p:nvPr/>
+        </p:nvSpPr>
+        <p:spPr>
+          <a:xfrm>
+            <a:off x="548640" y="6446520"/>
+            <a:ext cx="10881360" cy="320040"/>
+          </a:xfrm>
+          <a:prstGeom prst="rect">
+            <a:avLst/>
+          </a:prstGeom>
+          <a:noFill/>
+          <a:ln/>
+        </p:spPr>
+        <p:txBody>
+          <a:bodyPr wrap="square" rtlCol="0" anchor="ctr"/>
+          <a:lstStyle/>
+          <a:p>
+            <a:pPr algn="ctr" indent="0" marL="0">
+              <a:buNone/>
+            </a:pPr>
+            <a:r>
+              <a:rPr lang="en-US" sz="1100" i="1" dirty="0">
+                <a:solidFill>
+                  <a:srgbClr val="5B6672"/>
+                </a:solidFill>
+                <a:latin typeface="Calibri" pitchFamily="34" charset="0"/>
+                <a:ea typeface="Calibri" pitchFamily="34" charset="-122"/>
+                <a:cs typeface="Calibri" pitchFamily="34" charset="-120"/>
+              </a:rPr>
+              <a:t>Đo lại bằng eval thật sau mỗi fix — không suy đoán tác động. Chi tiết: docs/DATA_CARD.md Mục 12.1.</a:t>
+            </a:r>
+            <a:endParaRPr lang="en-US" sz="1100" dirty="0"/>
+          </a:p>
+        </p:txBody>
+      </p:sp>
+      <p:sp>
+        <p:nvSpPr>
+          <p:cNvPr id="23" name="Text 21"/>
+          <p:cNvSpPr/>
+          <p:nvPr/>
+        </p:nvSpPr>
+        <p:spPr>
+          <a:xfrm>
+            <a:off x="11548872" y="6400800"/>
+            <a:ext cx="365760" cy="274320"/>
+          </a:xfrm>
+          <a:prstGeom prst="rect">
+            <a:avLst/>
+          </a:prstGeom>
+          <a:noFill/>
+          <a:ln/>
+        </p:spPr>
+        <p:txBody>
+          <a:bodyPr wrap="square" rtlCol="0" anchor="ctr"/>
+          <a:lstStyle/>
+          <a:p>
+            <a:pPr algn="r" indent="0" marL="0">
+              <a:buNone/>
+            </a:pPr>
+            <a:r>
+              <a:rPr lang="en-US" sz="1000" dirty="0">
+                <a:solidFill>
+                  <a:srgbClr val="5B6672"/>
+                </a:solidFill>
+                <a:latin typeface="Calibri" pitchFamily="34" charset="0"/>
+                <a:ea typeface="Calibri" pitchFamily="34" charset="-122"/>
+                <a:cs typeface="Calibri" pitchFamily="34" charset="-120"/>
+              </a:rPr>
+              <a:t>12</a:t>
+            </a:r>
+            <a:endParaRPr lang="en-US" sz="1000" dirty="0"/>
+          </a:p>
+        </p:txBody>
+      </p:sp>
+    </p:spTree>
+  </p:cSld>
+  <p:clrMapOvr>
+    <a:masterClrMapping/>
+  </p:clrMapOvr>
+</p:sld>
+</file>
+
+<file path=ppt/slides/slide13.xml><?xml version="1.0" encoding="utf-8"?>
+<p:sld xmlns:a="http://schemas.openxmlformats.org/drawingml/2006/main" xmlns:r="http://schemas.openxmlformats.org/officeDocument/2006/relationships" xmlns:p="http://schemas.openxmlformats.org/presentationml/2006/main">
+  <p:cSld name="Slide 13">
     <p:bg>
       <p:bgPr>
         <a:solidFill>
@@ -4372,7 +5342,7 @@
                 <a:ea typeface="Calibri" pitchFamily="34" charset="-122"/>
                 <a:cs typeface="Calibri" pitchFamily="34" charset="-120"/>
               </a:rPr>
-              <a:t>12</a:t>
+              <a:t>13</a:t>
             </a:r>
             <a:endParaRPr lang="en-US" sz="1000" dirty="0"/>
           </a:p>
@@ -4386,9 +5356,9 @@
 </p:sld>
 </file>
 
-<file path=ppt/slides/slide13.xml><?xml version="1.0" encoding="utf-8"?>
+<file path=ppt/slides/slide14.xml><?xml version="1.0" encoding="utf-8"?>
 <p:sld xmlns:a="http://schemas.openxmlformats.org/drawingml/2006/main" xmlns:r="http://schemas.openxmlformats.org/officeDocument/2006/relationships" xmlns:p="http://schemas.openxmlformats.org/presentationml/2006/main">
-  <p:cSld name="Slide 13">
+  <p:cSld name="Slide 14">
     <p:bg>
       <p:bgPr>
         <a:solidFill>
@@ -4496,12 +5466,12 @@
         </p:nvSpPr>
         <p:spPr>
           <a:xfrm>
-            <a:off x="640080" y="2194560"/>
-            <a:ext cx="10881360" cy="749808"/>
+            <a:off x="640080" y="1965960"/>
+            <a:ext cx="10881360" cy="658368"/>
           </a:xfrm>
           <a:prstGeom prst="roundRect">
             <a:avLst>
-              <a:gd name="adj" fmla="val 7317"/>
+              <a:gd name="adj" fmla="val 8333"/>
             </a:avLst>
           </a:prstGeom>
           <a:solidFill>
@@ -4518,7 +5488,7 @@
         </p:nvSpPr>
         <p:spPr>
           <a:xfrm>
-            <a:off x="868680" y="2340864"/>
+            <a:off x="868680" y="2066544"/>
             <a:ext cx="457200" cy="457200"/>
           </a:xfrm>
           <a:prstGeom prst="ellipse">
@@ -4538,7 +5508,7 @@
         </p:nvSpPr>
         <p:spPr>
           <a:xfrm>
-            <a:off x="868680" y="2340864"/>
+            <a:off x="868680" y="2066544"/>
             <a:ext cx="457200" cy="457200"/>
           </a:xfrm>
           <a:prstGeom prst="rect">
@@ -4577,8 +5547,8 @@
         </p:nvSpPr>
         <p:spPr>
           <a:xfrm>
-            <a:off x="1508760" y="2194560"/>
-            <a:ext cx="9829800" cy="749808"/>
+            <a:off x="1508760" y="1965960"/>
+            <a:ext cx="9829800" cy="658368"/>
           </a:xfrm>
           <a:prstGeom prst="rect">
             <a:avLst/>
@@ -4592,12 +5562,12 @@
           <a:p>
             <a:pPr indent="0" marL="0">
               <a:lnSpc>
-                <a:spcPts val="1600"/>
+                <a:spcPts val="1400"/>
               </a:lnSpc>
               <a:buNone/>
             </a:pPr>
             <a:r>
-              <a:rPr lang="en-US" sz="1300" dirty="0">
+              <a:rPr lang="en-US" sz="1200" dirty="0">
                 <a:solidFill>
                   <a:srgbClr val="17212B"/>
                 </a:solidFill>
@@ -4607,7 +5577,7 @@
               </a:rPr>
               <a:t>Giám khảo LLM-as-judge cùng họ mô hình với mô hình sinh — có thể thiên lệch tự ưu ái.</a:t>
             </a:r>
-            <a:endParaRPr lang="en-US" sz="1300" dirty="0"/>
+            <a:endParaRPr lang="en-US" sz="1200" dirty="0"/>
           </a:p>
         </p:txBody>
       </p:sp>
@@ -4619,12 +5589,12 @@
         </p:nvSpPr>
         <p:spPr>
           <a:xfrm>
-            <a:off x="640080" y="3044952"/>
-            <a:ext cx="10881360" cy="749808"/>
+            <a:off x="640080" y="2734056"/>
+            <a:ext cx="10881360" cy="658368"/>
           </a:xfrm>
           <a:prstGeom prst="roundRect">
             <a:avLst>
-              <a:gd name="adj" fmla="val 7317"/>
+              <a:gd name="adj" fmla="val 8333"/>
             </a:avLst>
           </a:prstGeom>
           <a:solidFill>
@@ -4641,7 +5611,7 @@
         </p:nvSpPr>
         <p:spPr>
           <a:xfrm>
-            <a:off x="868680" y="3191256"/>
+            <a:off x="868680" y="2834640"/>
             <a:ext cx="457200" cy="457200"/>
           </a:xfrm>
           <a:prstGeom prst="ellipse">
@@ -4661,7 +5631,7 @@
         </p:nvSpPr>
         <p:spPr>
           <a:xfrm>
-            <a:off x="868680" y="3191256"/>
+            <a:off x="868680" y="2834640"/>
             <a:ext cx="457200" cy="457200"/>
           </a:xfrm>
           <a:prstGeom prst="rect">
@@ -4700,8 +5670,8 @@
         </p:nvSpPr>
         <p:spPr>
           <a:xfrm>
-            <a:off x="1508760" y="3044952"/>
-            <a:ext cx="9829800" cy="749808"/>
+            <a:off x="1508760" y="2734056"/>
+            <a:ext cx="9829800" cy="658368"/>
           </a:xfrm>
           <a:prstGeom prst="rect">
             <a:avLst/>
@@ -4715,12 +5685,12 @@
           <a:p>
             <a:pPr indent="0" marL="0">
               <a:lnSpc>
-                <a:spcPts val="1600"/>
+                <a:spcPts val="1400"/>
               </a:lnSpc>
               <a:buNone/>
             </a:pPr>
             <a:r>
-              <a:rPr lang="en-US" sz="1300" dirty="0">
+              <a:rPr lang="en-US" sz="1200" dirty="0">
                 <a:solidFill>
                   <a:srgbClr val="17212B"/>
                 </a:solidFill>
@@ -4730,7 +5700,7 @@
               </a:rPr>
               <a:t>Cỡ mẫu đánh giá sinh văn bản (n=8) còn nhỏ, cần mở rộng để có ý nghĩa thống kê chặt hơn.</a:t>
             </a:r>
-            <a:endParaRPr lang="en-US" sz="1300" dirty="0"/>
+            <a:endParaRPr lang="en-US" sz="1200" dirty="0"/>
           </a:p>
         </p:txBody>
       </p:sp>
@@ -4742,12 +5712,12 @@
         </p:nvSpPr>
         <p:spPr>
           <a:xfrm>
-            <a:off x="640080" y="3895344"/>
-            <a:ext cx="10881360" cy="749808"/>
+            <a:off x="640080" y="3502152"/>
+            <a:ext cx="10881360" cy="658368"/>
           </a:xfrm>
           <a:prstGeom prst="roundRect">
             <a:avLst>
-              <a:gd name="adj" fmla="val 7317"/>
+              <a:gd name="adj" fmla="val 8333"/>
             </a:avLst>
           </a:prstGeom>
           <a:solidFill>
@@ -4764,7 +5734,7 @@
         </p:nvSpPr>
         <p:spPr>
           <a:xfrm>
-            <a:off x="868680" y="4041648"/>
+            <a:off x="868680" y="3602736"/>
             <a:ext cx="457200" cy="457200"/>
           </a:xfrm>
           <a:prstGeom prst="ellipse">
@@ -4784,7 +5754,7 @@
         </p:nvSpPr>
         <p:spPr>
           <a:xfrm>
-            <a:off x="868680" y="4041648"/>
+            <a:off x="868680" y="3602736"/>
             <a:ext cx="457200" cy="457200"/>
           </a:xfrm>
           <a:prstGeom prst="rect">
@@ -4823,8 +5793,8 @@
         </p:nvSpPr>
         <p:spPr>
           <a:xfrm>
-            <a:off x="1508760" y="3895344"/>
-            <a:ext cx="9829800" cy="749808"/>
+            <a:off x="1508760" y="3502152"/>
+            <a:ext cx="9829800" cy="658368"/>
           </a:xfrm>
           <a:prstGeom prst="rect">
             <a:avLst/>
@@ -4838,12 +5808,12 @@
           <a:p>
             <a:pPr indent="0" marL="0">
               <a:lnSpc>
-                <a:spcPts val="1600"/>
+                <a:spcPts val="1400"/>
               </a:lnSpc>
               <a:buNone/>
             </a:pPr>
             <a:r>
-              <a:rPr lang="en-US" sz="1300" dirty="0">
+              <a:rPr lang="en-US" sz="1200" dirty="0">
                 <a:solidFill>
                   <a:srgbClr val="17212B"/>
                 </a:solidFill>
@@ -4851,9 +5821,9 @@
                 <a:ea typeface="Calibri" pitchFamily="34" charset="-122"/>
                 <a:cs typeface="Calibri" pitchFamily="34" charset="-120"/>
               </a:rPr>
-              <a:t>Chưa có HSMT thật đã phê duyệt trong kho tri thức — hệ thống mạng đấu thầu quốc gia yêu cầu đăng nhập + Client Agent chỉ chạy Windows.</a:t>
-            </a:r>
-            <a:endParaRPr lang="en-US" sz="1300" dirty="0"/>
+              <a:t>Sau khi sửa lỗi cắt âm thầm chunk, Recall@5 SAU rerank giảm nhẹ (0.804→0.761) trên tập 46 câu — 46 câu chưa đủ để phân biệt xu hướng thật với nhiễu thống kê, cần tập lớn hơn để đánh giá lại.</a:t>
+            </a:r>
+            <a:endParaRPr lang="en-US" sz="1200" dirty="0"/>
           </a:p>
         </p:txBody>
       </p:sp>
@@ -4865,12 +5835,12 @@
         </p:nvSpPr>
         <p:spPr>
           <a:xfrm>
-            <a:off x="640080" y="4745736"/>
-            <a:ext cx="10881360" cy="749808"/>
+            <a:off x="640080" y="4270248"/>
+            <a:ext cx="10881360" cy="658368"/>
           </a:xfrm>
           <a:prstGeom prst="roundRect">
             <a:avLst>
-              <a:gd name="adj" fmla="val 7317"/>
+              <a:gd name="adj" fmla="val 8333"/>
             </a:avLst>
           </a:prstGeom>
           <a:solidFill>
@@ -4887,7 +5857,7 @@
         </p:nvSpPr>
         <p:spPr>
           <a:xfrm>
-            <a:off x="868680" y="4892040"/>
+            <a:off x="868680" y="4370832"/>
             <a:ext cx="457200" cy="457200"/>
           </a:xfrm>
           <a:prstGeom prst="ellipse">
@@ -4907,7 +5877,7 @@
         </p:nvSpPr>
         <p:spPr>
           <a:xfrm>
-            <a:off x="868680" y="4892040"/>
+            <a:off x="868680" y="4370832"/>
             <a:ext cx="457200" cy="457200"/>
           </a:xfrm>
           <a:prstGeom prst="rect">
@@ -4946,8 +5916,8 @@
         </p:nvSpPr>
         <p:spPr>
           <a:xfrm>
-            <a:off x="1508760" y="4745736"/>
-            <a:ext cx="9829800" cy="749808"/>
+            <a:off x="1508760" y="4270248"/>
+            <a:ext cx="9829800" cy="658368"/>
           </a:xfrm>
           <a:prstGeom prst="rect">
             <a:avLst/>
@@ -4961,12 +5931,12 @@
           <a:p>
             <a:pPr indent="0" marL="0">
               <a:lnSpc>
-                <a:spcPts val="1600"/>
+                <a:spcPts val="1400"/>
               </a:lnSpc>
               <a:buNone/>
             </a:pPr>
             <a:r>
-              <a:rPr lang="en-US" sz="1300" dirty="0">
+              <a:rPr lang="en-US" sz="1200" dirty="0">
                 <a:solidFill>
                   <a:srgbClr val="17212B"/>
                 </a:solidFill>
@@ -4974,9 +5944,9 @@
                 <a:ea typeface="Calibri" pitchFamily="34" charset="-122"/>
                 <a:cs typeface="Calibri" pitchFamily="34" charset="-120"/>
               </a:rPr>
-              <a:t>Mức 3 mới ghép được nội dung AI soạn, chưa lắp khung cố định (chỉ dẫn nhà thầu, bảng dữ liệu đấu thầu).</a:t>
-            </a:r>
-            <a:endParaRPr lang="en-US" sz="1300" dirty="0"/>
+              <a:t>Chưa có HSMT thật đã phê duyệt trong kho tri thức — hệ thống mạng đấu thầu quốc gia yêu cầu đăng nhập + Client Agent chỉ chạy Windows.</a:t>
+            </a:r>
+            <a:endParaRPr lang="en-US" sz="1200" dirty="0"/>
           </a:p>
         </p:txBody>
       </p:sp>
@@ -4988,12 +5958,12 @@
         </p:nvSpPr>
         <p:spPr>
           <a:xfrm>
-            <a:off x="640080" y="5596128"/>
-            <a:ext cx="10881360" cy="749808"/>
+            <a:off x="640080" y="5038344"/>
+            <a:ext cx="10881360" cy="658368"/>
           </a:xfrm>
           <a:prstGeom prst="roundRect">
             <a:avLst>
-              <a:gd name="adj" fmla="val 7317"/>
+              <a:gd name="adj" fmla="val 8333"/>
             </a:avLst>
           </a:prstGeom>
           <a:solidFill>
@@ -5010,7 +5980,7 @@
         </p:nvSpPr>
         <p:spPr>
           <a:xfrm>
-            <a:off x="868680" y="5742432"/>
+            <a:off x="868680" y="5138928"/>
             <a:ext cx="457200" cy="457200"/>
           </a:xfrm>
           <a:prstGeom prst="ellipse">
@@ -5030,7 +6000,7 @@
         </p:nvSpPr>
         <p:spPr>
           <a:xfrm>
-            <a:off x="868680" y="5742432"/>
+            <a:off x="868680" y="5138928"/>
             <a:ext cx="457200" cy="457200"/>
           </a:xfrm>
           <a:prstGeom prst="rect">
@@ -5069,8 +6039,8 @@
         </p:nvSpPr>
         <p:spPr>
           <a:xfrm>
-            <a:off x="1508760" y="5596128"/>
-            <a:ext cx="9829800" cy="749808"/>
+            <a:off x="1508760" y="5038344"/>
+            <a:ext cx="9829800" cy="658368"/>
           </a:xfrm>
           <a:prstGeom prst="rect">
             <a:avLst/>
@@ -5084,12 +6054,12 @@
           <a:p>
             <a:pPr indent="0" marL="0">
               <a:lnSpc>
-                <a:spcPts val="1600"/>
+                <a:spcPts val="1400"/>
               </a:lnSpc>
               <a:buNone/>
             </a:pPr>
             <a:r>
-              <a:rPr lang="en-US" sz="1300" dirty="0">
+              <a:rPr lang="en-US" sz="1200" dirty="0">
                 <a:solidFill>
                   <a:srgbClr val="17212B"/>
                 </a:solidFill>
@@ -5097,117 +6067,130 @@
                 <a:ea typeface="Calibri" pitchFamily="34" charset="-122"/>
                 <a:cs typeface="Calibri" pitchFamily="34" charset="-120"/>
               </a:rPr>
-              <a:t>Rerank cross-encoder cải thiện chất lượng rõ rệt nhưng độ trễ cao (~20s/câu) — cần cân nhắc cho luồng tương tác thời gian thực.</a:t>
-            </a:r>
-            <a:endParaRPr lang="en-US" sz="1300" dirty="0"/>
-          </a:p>
-        </p:txBody>
-      </p:sp>
-      <p:sp>
-        <p:nvSpPr>
-          <p:cNvPr id="24" name="Text 22"/>
-          <p:cNvSpPr/>
-          <p:nvPr/>
-        </p:nvSpPr>
-        <p:spPr>
-          <a:xfrm>
-            <a:off x="11548872" y="6400800"/>
-            <a:ext cx="365760" cy="274320"/>
-          </a:xfrm>
-          <a:prstGeom prst="rect">
-            <a:avLst/>
-          </a:prstGeom>
-          <a:noFill/>
-          <a:ln/>
-        </p:spPr>
-        <p:txBody>
-          <a:bodyPr wrap="square" rtlCol="0" anchor="ctr"/>
-          <a:lstStyle/>
-          <a:p>
-            <a:pPr algn="r" indent="0" marL="0">
-              <a:buNone/>
-            </a:pPr>
-            <a:r>
-              <a:rPr lang="en-US" sz="1000" dirty="0">
-                <a:solidFill>
-                  <a:srgbClr val="5B6672"/>
+              <a:t>Mức 3 mới ghép được nội dung AI soạn, chưa lắp khung cố định (chỉ dẫn nhà thầu, bảng dữ liệu đấu thầu).</a:t>
+            </a:r>
+            <a:endParaRPr lang="en-US" sz="1200" dirty="0"/>
+          </a:p>
+        </p:txBody>
+      </p:sp>
+      <p:sp>
+        <p:nvSpPr>
+          <p:cNvPr id="24" name="Shape 22"/>
+          <p:cNvSpPr/>
+          <p:nvPr/>
+        </p:nvSpPr>
+        <p:spPr>
+          <a:xfrm>
+            <a:off x="640080" y="5806440"/>
+            <a:ext cx="10881360" cy="658368"/>
+          </a:xfrm>
+          <a:prstGeom prst="roundRect">
+            <a:avLst>
+              <a:gd name="adj" fmla="val 8333"/>
+            </a:avLst>
+          </a:prstGeom>
+          <a:solidFill>
+            <a:srgbClr val="FFFFFF"/>
+          </a:solidFill>
+          <a:ln/>
+        </p:spPr>
+      </p:sp>
+      <p:sp>
+        <p:nvSpPr>
+          <p:cNvPr id="25" name="Shape 23"/>
+          <p:cNvSpPr/>
+          <p:nvPr/>
+        </p:nvSpPr>
+        <p:spPr>
+          <a:xfrm>
+            <a:off x="868680" y="5907024"/>
+            <a:ext cx="457200" cy="457200"/>
+          </a:xfrm>
+          <a:prstGeom prst="ellipse">
+            <a:avLst/>
+          </a:prstGeom>
+          <a:solidFill>
+            <a:srgbClr val="2B6E62"/>
+          </a:solidFill>
+          <a:ln/>
+        </p:spPr>
+      </p:sp>
+      <p:sp>
+        <p:nvSpPr>
+          <p:cNvPr id="26" name="Text 24"/>
+          <p:cNvSpPr/>
+          <p:nvPr/>
+        </p:nvSpPr>
+        <p:spPr>
+          <a:xfrm>
+            <a:off x="868680" y="5907024"/>
+            <a:ext cx="457200" cy="457200"/>
+          </a:xfrm>
+          <a:prstGeom prst="rect">
+            <a:avLst/>
+          </a:prstGeom>
+          <a:noFill/>
+          <a:ln/>
+        </p:spPr>
+        <p:txBody>
+          <a:bodyPr wrap="square" rtlCol="0" anchor="ctr"/>
+          <a:lstStyle/>
+          <a:p>
+            <a:pPr algn="ctr" indent="0" marL="0">
+              <a:buNone/>
+            </a:pPr>
+            <a:r>
+              <a:rPr lang="en-US" sz="1600" b="1" dirty="0">
+                <a:solidFill>
+                  <a:srgbClr val="FFFFFF"/>
+                </a:solidFill>
+                <a:latin typeface="Cambria" pitchFamily="34" charset="0"/>
+                <a:ea typeface="Cambria" pitchFamily="34" charset="-122"/>
+                <a:cs typeface="Cambria" pitchFamily="34" charset="-120"/>
+              </a:rPr>
+              <a:t>!</a:t>
+            </a:r>
+            <a:endParaRPr lang="en-US" sz="1600" dirty="0"/>
+          </a:p>
+        </p:txBody>
+      </p:sp>
+      <p:sp>
+        <p:nvSpPr>
+          <p:cNvPr id="27" name="Text 25"/>
+          <p:cNvSpPr/>
+          <p:nvPr/>
+        </p:nvSpPr>
+        <p:spPr>
+          <a:xfrm>
+            <a:off x="1508760" y="5806440"/>
+            <a:ext cx="9829800" cy="658368"/>
+          </a:xfrm>
+          <a:prstGeom prst="rect">
+            <a:avLst/>
+          </a:prstGeom>
+          <a:noFill/>
+          <a:ln/>
+        </p:spPr>
+        <p:txBody>
+          <a:bodyPr wrap="square" rtlCol="0" anchor="ctr"/>
+          <a:lstStyle/>
+          <a:p>
+            <a:pPr indent="0" marL="0">
+              <a:lnSpc>
+                <a:spcPts val="1400"/>
+              </a:lnSpc>
+              <a:buNone/>
+            </a:pPr>
+            <a:r>
+              <a:rPr lang="en-US" sz="1200" dirty="0">
+                <a:solidFill>
+                  <a:srgbClr val="17212B"/>
                 </a:solidFill>
                 <a:latin typeface="Calibri" pitchFamily="34" charset="0"/>
                 <a:ea typeface="Calibri" pitchFamily="34" charset="-122"/>
                 <a:cs typeface="Calibri" pitchFamily="34" charset="-120"/>
               </a:rPr>
-              <a:t>13</a:t>
-            </a:r>
-            <a:endParaRPr lang="en-US" sz="1000" dirty="0"/>
-          </a:p>
-        </p:txBody>
-      </p:sp>
-    </p:spTree>
-  </p:cSld>
-  <p:clrMapOvr>
-    <a:masterClrMapping/>
-  </p:clrMapOvr>
-</p:sld>
-</file>
-
-<file path=ppt/slides/slide14.xml><?xml version="1.0" encoding="utf-8"?>
-<p:sld xmlns:a="http://schemas.openxmlformats.org/drawingml/2006/main" xmlns:r="http://schemas.openxmlformats.org/officeDocument/2006/relationships" xmlns:p="http://schemas.openxmlformats.org/presentationml/2006/main">
-  <p:cSld name="Slide 14">
-    <p:bg>
-      <p:bgPr>
-        <a:solidFill>
-          <a:srgbClr val="17212B"/>
-        </a:solidFill>
-      </p:bgPr>
-    </p:bg>
-    <p:spTree>
-      <p:nvGrpSpPr>
-        <p:cNvPr id="1" name=""/>
-        <p:cNvGrpSpPr/>
-        <p:nvPr/>
-      </p:nvGrpSpPr>
-      <p:grpSpPr>
-        <a:xfrm>
-          <a:off x="0" y="0"/>
-          <a:ext cx="0" cy="0"/>
-          <a:chOff x="0" y="0"/>
-          <a:chExt cx="0" cy="0"/>
-        </a:xfrm>
-      </p:grpSpPr>
-      <p:sp>
-        <p:nvSpPr>
-          <p:cNvPr id="2" name="Text 0"/>
-          <p:cNvSpPr/>
-          <p:nvPr/>
-        </p:nvSpPr>
-        <p:spPr>
-          <a:xfrm>
-            <a:off x="548640" y="365760"/>
-            <a:ext cx="7315200" cy="365760"/>
-          </a:xfrm>
-          <a:prstGeom prst="rect">
-            <a:avLst/>
-          </a:prstGeom>
-          <a:noFill/>
-          <a:ln/>
-        </p:spPr>
-        <p:txBody>
-          <a:bodyPr wrap="square" rtlCol="0" anchor="ctr"/>
-          <a:lstStyle/>
-          <a:p>
-            <a:pPr indent="0" marL="0">
-              <a:buNone/>
-            </a:pPr>
-            <a:r>
-              <a:rPr lang="en-US" sz="1200" b="1" spc="200" kern="0" dirty="0">
-                <a:solidFill>
-                  <a:srgbClr val="B8863B"/>
-                </a:solidFill>
-                <a:latin typeface="Calibri" pitchFamily="34" charset="0"/>
-                <a:ea typeface="Calibri" pitchFamily="34" charset="-122"/>
-                <a:cs typeface="Calibri" pitchFamily="34" charset="-120"/>
-              </a:rPr>
-              <a:t>KẾT LUẬN</a:t>
+              <a:t>Rerank cross-encoder vẫn còn độ trễ đáng kể (~7.6s/câu, đã giảm từ ~20s/câu) — cần cân nhắc cho luồng tương tác thời gian thực.</a:t>
             </a:r>
             <a:endParaRPr lang="en-US" sz="1200" dirty="0"/>
           </a:p>
@@ -5215,294 +6198,7 @@
       </p:sp>
       <p:sp>
         <p:nvSpPr>
-          <p:cNvPr id="3" name="Text 1"/>
-          <p:cNvSpPr/>
-          <p:nvPr/>
-        </p:nvSpPr>
-        <p:spPr>
-          <a:xfrm>
-            <a:off x="548640" y="685800"/>
-            <a:ext cx="11064240" cy="822960"/>
-          </a:xfrm>
-          <a:prstGeom prst="rect">
-            <a:avLst/>
-          </a:prstGeom>
-          <a:noFill/>
-          <a:ln/>
-        </p:spPr>
-        <p:txBody>
-          <a:bodyPr wrap="square" rtlCol="0" anchor="ctr"/>
-          <a:lstStyle/>
-          <a:p>
-            <a:pPr algn="l" indent="0" marL="0">
-              <a:buNone/>
-            </a:pPr>
-            <a:r>
-              <a:rPr lang="en-US" sz="2800" b="1" dirty="0">
-                <a:solidFill>
-                  <a:srgbClr val="FFFFFF"/>
-                </a:solidFill>
-                <a:latin typeface="Cambria" pitchFamily="34" charset="0"/>
-                <a:ea typeface="Cambria" pitchFamily="34" charset="-122"/>
-                <a:cs typeface="Cambria" pitchFamily="34" charset="-120"/>
-              </a:rPr>
-              <a:t>Đóng góp Deep Learning nằm ở thiết kế, ghép nối và đánh giá — đúng đề cương</a:t>
-            </a:r>
-            <a:endParaRPr lang="en-US" sz="2800" dirty="0"/>
-          </a:p>
-        </p:txBody>
-      </p:sp>
-      <p:sp>
-        <p:nvSpPr>
-          <p:cNvPr id="4" name="Shape 2"/>
-          <p:cNvSpPr/>
-          <p:nvPr/>
-        </p:nvSpPr>
-        <p:spPr>
-          <a:xfrm>
-            <a:off x="822960" y="2578608"/>
-            <a:ext cx="128016" cy="128016"/>
-          </a:xfrm>
-          <a:prstGeom prst="ellipse">
-            <a:avLst/>
-          </a:prstGeom>
-          <a:solidFill>
-            <a:srgbClr val="B8863B"/>
-          </a:solidFill>
-          <a:ln/>
-        </p:spPr>
-      </p:sp>
-      <p:sp>
-        <p:nvSpPr>
-          <p:cNvPr id="5" name="Text 3"/>
-          <p:cNvSpPr/>
-          <p:nvPr/>
-        </p:nvSpPr>
-        <p:spPr>
-          <a:xfrm>
-            <a:off x="1143000" y="2468880"/>
-            <a:ext cx="10149840" cy="777240"/>
-          </a:xfrm>
-          <a:prstGeom prst="rect">
-            <a:avLst/>
-          </a:prstGeom>
-          <a:noFill/>
-          <a:ln/>
-        </p:spPr>
-        <p:txBody>
-          <a:bodyPr wrap="square" rtlCol="0" anchor="ctr"/>
-          <a:lstStyle/>
-          <a:p>
-            <a:pPr indent="0" marL="0">
-              <a:lnSpc>
-                <a:spcPts val="2000"/>
-              </a:lnSpc>
-              <a:buNone/>
-            </a:pPr>
-            <a:r>
-              <a:rPr lang="en-US" sz="1500" dirty="0">
-                <a:solidFill>
-                  <a:srgbClr val="E8E5DC"/>
-                </a:solidFill>
-                <a:latin typeface="Calibri" pitchFamily="34" charset="0"/>
-                <a:ea typeface="Calibri" pitchFamily="34" charset="-122"/>
-                <a:cs typeface="Calibri" pitchFamily="34" charset="-120"/>
-              </a:rPr>
-              <a:t>Kho tri thức pháp luật thật 326 Điều — bao gồm 1 văn bản chuyên ngành CNTT khôi phục từ nguồn thay thế khi bản chính thức chỉ có scan ảnh.</a:t>
-            </a:r>
-            <a:endParaRPr lang="en-US" sz="1500" dirty="0"/>
-          </a:p>
-        </p:txBody>
-      </p:sp>
-      <p:sp>
-        <p:nvSpPr>
-          <p:cNvPr id="6" name="Shape 4"/>
-          <p:cNvSpPr/>
-          <p:nvPr/>
-        </p:nvSpPr>
-        <p:spPr>
-          <a:xfrm>
-            <a:off x="822960" y="3447288"/>
-            <a:ext cx="128016" cy="128016"/>
-          </a:xfrm>
-          <a:prstGeom prst="ellipse">
-            <a:avLst/>
-          </a:prstGeom>
-          <a:solidFill>
-            <a:srgbClr val="B8863B"/>
-          </a:solidFill>
-          <a:ln/>
-        </p:spPr>
-      </p:sp>
-      <p:sp>
-        <p:nvSpPr>
-          <p:cNvPr id="7" name="Text 5"/>
-          <p:cNvSpPr/>
-          <p:nvPr/>
-        </p:nvSpPr>
-        <p:spPr>
-          <a:xfrm>
-            <a:off x="1143000" y="3337560"/>
-            <a:ext cx="10149840" cy="777240"/>
-          </a:xfrm>
-          <a:prstGeom prst="rect">
-            <a:avLst/>
-          </a:prstGeom>
-          <a:noFill/>
-          <a:ln/>
-        </p:spPr>
-        <p:txBody>
-          <a:bodyPr wrap="square" rtlCol="0" anchor="ctr"/>
-          <a:lstStyle/>
-          <a:p>
-            <a:pPr indent="0" marL="0">
-              <a:lnSpc>
-                <a:spcPts val="2000"/>
-              </a:lnSpc>
-              <a:buNone/>
-            </a:pPr>
-            <a:r>
-              <a:rPr lang="en-US" sz="1500" dirty="0">
-                <a:solidFill>
-                  <a:srgbClr val="E8E5DC"/>
-                </a:solidFill>
-                <a:latin typeface="Calibri" pitchFamily="34" charset="0"/>
-                <a:ea typeface="Calibri" pitchFamily="34" charset="-122"/>
-                <a:cs typeface="Calibri" pitchFamily="34" charset="-120"/>
-              </a:rPr>
-              <a:t>Truy hồi lai + rerank vượt trội mọi phương án đơn lẻ: Recall@5 = 0.804.</a:t>
-            </a:r>
-            <a:endParaRPr lang="en-US" sz="1500" dirty="0"/>
-          </a:p>
-        </p:txBody>
-      </p:sp>
-      <p:sp>
-        <p:nvSpPr>
-          <p:cNvPr id="8" name="Shape 6"/>
-          <p:cNvSpPr/>
-          <p:nvPr/>
-        </p:nvSpPr>
-        <p:spPr>
-          <a:xfrm>
-            <a:off x="822960" y="4315968"/>
-            <a:ext cx="128016" cy="128016"/>
-          </a:xfrm>
-          <a:prstGeom prst="ellipse">
-            <a:avLst/>
-          </a:prstGeom>
-          <a:solidFill>
-            <a:srgbClr val="B8863B"/>
-          </a:solidFill>
-          <a:ln/>
-        </p:spPr>
-      </p:sp>
-      <p:sp>
-        <p:nvSpPr>
-          <p:cNvPr id="9" name="Text 7"/>
-          <p:cNvSpPr/>
-          <p:nvPr/>
-        </p:nvSpPr>
-        <p:spPr>
-          <a:xfrm>
-            <a:off x="1143000" y="4206240"/>
-            <a:ext cx="10149840" cy="777240"/>
-          </a:xfrm>
-          <a:prstGeom prst="rect">
-            <a:avLst/>
-          </a:prstGeom>
-          <a:noFill/>
-          <a:ln/>
-        </p:spPr>
-        <p:txBody>
-          <a:bodyPr wrap="square" rtlCol="0" anchor="ctr"/>
-          <a:lstStyle/>
-          <a:p>
-            <a:pPr indent="0" marL="0">
-              <a:lnSpc>
-                <a:spcPts val="2000"/>
-              </a:lnSpc>
-              <a:buNone/>
-            </a:pPr>
-            <a:r>
-              <a:rPr lang="en-US" sz="1500" dirty="0">
-                <a:solidFill>
-                  <a:srgbClr val="E8E5DC"/>
-                </a:solidFill>
-                <a:latin typeface="Calibri" pitchFamily="34" charset="0"/>
-                <a:ea typeface="Calibri" pitchFamily="34" charset="-122"/>
-                <a:cs typeface="Calibri" pitchFamily="34" charset="-120"/>
-              </a:rPr>
-              <a:t>RAG nâng độ bám căn cứ pháp lý từ 0.41 lên 0.94 — bằng chứng thực nghiệm trực tiếp cho cơ chế in-context learning.</a:t>
-            </a:r>
-            <a:endParaRPr lang="en-US" sz="1500" dirty="0"/>
-          </a:p>
-        </p:txBody>
-      </p:sp>
-      <p:sp>
-        <p:nvSpPr>
-          <p:cNvPr id="10" name="Shape 8"/>
-          <p:cNvSpPr/>
-          <p:nvPr/>
-        </p:nvSpPr>
-        <p:spPr>
-          <a:xfrm>
-            <a:off x="822960" y="5184648"/>
-            <a:ext cx="128016" cy="128016"/>
-          </a:xfrm>
-          <a:prstGeom prst="ellipse">
-            <a:avLst/>
-          </a:prstGeom>
-          <a:solidFill>
-            <a:srgbClr val="B8863B"/>
-          </a:solidFill>
-          <a:ln/>
-        </p:spPr>
-      </p:sp>
-      <p:sp>
-        <p:nvSpPr>
-          <p:cNvPr id="11" name="Text 9"/>
-          <p:cNvSpPr/>
-          <p:nvPr/>
-        </p:nvSpPr>
-        <p:spPr>
-          <a:xfrm>
-            <a:off x="1143000" y="5074920"/>
-            <a:ext cx="10149840" cy="777240"/>
-          </a:xfrm>
-          <a:prstGeom prst="rect">
-            <a:avLst/>
-          </a:prstGeom>
-          <a:noFill/>
-          <a:ln/>
-        </p:spPr>
-        <p:txBody>
-          <a:bodyPr wrap="square" rtlCol="0" anchor="ctr"/>
-          <a:lstStyle/>
-          <a:p>
-            <a:pPr indent="0" marL="0">
-              <a:lnSpc>
-                <a:spcPts val="2000"/>
-              </a:lnSpc>
-              <a:buNone/>
-            </a:pPr>
-            <a:r>
-              <a:rPr lang="en-US" sz="1500" dirty="0">
-                <a:solidFill>
-                  <a:srgbClr val="E8E5DC"/>
-                </a:solidFill>
-                <a:latin typeface="Calibri" pitchFamily="34" charset="0"/>
-                <a:ea typeface="Calibri" pitchFamily="34" charset="-122"/>
-                <a:cs typeface="Calibri" pitchFamily="34" charset="-120"/>
-              </a:rPr>
-              <a:t>Phân tích kiến trúc biểu diễn + không gian embedding gắn liền với kết quả truy hồi đo được, không chỉ mô tả lý thuyết suông.</a:t>
-            </a:r>
-            <a:endParaRPr lang="en-US" sz="1500" dirty="0"/>
-          </a:p>
-        </p:txBody>
-      </p:sp>
-      <p:sp>
-        <p:nvSpPr>
-          <p:cNvPr id="12" name="Text 10"/>
+          <p:cNvPr id="28" name="Text 26"/>
           <p:cNvSpPr/>
           <p:nvPr/>
         </p:nvSpPr>
@@ -5579,6 +6275,465 @@
         </p:nvSpPr>
         <p:spPr>
           <a:xfrm>
+            <a:off x="548640" y="365760"/>
+            <a:ext cx="7315200" cy="365760"/>
+          </a:xfrm>
+          <a:prstGeom prst="rect">
+            <a:avLst/>
+          </a:prstGeom>
+          <a:noFill/>
+          <a:ln/>
+        </p:spPr>
+        <p:txBody>
+          <a:bodyPr wrap="square" rtlCol="0" anchor="ctr"/>
+          <a:lstStyle/>
+          <a:p>
+            <a:pPr indent="0" marL="0">
+              <a:buNone/>
+            </a:pPr>
+            <a:r>
+              <a:rPr lang="en-US" sz="1200" b="1" spc="200" kern="0" dirty="0">
+                <a:solidFill>
+                  <a:srgbClr val="B8863B"/>
+                </a:solidFill>
+                <a:latin typeface="Calibri" pitchFamily="34" charset="0"/>
+                <a:ea typeface="Calibri" pitchFamily="34" charset="-122"/>
+                <a:cs typeface="Calibri" pitchFamily="34" charset="-120"/>
+              </a:rPr>
+              <a:t>KẾT LUẬN</a:t>
+            </a:r>
+            <a:endParaRPr lang="en-US" sz="1200" dirty="0"/>
+          </a:p>
+        </p:txBody>
+      </p:sp>
+      <p:sp>
+        <p:nvSpPr>
+          <p:cNvPr id="3" name="Text 1"/>
+          <p:cNvSpPr/>
+          <p:nvPr/>
+        </p:nvSpPr>
+        <p:spPr>
+          <a:xfrm>
+            <a:off x="548640" y="685800"/>
+            <a:ext cx="11064240" cy="822960"/>
+          </a:xfrm>
+          <a:prstGeom prst="rect">
+            <a:avLst/>
+          </a:prstGeom>
+          <a:noFill/>
+          <a:ln/>
+        </p:spPr>
+        <p:txBody>
+          <a:bodyPr wrap="square" rtlCol="0" anchor="ctr"/>
+          <a:lstStyle/>
+          <a:p>
+            <a:pPr algn="l" indent="0" marL="0">
+              <a:buNone/>
+            </a:pPr>
+            <a:r>
+              <a:rPr lang="en-US" sz="2800" b="1" dirty="0">
+                <a:solidFill>
+                  <a:srgbClr val="FFFFFF"/>
+                </a:solidFill>
+                <a:latin typeface="Cambria" pitchFamily="34" charset="0"/>
+                <a:ea typeface="Cambria" pitchFamily="34" charset="-122"/>
+                <a:cs typeface="Cambria" pitchFamily="34" charset="-120"/>
+              </a:rPr>
+              <a:t>Đóng góp Deep Learning nằm ở thiết kế, ghép nối và đánh giá — đúng đề cương</a:t>
+            </a:r>
+            <a:endParaRPr lang="en-US" sz="2800" dirty="0"/>
+          </a:p>
+        </p:txBody>
+      </p:sp>
+      <p:sp>
+        <p:nvSpPr>
+          <p:cNvPr id="4" name="Shape 2"/>
+          <p:cNvSpPr/>
+          <p:nvPr/>
+        </p:nvSpPr>
+        <p:spPr>
+          <a:xfrm>
+            <a:off x="822960" y="2441448"/>
+            <a:ext cx="128016" cy="128016"/>
+          </a:xfrm>
+          <a:prstGeom prst="ellipse">
+            <a:avLst/>
+          </a:prstGeom>
+          <a:solidFill>
+            <a:srgbClr val="B8863B"/>
+          </a:solidFill>
+          <a:ln/>
+        </p:spPr>
+      </p:sp>
+      <p:sp>
+        <p:nvSpPr>
+          <p:cNvPr id="5" name="Text 3"/>
+          <p:cNvSpPr/>
+          <p:nvPr/>
+        </p:nvSpPr>
+        <p:spPr>
+          <a:xfrm>
+            <a:off x="1143000" y="2331720"/>
+            <a:ext cx="10149840" cy="731520"/>
+          </a:xfrm>
+          <a:prstGeom prst="rect">
+            <a:avLst/>
+          </a:prstGeom>
+          <a:noFill/>
+          <a:ln/>
+        </p:spPr>
+        <p:txBody>
+          <a:bodyPr wrap="square" rtlCol="0" anchor="ctr"/>
+          <a:lstStyle/>
+          <a:p>
+            <a:pPr indent="0" marL="0">
+              <a:lnSpc>
+                <a:spcPts val="1800"/>
+              </a:lnSpc>
+              <a:buNone/>
+            </a:pPr>
+            <a:r>
+              <a:rPr lang="en-US" sz="1400" dirty="0">
+                <a:solidFill>
+                  <a:srgbClr val="E8E5DC"/>
+                </a:solidFill>
+                <a:latin typeface="Calibri" pitchFamily="34" charset="0"/>
+                <a:ea typeface="Calibri" pitchFamily="34" charset="-122"/>
+                <a:cs typeface="Calibri" pitchFamily="34" charset="-120"/>
+              </a:rPr>
+              <a:t>Kho tri thức pháp luật thật 326 Điều — bao gồm 1 văn bản chuyên ngành CNTT khôi phục từ nguồn thay thế khi bản chính thức chỉ có scan ảnh.</a:t>
+            </a:r>
+            <a:endParaRPr lang="en-US" sz="1400" dirty="0"/>
+          </a:p>
+        </p:txBody>
+      </p:sp>
+      <p:sp>
+        <p:nvSpPr>
+          <p:cNvPr id="6" name="Shape 4"/>
+          <p:cNvSpPr/>
+          <p:nvPr/>
+        </p:nvSpPr>
+        <p:spPr>
+          <a:xfrm>
+            <a:off x="822960" y="3218688"/>
+            <a:ext cx="128016" cy="128016"/>
+          </a:xfrm>
+          <a:prstGeom prst="ellipse">
+            <a:avLst/>
+          </a:prstGeom>
+          <a:solidFill>
+            <a:srgbClr val="B8863B"/>
+          </a:solidFill>
+          <a:ln/>
+        </p:spPr>
+      </p:sp>
+      <p:sp>
+        <p:nvSpPr>
+          <p:cNvPr id="7" name="Text 5"/>
+          <p:cNvSpPr/>
+          <p:nvPr/>
+        </p:nvSpPr>
+        <p:spPr>
+          <a:xfrm>
+            <a:off x="1143000" y="3108960"/>
+            <a:ext cx="10149840" cy="731520"/>
+          </a:xfrm>
+          <a:prstGeom prst="rect">
+            <a:avLst/>
+          </a:prstGeom>
+          <a:noFill/>
+          <a:ln/>
+        </p:spPr>
+        <p:txBody>
+          <a:bodyPr wrap="square" rtlCol="0" anchor="ctr"/>
+          <a:lstStyle/>
+          <a:p>
+            <a:pPr indent="0" marL="0">
+              <a:lnSpc>
+                <a:spcPts val="1800"/>
+              </a:lnSpc>
+              <a:buNone/>
+            </a:pPr>
+            <a:r>
+              <a:rPr lang="en-US" sz="1400" dirty="0">
+                <a:solidFill>
+                  <a:srgbClr val="E8E5DC"/>
+                </a:solidFill>
+                <a:latin typeface="Calibri" pitchFamily="34" charset="0"/>
+                <a:ea typeface="Calibri" pitchFamily="34" charset="-122"/>
+                <a:cs typeface="Calibri" pitchFamily="34" charset="-120"/>
+              </a:rPr>
+              <a:t>Truy hồi lai + rerank vượt trội mọi phương án đơn lẻ: Recall@5 = 0.761.</a:t>
+            </a:r>
+            <a:endParaRPr lang="en-US" sz="1400" dirty="0"/>
+          </a:p>
+        </p:txBody>
+      </p:sp>
+      <p:sp>
+        <p:nvSpPr>
+          <p:cNvPr id="8" name="Shape 6"/>
+          <p:cNvSpPr/>
+          <p:nvPr/>
+        </p:nvSpPr>
+        <p:spPr>
+          <a:xfrm>
+            <a:off x="822960" y="3995928"/>
+            <a:ext cx="128016" cy="128016"/>
+          </a:xfrm>
+          <a:prstGeom prst="ellipse">
+            <a:avLst/>
+          </a:prstGeom>
+          <a:solidFill>
+            <a:srgbClr val="B8863B"/>
+          </a:solidFill>
+          <a:ln/>
+        </p:spPr>
+      </p:sp>
+      <p:sp>
+        <p:nvSpPr>
+          <p:cNvPr id="9" name="Text 7"/>
+          <p:cNvSpPr/>
+          <p:nvPr/>
+        </p:nvSpPr>
+        <p:spPr>
+          <a:xfrm>
+            <a:off x="1143000" y="3886200"/>
+            <a:ext cx="10149840" cy="731520"/>
+          </a:xfrm>
+          <a:prstGeom prst="rect">
+            <a:avLst/>
+          </a:prstGeom>
+          <a:noFill/>
+          <a:ln/>
+        </p:spPr>
+        <p:txBody>
+          <a:bodyPr wrap="square" rtlCol="0" anchor="ctr"/>
+          <a:lstStyle/>
+          <a:p>
+            <a:pPr indent="0" marL="0">
+              <a:lnSpc>
+                <a:spcPts val="1800"/>
+              </a:lnSpc>
+              <a:buNone/>
+            </a:pPr>
+            <a:r>
+              <a:rPr lang="en-US" sz="1400" dirty="0">
+                <a:solidFill>
+                  <a:srgbClr val="E8E5DC"/>
+                </a:solidFill>
+                <a:latin typeface="Calibri" pitchFamily="34" charset="0"/>
+                <a:ea typeface="Calibri" pitchFamily="34" charset="-122"/>
+                <a:cs typeface="Calibri" pitchFamily="34" charset="-120"/>
+              </a:rPr>
+              <a:t>RAG nâng độ bám căn cứ pháp lý từ 0.41 lên 0.94 — bằng chứng thực nghiệm trực tiếp cho cơ chế in-context learning.</a:t>
+            </a:r>
+            <a:endParaRPr lang="en-US" sz="1400" dirty="0"/>
+          </a:p>
+        </p:txBody>
+      </p:sp>
+      <p:sp>
+        <p:nvSpPr>
+          <p:cNvPr id="10" name="Shape 8"/>
+          <p:cNvSpPr/>
+          <p:nvPr/>
+        </p:nvSpPr>
+        <p:spPr>
+          <a:xfrm>
+            <a:off x="822960" y="4773168"/>
+            <a:ext cx="128016" cy="128016"/>
+          </a:xfrm>
+          <a:prstGeom prst="ellipse">
+            <a:avLst/>
+          </a:prstGeom>
+          <a:solidFill>
+            <a:srgbClr val="B8863B"/>
+          </a:solidFill>
+          <a:ln/>
+        </p:spPr>
+      </p:sp>
+      <p:sp>
+        <p:nvSpPr>
+          <p:cNvPr id="11" name="Text 9"/>
+          <p:cNvSpPr/>
+          <p:nvPr/>
+        </p:nvSpPr>
+        <p:spPr>
+          <a:xfrm>
+            <a:off x="1143000" y="4663440"/>
+            <a:ext cx="10149840" cy="731520"/>
+          </a:xfrm>
+          <a:prstGeom prst="rect">
+            <a:avLst/>
+          </a:prstGeom>
+          <a:noFill/>
+          <a:ln/>
+        </p:spPr>
+        <p:txBody>
+          <a:bodyPr wrap="square" rtlCol="0" anchor="ctr"/>
+          <a:lstStyle/>
+          <a:p>
+            <a:pPr indent="0" marL="0">
+              <a:lnSpc>
+                <a:spcPts val="1800"/>
+              </a:lnSpc>
+              <a:buNone/>
+            </a:pPr>
+            <a:r>
+              <a:rPr lang="en-US" sz="1400" dirty="0">
+                <a:solidFill>
+                  <a:srgbClr val="E8E5DC"/>
+                </a:solidFill>
+                <a:latin typeface="Calibri" pitchFamily="34" charset="0"/>
+                <a:ea typeface="Calibri" pitchFamily="34" charset="-122"/>
+                <a:cs typeface="Calibri" pitchFamily="34" charset="-120"/>
+              </a:rPr>
+              <a:t>Rà soát pipeline bằng đo đạc thực tế (không suy đoán) tìm và sửa 3 lỗi thật, minh chứng giá trị kiểm chứng kỹ thuật độc lập.</a:t>
+            </a:r>
+            <a:endParaRPr lang="en-US" sz="1400" dirty="0"/>
+          </a:p>
+        </p:txBody>
+      </p:sp>
+      <p:sp>
+        <p:nvSpPr>
+          <p:cNvPr id="12" name="Shape 10"/>
+          <p:cNvSpPr/>
+          <p:nvPr/>
+        </p:nvSpPr>
+        <p:spPr>
+          <a:xfrm>
+            <a:off x="822960" y="5550408"/>
+            <a:ext cx="128016" cy="128016"/>
+          </a:xfrm>
+          <a:prstGeom prst="ellipse">
+            <a:avLst/>
+          </a:prstGeom>
+          <a:solidFill>
+            <a:srgbClr val="B8863B"/>
+          </a:solidFill>
+          <a:ln/>
+        </p:spPr>
+      </p:sp>
+      <p:sp>
+        <p:nvSpPr>
+          <p:cNvPr id="13" name="Text 11"/>
+          <p:cNvSpPr/>
+          <p:nvPr/>
+        </p:nvSpPr>
+        <p:spPr>
+          <a:xfrm>
+            <a:off x="1143000" y="5440680"/>
+            <a:ext cx="10149840" cy="731520"/>
+          </a:xfrm>
+          <a:prstGeom prst="rect">
+            <a:avLst/>
+          </a:prstGeom>
+          <a:noFill/>
+          <a:ln/>
+        </p:spPr>
+        <p:txBody>
+          <a:bodyPr wrap="square" rtlCol="0" anchor="ctr"/>
+          <a:lstStyle/>
+          <a:p>
+            <a:pPr indent="0" marL="0">
+              <a:lnSpc>
+                <a:spcPts val="1800"/>
+              </a:lnSpc>
+              <a:buNone/>
+            </a:pPr>
+            <a:r>
+              <a:rPr lang="en-US" sz="1400" dirty="0">
+                <a:solidFill>
+                  <a:srgbClr val="E8E5DC"/>
+                </a:solidFill>
+                <a:latin typeface="Calibri" pitchFamily="34" charset="0"/>
+                <a:ea typeface="Calibri" pitchFamily="34" charset="-122"/>
+                <a:cs typeface="Calibri" pitchFamily="34" charset="-120"/>
+              </a:rPr>
+              <a:t>Phân tích kiến trúc biểu diễn + không gian embedding gắn liền với kết quả truy hồi đo được, không chỉ mô tả lý thuyết suông.</a:t>
+            </a:r>
+            <a:endParaRPr lang="en-US" sz="1400" dirty="0"/>
+          </a:p>
+        </p:txBody>
+      </p:sp>
+      <p:sp>
+        <p:nvSpPr>
+          <p:cNvPr id="14" name="Text 12"/>
+          <p:cNvSpPr/>
+          <p:nvPr/>
+        </p:nvSpPr>
+        <p:spPr>
+          <a:xfrm>
+            <a:off x="11548872" y="6400800"/>
+            <a:ext cx="365760" cy="274320"/>
+          </a:xfrm>
+          <a:prstGeom prst="rect">
+            <a:avLst/>
+          </a:prstGeom>
+          <a:noFill/>
+          <a:ln/>
+        </p:spPr>
+        <p:txBody>
+          <a:bodyPr wrap="square" rtlCol="0" anchor="ctr"/>
+          <a:lstStyle/>
+          <a:p>
+            <a:pPr algn="r" indent="0" marL="0">
+              <a:buNone/>
+            </a:pPr>
+            <a:r>
+              <a:rPr lang="en-US" sz="1000" dirty="0">
+                <a:solidFill>
+                  <a:srgbClr val="5B6672"/>
+                </a:solidFill>
+                <a:latin typeface="Calibri" pitchFamily="34" charset="0"/>
+                <a:ea typeface="Calibri" pitchFamily="34" charset="-122"/>
+                <a:cs typeface="Calibri" pitchFamily="34" charset="-120"/>
+              </a:rPr>
+              <a:t>15</a:t>
+            </a:r>
+            <a:endParaRPr lang="en-US" sz="1000" dirty="0"/>
+          </a:p>
+        </p:txBody>
+      </p:sp>
+    </p:spTree>
+  </p:cSld>
+  <p:clrMapOvr>
+    <a:masterClrMapping/>
+  </p:clrMapOvr>
+</p:sld>
+</file>
+
+<file path=ppt/slides/slide16.xml><?xml version="1.0" encoding="utf-8"?>
+<p:sld xmlns:a="http://schemas.openxmlformats.org/drawingml/2006/main" xmlns:r="http://schemas.openxmlformats.org/officeDocument/2006/relationships" xmlns:p="http://schemas.openxmlformats.org/presentationml/2006/main">
+  <p:cSld name="Slide 16">
+    <p:bg>
+      <p:bgPr>
+        <a:solidFill>
+          <a:srgbClr val="17212B"/>
+        </a:solidFill>
+      </p:bgPr>
+    </p:bg>
+    <p:spTree>
+      <p:nvGrpSpPr>
+        <p:cNvPr id="1" name=""/>
+        <p:cNvGrpSpPr/>
+        <p:nvPr/>
+      </p:nvGrpSpPr>
+      <p:grpSpPr>
+        <a:xfrm>
+          <a:off x="0" y="0"/>
+          <a:ext cx="0" cy="0"/>
+          <a:chOff x="0" y="0"/>
+          <a:chExt cx="0" cy="0"/>
+        </a:xfrm>
+      </p:grpSpPr>
+      <p:sp>
+        <p:nvSpPr>
+          <p:cNvPr id="2" name="Text 0"/>
+          <p:cNvSpPr/>
+          <p:nvPr/>
+        </p:nvSpPr>
+        <p:spPr>
+          <a:xfrm>
             <a:off x="822960" y="2651760"/>
             <a:ext cx="10515600" cy="914400"/>
           </a:xfrm>
@@ -10601,7 +11756,7 @@
                 <a:ea typeface="Calibri" pitchFamily="34" charset="-122"/>
                 <a:cs typeface="Calibri" pitchFamily="34" charset="-120"/>
               </a:rPr>
-              <a:t>Model đa ngôn ngữ có similarity tuyệt đối cao hơn ở cả 2 nhóm — dấu hiệu embedding “co cụm” hơn. Model tiếng Việt chuyên biệt tách biệt tương đối tốt hơn (0.1595 &gt; 0.1477).</a:t>
+              <a:t>Model đa ngôn ngữ có similarity tuyệt đối cao hơn ở cả 2 nhóm — dấu hiệu embedding “co cụm” hơn. Model tiếng Việt chuyên biệt tách biệt tương đối tốt hơn (0.1836 &gt; 0.1674, sau khi sửa lỗi mã hoá — xem slide sau).</a:t>
             </a:r>
             <a:endParaRPr lang="en-US" sz="1200" dirty="0"/>
           </a:p>

</xml_diff>

<commit_message>
Rebuild report/slides binaries (content unchanged, verified)
Local docx/pptx had drifted from the previous commit at the binary level
(office-doc generators embed non-deterministic timestamps/compression) --
verified content is identical to what was committed before: 79 paragraphs
+ 3 tables (4/5/3 rows) in the report, 17 slides in the deck.

Co-Authored-By: Claude Sonnet 5 <noreply@anthropic.com>
</commit_message>
<xml_diff>
--- a/docs/AutoTender-VN_Slides.pptx
+++ b/docs/AutoTender-VN_Slides.pptx
@@ -4,6 +4,9 @@
   <p:sldMasterIdLst>
     <p:sldMasterId id="2147483648" r:id="rId1"/>
   </p:sldMasterIdLst>
+  <p:notesMasterIdLst>
+    <p:notesMasterId r:id="rId19"/>
+  </p:notesMasterIdLst>
   <p:sldIdLst>
     <p:sldId id="256" r:id="rId2"/>
     <p:sldId id="257" r:id="rId3"/>
@@ -23,9 +26,6 @@
     <p:sldId id="271" r:id="rId17"/>
     <p:sldId id="272" r:id="rId18"/>
   </p:sldIdLst>
-  <p:notesMasterIdLst>
-    <p:notesMasterId r:id="rId19"/>
-  </p:notesMasterIdLst>
   <p:sldSz cx="12192000" cy="6858000"/>
   <p:notesSz cx="6858000" cy="12192000"/>
   <p:defaultTextStyle>
@@ -120,13 +120,20 @@
       </a:defRPr>
     </a:lvl9pPr>
   </p:defaultTextStyle>
+  <p:extLst>
+    <p:ext uri="{EFAFB233-063F-42B5-8137-9DF3F51BA10A}">
+      <p15:sldGuideLst xmlns:p15="http://schemas.microsoft.com/office/powerpoint/2012/main"/>
+    </p:ext>
+  </p:extLst>
 </p:presentation>
 </file>
 
 <file path=ppt/charts/chart1.xml><?xml version="1.0" encoding="utf-8"?>
-<c:chartSpace xmlns:c="http://schemas.openxmlformats.org/drawingml/2006/chart" xmlns:a="http://schemas.openxmlformats.org/drawingml/2006/main" xmlns:r="http://schemas.openxmlformats.org/officeDocument/2006/relationships">
+<c:chartSpace xmlns:c="http://schemas.openxmlformats.org/drawingml/2006/chart" xmlns:a="http://schemas.openxmlformats.org/drawingml/2006/main" xmlns:r="http://schemas.openxmlformats.org/officeDocument/2006/relationships" xmlns:c16r2="http://schemas.microsoft.com/office/drawing/2015/06/chart">
   <c:date1904 val="0"/>
+  <c:lang val="en-US"/>
   <c:roundedCorners val="1"/>
+  <c:style val="2"/>
   <c:chart>
     <c:title>
       <c:tx>
@@ -154,7 +161,6 @@
           </a:p>
         </c:rich>
       </c:tx>
-      <c:layout/>
       <c:overlay val="0"/>
     </c:title>
     <c:autoTitleDeleted val="0"/>
@@ -187,18 +193,26 @@
           <c:invertIfNegative val="0"/>
           <c:dLbls>
             <c:numFmt formatCode="0.0000" sourceLinked="0"/>
+            <c:spPr>
+              <a:noFill/>
+              <a:ln>
+                <a:noFill/>
+              </a:ln>
+              <a:effectLst/>
+            </c:spPr>
             <c:txPr>
               <a:bodyPr/>
               <a:lstStyle/>
               <a:p>
                 <a:pPr>
-                  <a:defRPr b="0" i="0" strike="noStrike" sz="1200" u="none">
+                  <a:defRPr sz="1200" b="0" i="0" u="none" strike="noStrike">
                     <a:solidFill>
                       <a:srgbClr val="17212B"/>
                     </a:solidFill>
                     <a:latin typeface="Arial"/>
                   </a:defRPr>
                 </a:pPr>
+                <a:endParaRPr lang="en-US"/>
               </a:p>
             </c:txPr>
             <c:showLegendKey val="0"/>
@@ -208,28 +222,31 @@
             <c:showPercent val="0"/>
             <c:showBubbleSize val="0"/>
             <c:showLeaderLines val="0"/>
+            <c:extLst>
+              <c:ext xmlns:c15="http://schemas.microsoft.com/office/drawing/2012/chart" uri="{CE6537A1-D6FC-4f65-9D91-7224C49458BB}">
+                <c15:showLeaderLines val="0"/>
+              </c:ext>
+            </c:extLst>
           </c:dLbls>
           <c:cat>
-            <c:multiLvlStrRef>
+            <c:strRef>
               <c:f>Sheet1!$A$2:$A$4</c:f>
-              <c:multiLvlStrCache>
+              <c:strCache>
                 <c:ptCount val="3"/>
-                <c:lvl>
-                  <c:pt idx="0">
-                    <c:v>vi_bi_encoder
+                <c:pt idx="0">
+                  <c:v>vi_bi_encoder
 (768d, SimCSE tiếng Việt)</c:v>
-                  </c:pt>
-                  <c:pt idx="1">
-                    <c:v>multilingual_minilm
+                </c:pt>
+                <c:pt idx="1">
+                  <c:v>multilingual_minilm
 (384d, đa ngôn ngữ)</c:v>
-                  </c:pt>
-                  <c:pt idx="2">
-                    <c:v>bge-m3
+                </c:pt>
+                <c:pt idx="2">
+                  <c:v>bge-m3
 (1024d, ngữ cảnh dài)</c:v>
-                  </c:pt>
-                </c:lvl>
-              </c:multiLvlStrCache>
-            </c:multiLvlStrRef>
+                </c:pt>
+              </c:strCache>
+            </c:strRef>
           </c:cat>
           <c:val>
             <c:numRef>
@@ -238,47 +255,34 @@
                 <c:formatCode>General</c:formatCode>
                 <c:ptCount val="3"/>
                 <c:pt idx="0">
-                  <c:v>0.1836</c:v>
+                  <c:v>0.18360000000000001</c:v>
                 </c:pt>
                 <c:pt idx="1">
-                  <c:v>0.1674</c:v>
+                  <c:v>0.16739999999999999</c:v>
                 </c:pt>
                 <c:pt idx="2">
-                  <c:v>0.1155</c:v>
+                  <c:v>0.11550000000000001</c:v>
                 </c:pt>
               </c:numCache>
             </c:numRef>
           </c:val>
+          <c:extLst>
+            <c:ext xmlns:c16="http://schemas.microsoft.com/office/drawing/2014/chart" uri="{C3380CC4-5D6E-409C-BE32-E72D297353CC}">
+              <c16:uniqueId val="{00000000-F413-4992-BA96-50D88B9FF331}"/>
+            </c:ext>
+          </c:extLst>
         </c:ser>
         <c:dLbls>
-          <c:numFmt formatCode="0.0000" sourceLinked="0"/>
-          <c:txPr>
-            <a:bodyPr/>
-            <a:lstStyle/>
-            <a:p>
-              <a:pPr>
-                <a:defRPr b="0" i="0" strike="noStrike" sz="1200" u="none">
-                  <a:solidFill>
-                    <a:srgbClr val="17212B"/>
-                  </a:solidFill>
-                  <a:latin typeface="Arial"/>
-                </a:defRPr>
-              </a:pPr>
-            </a:p>
-          </c:txPr>
           <c:showLegendKey val="0"/>
           <c:showVal val="1"/>
           <c:showCatName val="0"/>
           <c:showSerName val="0"/>
           <c:showPercent val="0"/>
           <c:showBubbleSize val="0"/>
-          <c:showLeaderLines val="0"/>
         </c:dLbls>
         <c:gapWidth val="60"/>
-        <c:overlap val="0"/>
         <c:axId val="2094734554"/>
         <c:axId val="2094734552"/>
-        <c:axId val="2094734556"/>
       </c:barChart>
       <c:catAx>
         <c:axId val="2094734554"/>
@@ -319,6 +323,7 @@
         <c:crosses val="autoZero"/>
         <c:auto val="1"/>
         <c:lblAlgn val="ctr"/>
+        <c:lblOffset val="100"/>
         <c:noMultiLvlLbl val="1"/>
       </c:catAx>
       <c:valAx>
@@ -381,6 +386,7 @@
     </c:plotArea>
     <c:plotVisOnly val="1"/>
     <c:dispBlanksAs val="span"/>
+    <c:showDLblsOverMax val="1"/>
   </c:chart>
   <c:spPr>
     <a:noFill/>
@@ -396,9 +402,11 @@
 </file>
 
 <file path=ppt/charts/chart2.xml><?xml version="1.0" encoding="utf-8"?>
-<c:chartSpace xmlns:c="http://schemas.openxmlformats.org/drawingml/2006/chart" xmlns:a="http://schemas.openxmlformats.org/drawingml/2006/main" xmlns:r="http://schemas.openxmlformats.org/officeDocument/2006/relationships">
+<c:chartSpace xmlns:c="http://schemas.openxmlformats.org/drawingml/2006/chart" xmlns:a="http://schemas.openxmlformats.org/drawingml/2006/main" xmlns:r="http://schemas.openxmlformats.org/officeDocument/2006/relationships" xmlns:c16r2="http://schemas.microsoft.com/office/drawing/2015/06/chart">
   <c:date1904 val="0"/>
+  <c:lang val="en-US"/>
   <c:roundedCorners val="1"/>
+  <c:style val="2"/>
   <c:chart>
     <c:autoTitleDeleted val="1"/>
     <c:plotArea>
@@ -430,18 +438,26 @@
           <c:invertIfNegative val="0"/>
           <c:dLbls>
             <c:numFmt formatCode="0.00" sourceLinked="0"/>
+            <c:spPr>
+              <a:noFill/>
+              <a:ln>
+                <a:noFill/>
+              </a:ln>
+              <a:effectLst/>
+            </c:spPr>
             <c:txPr>
               <a:bodyPr/>
               <a:lstStyle/>
               <a:p>
                 <a:pPr>
-                  <a:defRPr b="0" i="0" strike="noStrike" sz="900" u="none">
+                  <a:defRPr sz="900" b="0" i="0" u="none" strike="noStrike">
                     <a:solidFill>
                       <a:srgbClr val="17212B"/>
                     </a:solidFill>
                     <a:latin typeface="Arial"/>
                   </a:defRPr>
                 </a:pPr>
+                <a:endParaRPr lang="en-US"/>
               </a:p>
             </c:txPr>
             <c:showLegendKey val="0"/>
@@ -451,28 +467,31 @@
             <c:showPercent val="0"/>
             <c:showBubbleSize val="0"/>
             <c:showLeaderLines val="0"/>
+            <c:extLst>
+              <c:ext xmlns:c15="http://schemas.microsoft.com/office/drawing/2012/chart" uri="{CE6537A1-D6FC-4f65-9D91-7224C49458BB}">
+                <c15:showLeaderLines val="0"/>
+              </c:ext>
+            </c:extLst>
           </c:dLbls>
           <c:cat>
-            <c:multiLvlStrRef>
+            <c:strRef>
               <c:f>Sheet1!$A$2:$A$5</c:f>
-              <c:multiLvlStrCache>
+              <c:strCache>
                 <c:ptCount val="4"/>
-                <c:lvl>
-                  <c:pt idx="0">
-                    <c:v>BM25</c:v>
-                  </c:pt>
-                  <c:pt idx="1">
-                    <c:v>Dense</c:v>
-                  </c:pt>
-                  <c:pt idx="2">
-                    <c:v>Hybrid RRF</c:v>
-                  </c:pt>
-                  <c:pt idx="3">
-                    <c:v>Hybrid+Rerank</c:v>
-                  </c:pt>
-                </c:lvl>
-              </c:multiLvlStrCache>
-            </c:multiLvlStrRef>
+                <c:pt idx="0">
+                  <c:v>BM25</c:v>
+                </c:pt>
+                <c:pt idx="1">
+                  <c:v>Dense</c:v>
+                </c:pt>
+                <c:pt idx="2">
+                  <c:v>Hybrid RRF</c:v>
+                </c:pt>
+                <c:pt idx="3">
+                  <c:v>Hybrid+Rerank</c:v>
+                </c:pt>
+              </c:strCache>
+            </c:strRef>
           </c:cat>
           <c:val>
             <c:numRef>
@@ -481,20 +500,25 @@
                 <c:formatCode>General</c:formatCode>
                 <c:ptCount val="4"/>
                 <c:pt idx="0">
-                  <c:v>0.565</c:v>
+                  <c:v>0.56499999999999995</c:v>
                 </c:pt>
                 <c:pt idx="1">
-                  <c:v>0.696</c:v>
+                  <c:v>0.69599999999999995</c:v>
                 </c:pt>
                 <c:pt idx="2">
-                  <c:v>0.674</c:v>
+                  <c:v>0.67400000000000004</c:v>
                 </c:pt>
                 <c:pt idx="3">
-                  <c:v>0.761</c:v>
+                  <c:v>0.76100000000000001</c:v>
                 </c:pt>
               </c:numCache>
             </c:numRef>
           </c:val>
+          <c:extLst>
+            <c:ext xmlns:c16="http://schemas.microsoft.com/office/drawing/2014/chart" uri="{C3380CC4-5D6E-409C-BE32-E72D297353CC}">
+              <c16:uniqueId val="{00000000-B019-48BF-A512-01180258AEA2}"/>
+            </c:ext>
+          </c:extLst>
         </c:ser>
         <c:ser>
           <c:idx val="1"/>
@@ -519,18 +543,26 @@
           <c:invertIfNegative val="0"/>
           <c:dLbls>
             <c:numFmt formatCode="0.00" sourceLinked="0"/>
+            <c:spPr>
+              <a:noFill/>
+              <a:ln>
+                <a:noFill/>
+              </a:ln>
+              <a:effectLst/>
+            </c:spPr>
             <c:txPr>
               <a:bodyPr/>
               <a:lstStyle/>
               <a:p>
                 <a:pPr>
-                  <a:defRPr b="0" i="0" strike="noStrike" sz="900" u="none">
+                  <a:defRPr sz="900" b="0" i="0" u="none" strike="noStrike">
                     <a:solidFill>
                       <a:srgbClr val="17212B"/>
                     </a:solidFill>
                     <a:latin typeface="Arial"/>
                   </a:defRPr>
                 </a:pPr>
+                <a:endParaRPr lang="en-US"/>
               </a:p>
             </c:txPr>
             <c:showLegendKey val="0"/>
@@ -540,28 +572,31 @@
             <c:showPercent val="0"/>
             <c:showBubbleSize val="0"/>
             <c:showLeaderLines val="0"/>
+            <c:extLst>
+              <c:ext xmlns:c15="http://schemas.microsoft.com/office/drawing/2012/chart" uri="{CE6537A1-D6FC-4f65-9D91-7224C49458BB}">
+                <c15:showLeaderLines val="0"/>
+              </c:ext>
+            </c:extLst>
           </c:dLbls>
           <c:cat>
-            <c:multiLvlStrRef>
+            <c:strRef>
               <c:f>Sheet1!$A$2:$A$5</c:f>
-              <c:multiLvlStrCache>
+              <c:strCache>
                 <c:ptCount val="4"/>
-                <c:lvl>
-                  <c:pt idx="0">
-                    <c:v>BM25</c:v>
-                  </c:pt>
-                  <c:pt idx="1">
-                    <c:v>Dense</c:v>
-                  </c:pt>
-                  <c:pt idx="2">
-                    <c:v>Hybrid RRF</c:v>
-                  </c:pt>
-                  <c:pt idx="3">
-                    <c:v>Hybrid+Rerank</c:v>
-                  </c:pt>
-                </c:lvl>
-              </c:multiLvlStrCache>
-            </c:multiLvlStrRef>
+                <c:pt idx="0">
+                  <c:v>BM25</c:v>
+                </c:pt>
+                <c:pt idx="1">
+                  <c:v>Dense</c:v>
+                </c:pt>
+                <c:pt idx="2">
+                  <c:v>Hybrid RRF</c:v>
+                </c:pt>
+                <c:pt idx="3">
+                  <c:v>Hybrid+Rerank</c:v>
+                </c:pt>
+              </c:strCache>
+            </c:strRef>
           </c:cat>
           <c:val>
             <c:numRef>
@@ -570,20 +605,25 @@
                 <c:formatCode>General</c:formatCode>
                 <c:ptCount val="4"/>
                 <c:pt idx="0">
-                  <c:v>0.385</c:v>
+                  <c:v>0.38500000000000001</c:v>
                 </c:pt>
                 <c:pt idx="1">
-                  <c:v>0.546</c:v>
+                  <c:v>0.54600000000000004</c:v>
                 </c:pt>
                 <c:pt idx="2">
-                  <c:v>0.537</c:v>
+                  <c:v>0.53700000000000003</c:v>
                 </c:pt>
                 <c:pt idx="3">
-                  <c:v>0.587</c:v>
+                  <c:v>0.58699999999999997</c:v>
                 </c:pt>
               </c:numCache>
             </c:numRef>
           </c:val>
+          <c:extLst>
+            <c:ext xmlns:c16="http://schemas.microsoft.com/office/drawing/2014/chart" uri="{C3380CC4-5D6E-409C-BE32-E72D297353CC}">
+              <c16:uniqueId val="{00000001-B019-48BF-A512-01180258AEA2}"/>
+            </c:ext>
+          </c:extLst>
         </c:ser>
         <c:ser>
           <c:idx val="2"/>
@@ -608,18 +648,26 @@
           <c:invertIfNegative val="0"/>
           <c:dLbls>
             <c:numFmt formatCode="0.00" sourceLinked="0"/>
+            <c:spPr>
+              <a:noFill/>
+              <a:ln>
+                <a:noFill/>
+              </a:ln>
+              <a:effectLst/>
+            </c:spPr>
             <c:txPr>
               <a:bodyPr/>
               <a:lstStyle/>
               <a:p>
                 <a:pPr>
-                  <a:defRPr b="0" i="0" strike="noStrike" sz="900" u="none">
+                  <a:defRPr sz="900" b="0" i="0" u="none" strike="noStrike">
                     <a:solidFill>
                       <a:srgbClr val="17212B"/>
                     </a:solidFill>
                     <a:latin typeface="Arial"/>
                   </a:defRPr>
                 </a:pPr>
+                <a:endParaRPr lang="en-US"/>
               </a:p>
             </c:txPr>
             <c:showLegendKey val="0"/>
@@ -629,28 +677,31 @@
             <c:showPercent val="0"/>
             <c:showBubbleSize val="0"/>
             <c:showLeaderLines val="0"/>
+            <c:extLst>
+              <c:ext xmlns:c15="http://schemas.microsoft.com/office/drawing/2012/chart" uri="{CE6537A1-D6FC-4f65-9D91-7224C49458BB}">
+                <c15:showLeaderLines val="0"/>
+              </c:ext>
+            </c:extLst>
           </c:dLbls>
           <c:cat>
-            <c:multiLvlStrRef>
+            <c:strRef>
               <c:f>Sheet1!$A$2:$A$5</c:f>
-              <c:multiLvlStrCache>
+              <c:strCache>
                 <c:ptCount val="4"/>
-                <c:lvl>
-                  <c:pt idx="0">
-                    <c:v>BM25</c:v>
-                  </c:pt>
-                  <c:pt idx="1">
-                    <c:v>Dense</c:v>
-                  </c:pt>
-                  <c:pt idx="2">
-                    <c:v>Hybrid RRF</c:v>
-                  </c:pt>
-                  <c:pt idx="3">
-                    <c:v>Hybrid+Rerank</c:v>
-                  </c:pt>
-                </c:lvl>
-              </c:multiLvlStrCache>
-            </c:multiLvlStrRef>
+                <c:pt idx="0">
+                  <c:v>BM25</c:v>
+                </c:pt>
+                <c:pt idx="1">
+                  <c:v>Dense</c:v>
+                </c:pt>
+                <c:pt idx="2">
+                  <c:v>Hybrid RRF</c:v>
+                </c:pt>
+                <c:pt idx="3">
+                  <c:v>Hybrid+Rerank</c:v>
+                </c:pt>
+              </c:strCache>
+            </c:strRef>
           </c:cat>
           <c:val>
             <c:numRef>
@@ -659,13 +710,13 @@
                 <c:formatCode>General</c:formatCode>
                 <c:ptCount val="4"/>
                 <c:pt idx="0">
-                  <c:v>0.426</c:v>
+                  <c:v>0.42599999999999999</c:v>
                 </c:pt>
                 <c:pt idx="1">
-                  <c:v>0.58</c:v>
+                  <c:v>0.57999999999999996</c:v>
                 </c:pt>
                 <c:pt idx="2">
-                  <c:v>0.564</c:v>
+                  <c:v>0.56399999999999995</c:v>
                 </c:pt>
                 <c:pt idx="3">
                   <c:v>0.627</c:v>
@@ -673,36 +724,23 @@
               </c:numCache>
             </c:numRef>
           </c:val>
+          <c:extLst>
+            <c:ext xmlns:c16="http://schemas.microsoft.com/office/drawing/2014/chart" uri="{C3380CC4-5D6E-409C-BE32-E72D297353CC}">
+              <c16:uniqueId val="{00000002-B019-48BF-A512-01180258AEA2}"/>
+            </c:ext>
+          </c:extLst>
         </c:ser>
         <c:dLbls>
-          <c:numFmt formatCode="0.00" sourceLinked="0"/>
-          <c:txPr>
-            <a:bodyPr/>
-            <a:lstStyle/>
-            <a:p>
-              <a:pPr>
-                <a:defRPr b="0" i="0" strike="noStrike" sz="900" u="none">
-                  <a:solidFill>
-                    <a:srgbClr val="17212B"/>
-                  </a:solidFill>
-                  <a:latin typeface="Arial"/>
-                </a:defRPr>
-              </a:pPr>
-            </a:p>
-          </c:txPr>
           <c:showLegendKey val="0"/>
           <c:showVal val="1"/>
           <c:showCatName val="0"/>
           <c:showSerName val="0"/>
           <c:showPercent val="0"/>
           <c:showBubbleSize val="0"/>
-          <c:showLeaderLines val="0"/>
         </c:dLbls>
         <c:gapWidth val="40"/>
-        <c:overlap val="0"/>
         <c:axId val="2094734554"/>
         <c:axId val="2094734552"/>
-        <c:axId val="2094734556"/>
       </c:barChart>
       <c:catAx>
         <c:axId val="2094734554"/>
@@ -743,6 +781,7 @@
         <c:crosses val="autoZero"/>
         <c:auto val="1"/>
         <c:lblAlgn val="ctr"/>
+        <c:lblOffset val="100"/>
         <c:noMultiLvlLbl val="1"/>
       </c:catAx>
       <c:valAx>
@@ -824,6 +863,7 @@
     </c:legend>
     <c:plotVisOnly val="1"/>
     <c:dispBlanksAs val="span"/>
+    <c:showDLblsOverMax val="1"/>
   </c:chart>
   <c:spPr>
     <a:noFill/>
@@ -860,234 +900,10 @@
           <a:chExt cx="0" cy="0"/>
         </a:xfrm>
       </p:grpSpPr>
-      <p:sp>
-        <p:nvSpPr>
-          <p:cNvPr id="2" name="Header Placeholder 1"/>
-          <p:cNvSpPr>
-            <a:spLocks noGrp="1"/>
-          </p:cNvSpPr>
-          <p:nvPr>
-            <p:ph type="hdr" sz="quarter"/>
-          </p:nvPr>
-        </p:nvSpPr>
-        <p:spPr>
-          <a:xfrm>
-            <a:off x="0" y="0"/>
-            <a:ext cx="2971800" cy="458788"/>
-          </a:xfrm>
-          <a:prstGeom prst="rect">
-            <a:avLst/>
-          </a:prstGeom>
-        </p:spPr>
-        <p:txBody>
-          <a:bodyPr vert="horz" lIns="91440" tIns="45720" rIns="91440" bIns="45720" rtlCol="0"/>
-          <a:lstStyle>
-            <a:lvl1pPr algn="l">
-              <a:defRPr sz="1200"/>
-            </a:lvl1pPr>
-          </a:lstStyle>
-          <a:p>
-            <a:endParaRPr lang="en-US"/>
-          </a:p>
-        </p:txBody>
-      </p:sp>
-      <p:sp>
-        <p:nvSpPr>
-          <p:cNvPr id="3" name="Date Placeholder 2"/>
-          <p:cNvSpPr>
-            <a:spLocks noGrp="1"/>
-          </p:cNvSpPr>
-          <p:nvPr>
-            <p:ph type="dt" idx="1"/>
-          </p:nvPr>
-        </p:nvSpPr>
-        <p:spPr>
-          <a:xfrm>
-            <a:off x="3884613" y="0"/>
-            <a:ext cx="2971800" cy="458788"/>
-          </a:xfrm>
-          <a:prstGeom prst="rect">
-            <a:avLst/>
-          </a:prstGeom>
-        </p:spPr>
-        <p:txBody>
-          <a:bodyPr vert="horz" lIns="91440" tIns="45720" rIns="91440" bIns="45720" rtlCol="0"/>
-          <a:lstStyle>
-            <a:lvl1pPr algn="r">
-              <a:defRPr sz="1200"/>
-            </a:lvl1pPr>
-          </a:lstStyle>
-          <a:p>
-            <a:fld id="{5282F153-3F37-0F45-9E97-73ACFA13230C}" type="datetimeFigureOut">
-              <a:rPr lang="en-US"/>
-              <a:t>7/23/19</a:t>
-            </a:fld>
-            <a:endParaRPr lang="en-US"/>
-          </a:p>
-        </p:txBody>
-      </p:sp>
-      <p:sp>
-        <p:nvSpPr>
-          <p:cNvPr id="4" name="Slide Image Placeholder 3"/>
-          <p:cNvSpPr>
-            <a:spLocks noGrp="1" noRot="1" noChangeAspect="1"/>
-          </p:cNvSpPr>
-          <p:nvPr>
-            <p:ph type="sldImg" idx="2"/>
-          </p:nvPr>
-        </p:nvSpPr>
-        <p:spPr>
-          <a:xfrm>
-            <a:off x="685800" y="1143000"/>
-            <a:ext cx="5486400" cy="3086100"/>
-          </a:xfrm>
-          <a:prstGeom prst="rect">
-            <a:avLst/>
-          </a:prstGeom>
-          <a:noFill/>
-          <a:ln w="12700">
-            <a:solidFill>
-              <a:prstClr val="black"/>
-            </a:solidFill>
-          </a:ln>
-        </p:spPr>
-        <p:txBody>
-          <a:bodyPr vert="horz" lIns="91440" tIns="45720" rIns="91440" bIns="45720" rtlCol="0" anchor="ctr"/>
-          <a:lstStyle/>
-          <a:p>
-            <a:endParaRPr lang="en-US"/>
-          </a:p>
-        </p:txBody>
-      </p:sp>
-      <p:sp>
-        <p:nvSpPr>
-          <p:cNvPr id="5" name="Notes Placeholder 4"/>
-          <p:cNvSpPr>
-            <a:spLocks noGrp="1"/>
-          </p:cNvSpPr>
-          <p:nvPr>
-            <p:ph type="body" sz="quarter" idx="3"/>
-          </p:nvPr>
-        </p:nvSpPr>
-        <p:spPr>
-          <a:xfrm>
-            <a:off x="685800" y="4400550"/>
-            <a:ext cx="5486400" cy="3600450"/>
-          </a:xfrm>
-          <a:prstGeom prst="rect">
-            <a:avLst/>
-          </a:prstGeom>
-        </p:spPr>
-        <p:txBody>
-          <a:bodyPr vert="horz" lIns="91440" tIns="45720" rIns="91440" bIns="45720" rtlCol="0"/>
-          <a:lstStyle/>
-          <a:p>
-            <a:pPr lvl="0"/>
-            <a:r>
-              <a:rPr lang="en-US"/>
-              <a:t>Click to edit Master text styles</a:t>
-            </a:r>
-          </a:p>
-          <a:p>
-            <a:pPr lvl="1"/>
-            <a:r>
-              <a:rPr lang="en-US"/>
-              <a:t>Second level</a:t>
-            </a:r>
-          </a:p>
-          <a:p>
-            <a:pPr lvl="2"/>
-            <a:r>
-              <a:rPr lang="en-US"/>
-              <a:t>Third level</a:t>
-            </a:r>
-          </a:p>
-          <a:p>
-            <a:pPr lvl="3"/>
-            <a:r>
-              <a:rPr lang="en-US"/>
-              <a:t>Fourth level</a:t>
-            </a:r>
-          </a:p>
-          <a:p>
-            <a:pPr lvl="4"/>
-            <a:r>
-              <a:rPr lang="en-US"/>
-              <a:t>Fifth level</a:t>
-            </a:r>
-          </a:p>
-        </p:txBody>
-      </p:sp>
-      <p:sp>
-        <p:nvSpPr>
-          <p:cNvPr id="6" name="Footer Placeholder 5"/>
-          <p:cNvSpPr>
-            <a:spLocks noGrp="1"/>
-          </p:cNvSpPr>
-          <p:nvPr>
-            <p:ph type="ftr" sz="quarter" idx="4"/>
-          </p:nvPr>
-        </p:nvSpPr>
-        <p:spPr>
-          <a:xfrm>
-            <a:off x="0" y="8685213"/>
-            <a:ext cx="2971800" cy="458787"/>
-          </a:xfrm>
-          <a:prstGeom prst="rect">
-            <a:avLst/>
-          </a:prstGeom>
-        </p:spPr>
-        <p:txBody>
-          <a:bodyPr vert="horz" lIns="91440" tIns="45720" rIns="91440" bIns="45720" rtlCol="0" anchor="b"/>
-          <a:lstStyle>
-            <a:lvl1pPr algn="l">
-              <a:defRPr sz="1200"/>
-            </a:lvl1pPr>
-          </a:lstStyle>
-          <a:p>
-            <a:endParaRPr lang="en-US"/>
-          </a:p>
-        </p:txBody>
-      </p:sp>
-      <p:sp>
-        <p:nvSpPr>
-          <p:cNvPr id="7" name="Slide Number Placeholder 6"/>
-          <p:cNvSpPr>
-            <a:spLocks noGrp="1"/>
-          </p:cNvSpPr>
-          <p:nvPr>
-            <p:ph type="sldNum" sz="quarter" idx="5"/>
-          </p:nvPr>
-        </p:nvSpPr>
-        <p:spPr>
-          <a:xfrm>
-            <a:off x="3884613" y="8685213"/>
-            <a:ext cx="2971800" cy="458787"/>
-          </a:xfrm>
-          <a:prstGeom prst="rect">
-            <a:avLst/>
-          </a:prstGeom>
-        </p:spPr>
-        <p:txBody>
-          <a:bodyPr vert="horz" lIns="91440" tIns="45720" rIns="91440" bIns="45720" rtlCol="0" anchor="b"/>
-          <a:lstStyle>
-            <a:lvl1pPr algn="r">
-              <a:defRPr sz="1200"/>
-            </a:lvl1pPr>
-          </a:lstStyle>
-          <a:p>
-            <a:fld id="{CE5E9CC1-C706-0F49-92D6-E571CC5EEA8F}" type="slidenum">
-              <a:rPr lang="en-US"/>
-              <a:t>‹#›</a:t>
-            </a:fld>
-            <a:endParaRPr lang="en-US"/>
-          </a:p>
-        </p:txBody>
-      </p:sp>
     </p:spTree>
     <p:extLst>
       <p:ext uri="{BB962C8B-B14F-4D97-AF65-F5344CB8AC3E}">
-        <p14:creationId xmlns:p14="http://schemas.microsoft.com/office/powerpoint/2010/main" val="1024086991"/>
+        <p14:creationId xmlns:p14="http://schemas.microsoft.com/office/powerpoint/2010/main" val="2599231122"/>
       </p:ext>
     </p:extLst>
   </p:cSld>
@@ -1231,10 +1047,6 @@
           <a:bodyPr/>
           <a:lstStyle/>
           <a:p>
-            <a:r>
-              <a:rPr lang="en-US" dirty="0"/>
-              <a:t/>
-            </a:r>
             <a:endParaRPr lang="en-US" dirty="0"/>
           </a:p>
         </p:txBody>
@@ -1319,10 +1131,6 @@
           <a:bodyPr/>
           <a:lstStyle/>
           <a:p>
-            <a:r>
-              <a:rPr lang="en-US" dirty="0"/>
-              <a:t/>
-            </a:r>
             <a:endParaRPr lang="en-US" dirty="0"/>
           </a:p>
         </p:txBody>
@@ -1407,10 +1215,6 @@
           <a:bodyPr/>
           <a:lstStyle/>
           <a:p>
-            <a:r>
-              <a:rPr lang="en-US" dirty="0"/>
-              <a:t/>
-            </a:r>
             <a:endParaRPr lang="en-US" dirty="0"/>
           </a:p>
         </p:txBody>
@@ -1495,10 +1299,6 @@
           <a:bodyPr/>
           <a:lstStyle/>
           <a:p>
-            <a:r>
-              <a:rPr lang="en-US" dirty="0"/>
-              <a:t/>
-            </a:r>
             <a:endParaRPr lang="en-US" dirty="0"/>
           </a:p>
         </p:txBody>
@@ -1583,10 +1383,6 @@
           <a:bodyPr/>
           <a:lstStyle/>
           <a:p>
-            <a:r>
-              <a:rPr lang="en-US" dirty="0"/>
-              <a:t/>
-            </a:r>
             <a:endParaRPr lang="en-US" dirty="0"/>
           </a:p>
         </p:txBody>
@@ -1671,10 +1467,6 @@
           <a:bodyPr/>
           <a:lstStyle/>
           <a:p>
-            <a:r>
-              <a:rPr lang="en-US" dirty="0"/>
-              <a:t/>
-            </a:r>
             <a:endParaRPr lang="en-US" dirty="0"/>
           </a:p>
         </p:txBody>
@@ -1759,10 +1551,6 @@
           <a:bodyPr/>
           <a:lstStyle/>
           <a:p>
-            <a:r>
-              <a:rPr lang="en-US" dirty="0"/>
-              <a:t/>
-            </a:r>
             <a:endParaRPr lang="en-US" dirty="0"/>
           </a:p>
         </p:txBody>
@@ -1847,10 +1635,6 @@
           <a:bodyPr/>
           <a:lstStyle/>
           <a:p>
-            <a:r>
-              <a:rPr lang="en-US" dirty="0"/>
-              <a:t/>
-            </a:r>
             <a:endParaRPr lang="en-US" dirty="0"/>
           </a:p>
         </p:txBody>
@@ -1935,10 +1719,6 @@
           <a:bodyPr/>
           <a:lstStyle/>
           <a:p>
-            <a:r>
-              <a:rPr lang="en-US" dirty="0"/>
-              <a:t/>
-            </a:r>
             <a:endParaRPr lang="en-US" dirty="0"/>
           </a:p>
         </p:txBody>
@@ -2023,10 +1803,6 @@
           <a:bodyPr/>
           <a:lstStyle/>
           <a:p>
-            <a:r>
-              <a:rPr lang="en-US" dirty="0"/>
-              <a:t/>
-            </a:r>
             <a:endParaRPr lang="en-US" dirty="0"/>
           </a:p>
         </p:txBody>
@@ -2111,10 +1887,6 @@
           <a:bodyPr/>
           <a:lstStyle/>
           <a:p>
-            <a:r>
-              <a:rPr lang="en-US" dirty="0"/>
-              <a:t/>
-            </a:r>
             <a:endParaRPr lang="en-US" dirty="0"/>
           </a:p>
         </p:txBody>
@@ -2199,10 +1971,6 @@
           <a:bodyPr/>
           <a:lstStyle/>
           <a:p>
-            <a:r>
-              <a:rPr lang="en-US" dirty="0"/>
-              <a:t/>
-            </a:r>
             <a:endParaRPr lang="en-US" dirty="0"/>
           </a:p>
         </p:txBody>
@@ -2287,10 +2055,6 @@
           <a:bodyPr/>
           <a:lstStyle/>
           <a:p>
-            <a:r>
-              <a:rPr lang="en-US" dirty="0"/>
-              <a:t/>
-            </a:r>
             <a:endParaRPr lang="en-US" dirty="0"/>
           </a:p>
         </p:txBody>
@@ -2375,10 +2139,6 @@
           <a:bodyPr/>
           <a:lstStyle/>
           <a:p>
-            <a:r>
-              <a:rPr lang="en-US" dirty="0"/>
-              <a:t/>
-            </a:r>
             <a:endParaRPr lang="en-US" dirty="0"/>
           </a:p>
         </p:txBody>
@@ -2463,10 +2223,6 @@
           <a:bodyPr/>
           <a:lstStyle/>
           <a:p>
-            <a:r>
-              <a:rPr lang="en-US" dirty="0"/>
-              <a:t/>
-            </a:r>
             <a:endParaRPr lang="en-US" dirty="0"/>
           </a:p>
         </p:txBody>
@@ -2551,10 +2307,6 @@
           <a:bodyPr/>
           <a:lstStyle/>
           <a:p>
-            <a:r>
-              <a:rPr lang="en-US" dirty="0"/>
-              <a:t/>
-            </a:r>
             <a:endParaRPr lang="en-US" dirty="0"/>
           </a:p>
         </p:txBody>
@@ -2639,10 +2391,6 @@
           <a:bodyPr/>
           <a:lstStyle/>
           <a:p>
-            <a:r>
-              <a:rPr lang="en-US" dirty="0"/>
-              <a:t/>
-            </a:r>
             <a:endParaRPr lang="en-US" dirty="0"/>
           </a:p>
         </p:txBody>
@@ -2716,6 +2464,11 @@
 <file path=ppt/slideMasters/slideMaster1.xml><?xml version="1.0" encoding="utf-8"?>
 <p:sldMaster xmlns:a="http://schemas.openxmlformats.org/drawingml/2006/main" xmlns:r="http://schemas.openxmlformats.org/officeDocument/2006/relationships" xmlns:p="http://schemas.openxmlformats.org/presentationml/2006/main">
   <p:cSld>
+    <p:bg>
+      <p:bgRef idx="1001">
+        <a:schemeClr val="bg1"/>
+      </p:bgRef>
+    </p:bg>
     <p:spTree>
       <p:nvGrpSpPr>
         <p:cNvPr id="1" name=""/>
@@ -2998,6 +2751,7 @@
         <a:solidFill>
           <a:srgbClr val="17212B"/>
         </a:solidFill>
+        <a:effectLst/>
       </p:bgPr>
     </p:bg>
     <p:spTree>
@@ -3035,11 +2789,11 @@
           <a:bodyPr wrap="square" rtlCol="0" anchor="ctr"/>
           <a:lstStyle/>
           <a:p>
-            <a:pPr indent="0" marL="0">
-              <a:buNone/>
-            </a:pPr>
-            <a:r>
-              <a:rPr lang="en-US" sz="1300" b="1" spc="200" kern="0" dirty="0">
+            <a:pPr marL="0" indent="0">
+              <a:buNone/>
+            </a:pPr>
+            <a:r>
+              <a:rPr lang="en-US" sz="1300" b="1" kern="0" spc="200" dirty="0">
                 <a:solidFill>
                   <a:srgbClr val="2B6E62"/>
                 </a:solidFill>
@@ -3074,7 +2828,7 @@
           <a:bodyPr wrap="square" rtlCol="0" anchor="ctr"/>
           <a:lstStyle/>
           <a:p>
-            <a:pPr indent="0" marL="0">
+            <a:pPr marL="0" indent="0">
               <a:buNone/>
             </a:pPr>
             <a:r>
@@ -3113,7 +2867,7 @@
           <a:bodyPr wrap="square" rtlCol="0" anchor="ctr"/>
           <a:lstStyle/>
           <a:p>
-            <a:pPr indent="0" marL="0">
+            <a:pPr marL="0" indent="0">
               <a:lnSpc>
                 <a:spcPts val="2600"/>
               </a:lnSpc>
@@ -3133,7 +2887,7 @@
             <a:endParaRPr lang="en-US" sz="1900" dirty="0"/>
           </a:p>
           <a:p>
-            <a:pPr indent="0" marL="0">
+            <a:pPr marL="0" indent="0">
               <a:lnSpc>
                 <a:spcPts val="2600"/>
               </a:lnSpc>
@@ -3198,7 +2952,7 @@
           <a:bodyPr wrap="square" rtlCol="0" anchor="ctr"/>
           <a:lstStyle/>
           <a:p>
-            <a:pPr indent="0" marL="0">
+            <a:pPr marL="0" indent="0">
               <a:buNone/>
             </a:pPr>
             <a:r>
@@ -3210,7 +2964,29 @@
                 <a:ea typeface="Calibri" pitchFamily="34" charset="-122"/>
                 <a:cs typeface="Calibri" pitchFamily="34" charset="-120"/>
               </a:rPr>
-              <a:t>Nguyễn Đình Đán  •  Nguyễn Văn Vũ  •  Triệu Việt Hoa  •  Hoàng Xuân Sơn  •  Nguyễn Thái Thịnh</a:t>
+              <a:t>Nguyễn Đình Đán  •  Nguyễn Văn Vũ  •  </a:t>
+            </a:r>
+            <a:r>
+              <a:rPr lang="en-US" sz="1500" b="1" dirty="0" err="1">
+                <a:solidFill>
+                  <a:srgbClr val="FFFFFF"/>
+                </a:solidFill>
+                <a:latin typeface="Calibri" pitchFamily="34" charset="0"/>
+                <a:ea typeface="Calibri" pitchFamily="34" charset="-122"/>
+                <a:cs typeface="Calibri" pitchFamily="34" charset="-120"/>
+              </a:rPr>
+              <a:t>Trần</a:t>
+            </a:r>
+            <a:r>
+              <a:rPr lang="en-US" sz="1500" b="1" dirty="0">
+                <a:solidFill>
+                  <a:srgbClr val="FFFFFF"/>
+                </a:solidFill>
+                <a:latin typeface="Calibri" pitchFamily="34" charset="0"/>
+                <a:ea typeface="Calibri" pitchFamily="34" charset="-122"/>
+                <a:cs typeface="Calibri" pitchFamily="34" charset="-120"/>
+              </a:rPr>
+              <a:t> Việt Hoa  •  Hoàng Xuân Sơn  •  Nguyễn Thái Thịnh</a:t>
             </a:r>
             <a:endParaRPr lang="en-US" sz="1500" dirty="0"/>
           </a:p>
@@ -3237,7 +3013,7 @@
           <a:bodyPr wrap="square" rtlCol="0" anchor="ctr"/>
           <a:lstStyle/>
           <a:p>
-            <a:pPr indent="0" marL="0">
+            <a:pPr marL="0" indent="0">
               <a:buNone/>
             </a:pPr>
             <a:r>
@@ -3271,6 +3047,7 @@
         <a:solidFill>
           <a:srgbClr val="17212B"/>
         </a:solidFill>
+        <a:effectLst/>
       </p:bgPr>
     </p:bg>
     <p:spTree>
@@ -3308,11 +3085,11 @@
           <a:bodyPr wrap="square" rtlCol="0" anchor="ctr"/>
           <a:lstStyle/>
           <a:p>
-            <a:pPr indent="0" marL="0">
-              <a:buNone/>
-            </a:pPr>
-            <a:r>
-              <a:rPr lang="en-US" sz="1200" b="1" spc="200" kern="0" dirty="0">
+            <a:pPr marL="0" indent="0">
+              <a:buNone/>
+            </a:pPr>
+            <a:r>
+              <a:rPr lang="en-US" sz="1200" b="1" kern="0" spc="200" dirty="0">
                 <a:solidFill>
                   <a:srgbClr val="B8863B"/>
                 </a:solidFill>
@@ -3347,7 +3124,7 @@
           <a:bodyPr wrap="square" rtlCol="0" anchor="ctr"/>
           <a:lstStyle/>
           <a:p>
-            <a:pPr algn="l" indent="0" marL="0">
+            <a:pPr marL="0" indent="0" algn="l">
               <a:buNone/>
             </a:pPr>
             <a:r>
@@ -3408,7 +3185,7 @@
           <a:bodyPr wrap="square" rtlCol="0" anchor="ctr"/>
           <a:lstStyle/>
           <a:p>
-            <a:pPr indent="0" marL="0">
+            <a:pPr marL="0" indent="0">
               <a:lnSpc>
                 <a:spcPts val="1800"/>
               </a:lnSpc>
@@ -3450,7 +3227,7 @@
           <a:bodyPr wrap="square" rtlCol="0" anchor="ctr"/>
           <a:lstStyle/>
           <a:p>
-            <a:pPr indent="0" marL="0">
+            <a:pPr marL="0" indent="0">
               <a:lnSpc>
                 <a:spcPts val="1700"/>
               </a:lnSpc>
@@ -3514,7 +3291,7 @@
           <a:bodyPr wrap="square" rtlCol="0" anchor="ctr"/>
           <a:lstStyle/>
           <a:p>
-            <a:pPr indent="0" marL="0">
+            <a:pPr marL="0" indent="0">
               <a:lnSpc>
                 <a:spcPts val="1800"/>
               </a:lnSpc>
@@ -3556,7 +3333,7 @@
           <a:bodyPr wrap="square" rtlCol="0" anchor="ctr"/>
           <a:lstStyle/>
           <a:p>
-            <a:pPr indent="0" marL="0">
+            <a:pPr marL="0" indent="0">
               <a:lnSpc>
                 <a:spcPts val="1700"/>
               </a:lnSpc>
@@ -3620,7 +3397,7 @@
           <a:bodyPr wrap="square" rtlCol="0" anchor="ctr"/>
           <a:lstStyle/>
           <a:p>
-            <a:pPr indent="0" marL="0">
+            <a:pPr marL="0" indent="0">
               <a:lnSpc>
                 <a:spcPts val="1800"/>
               </a:lnSpc>
@@ -3662,7 +3439,7 @@
           <a:bodyPr wrap="square" rtlCol="0" anchor="ctr"/>
           <a:lstStyle/>
           <a:p>
-            <a:pPr indent="0" marL="0">
+            <a:pPr marL="0" indent="0">
               <a:lnSpc>
                 <a:spcPts val="1700"/>
               </a:lnSpc>
@@ -3704,7 +3481,7 @@
           <a:bodyPr wrap="square" rtlCol="0" anchor="ctr"/>
           <a:lstStyle/>
           <a:p>
-            <a:pPr indent="0" marL="0">
+            <a:pPr marL="0" indent="0">
               <a:buNone/>
             </a:pPr>
             <a:r>
@@ -3743,7 +3520,7 @@
           <a:bodyPr wrap="square" rtlCol="0" anchor="ctr"/>
           <a:lstStyle/>
           <a:p>
-            <a:pPr algn="r" indent="0" marL="0">
+            <a:pPr marL="0" indent="0" algn="r">
               <a:buNone/>
             </a:pPr>
             <a:r>
@@ -3777,6 +3554,7 @@
         <a:solidFill>
           <a:srgbClr val="F2F0E9"/>
         </a:solidFill>
+        <a:effectLst/>
       </p:bgPr>
     </p:bg>
     <p:spTree>
@@ -3814,11 +3592,11 @@
           <a:bodyPr wrap="square" rtlCol="0" anchor="ctr"/>
           <a:lstStyle/>
           <a:p>
-            <a:pPr indent="0" marL="0">
-              <a:buNone/>
-            </a:pPr>
-            <a:r>
-              <a:rPr lang="en-US" sz="1200" b="1" spc="200" kern="0" dirty="0">
+            <a:pPr marL="0" indent="0">
+              <a:buNone/>
+            </a:pPr>
+            <a:r>
+              <a:rPr lang="en-US" sz="1200" b="1" kern="0" spc="200" dirty="0">
                 <a:solidFill>
                   <a:srgbClr val="2B6E62"/>
                 </a:solidFill>
@@ -3853,7 +3631,7 @@
           <a:bodyPr wrap="square" rtlCol="0" anchor="ctr"/>
           <a:lstStyle/>
           <a:p>
-            <a:pPr algn="l" indent="0" marL="0">
+            <a:pPr marL="0" indent="0" algn="l">
               <a:buNone/>
             </a:pPr>
             <a:r>
@@ -3873,7 +3651,7 @@
       </p:sp>
       <p:graphicFrame>
         <p:nvGraphicFramePr>
-          <p:cNvPr id="4" name="Chart 0" descr=""/>
+          <p:cNvPr id="4" name="Chart 0"/>
           <p:cNvGraphicFramePr/>
           <p:nvPr/>
         </p:nvGraphicFramePr>
@@ -3881,9 +3659,9 @@
           <a:off x="548640" y="2148840"/>
           <a:ext cx="11064240" cy="3931920"/>
         </p:xfrm>
-        <a:graphic xmlns:a="http://schemas.openxmlformats.org/drawingml/2006/main">
+        <a:graphic>
           <a:graphicData uri="http://schemas.openxmlformats.org/drawingml/2006/chart">
-            <c:chart xmlns:c="http://schemas.openxmlformats.org/drawingml/2006/chart" r:id="rId1"/>
+            <c:chart xmlns:c="http://schemas.openxmlformats.org/drawingml/2006/chart" xmlns:r="http://schemas.openxmlformats.org/officeDocument/2006/relationships" r:id="rId3"/>
           </a:graphicData>
         </a:graphic>
       </p:graphicFrame>
@@ -3908,7 +3686,7 @@
           <a:bodyPr wrap="square" rtlCol="0" anchor="ctr"/>
           <a:lstStyle/>
           <a:p>
-            <a:pPr algn="ctr" indent="0" marL="0">
+            <a:pPr marL="0" indent="0" algn="ctr">
               <a:buNone/>
             </a:pPr>
             <a:r>
@@ -3947,7 +3725,7 @@
           <a:bodyPr wrap="square" rtlCol="0" anchor="ctr"/>
           <a:lstStyle/>
           <a:p>
-            <a:pPr algn="r" indent="0" marL="0">
+            <a:pPr marL="0" indent="0" algn="r">
               <a:buNone/>
             </a:pPr>
             <a:r>
@@ -3981,6 +3759,7 @@
         <a:solidFill>
           <a:srgbClr val="F2F0E9"/>
         </a:solidFill>
+        <a:effectLst/>
       </p:bgPr>
     </p:bg>
     <p:spTree>
@@ -4018,11 +3797,11 @@
           <a:bodyPr wrap="square" rtlCol="0" anchor="ctr"/>
           <a:lstStyle/>
           <a:p>
-            <a:pPr indent="0" marL="0">
-              <a:buNone/>
-            </a:pPr>
-            <a:r>
-              <a:rPr lang="en-US" sz="1200" b="1" spc="200" kern="0" dirty="0">
+            <a:pPr marL="0" indent="0">
+              <a:buNone/>
+            </a:pPr>
+            <a:r>
+              <a:rPr lang="en-US" sz="1200" b="1" kern="0" spc="200" dirty="0">
                 <a:solidFill>
                   <a:srgbClr val="2B6E62"/>
                 </a:solidFill>
@@ -4057,7 +3836,7 @@
           <a:bodyPr wrap="square" rtlCol="0" anchor="ctr"/>
           <a:lstStyle/>
           <a:p>
-            <a:pPr algn="l" indent="0" marL="0">
+            <a:pPr marL="0" indent="0" algn="l">
               <a:buNone/>
             </a:pPr>
             <a:r>
@@ -4096,7 +3875,7 @@
           </a:solidFill>
           <a:ln/>
           <a:effectLst>
-            <a:outerShdw sx="100000" sy="100000" kx="0" ky="0" algn="bl" rotWithShape="0" blurRad="76200" dist="25400" dir="5400000">
+            <a:outerShdw blurRad="76200" dist="25400" dir="5400000" algn="bl" rotWithShape="0">
               <a:srgbClr val="000000">
                 <a:alpha val="12000"/>
               </a:srgbClr>
@@ -4145,7 +3924,7 @@
           <a:bodyPr wrap="square" rtlCol="0" anchor="ctr"/>
           <a:lstStyle/>
           <a:p>
-            <a:pPr algn="ctr" indent="0" marL="0">
+            <a:pPr marL="0" indent="0" algn="ctr">
               <a:buNone/>
             </a:pPr>
             <a:r>
@@ -4184,7 +3963,7 @@
           <a:bodyPr wrap="square" rtlCol="0" anchor="ctr"/>
           <a:lstStyle/>
           <a:p>
-            <a:pPr indent="0" marL="0">
+            <a:pPr marL="0" indent="0">
               <a:buNone/>
             </a:pPr>
             <a:r>
@@ -4223,7 +4002,7 @@
           <a:bodyPr wrap="square" rtlCol="0" anchor="ctr"/>
           <a:lstStyle/>
           <a:p>
-            <a:pPr indent="0" marL="0">
+            <a:pPr marL="0" indent="0">
               <a:lnSpc>
                 <a:spcPts val="1400"/>
               </a:lnSpc>
@@ -4265,7 +4044,7 @@
           <a:bodyPr wrap="square" rtlCol="0" anchor="ctr"/>
           <a:lstStyle/>
           <a:p>
-            <a:pPr algn="ctr" indent="0" marL="0">
+            <a:pPr marL="0" indent="0" algn="ctr">
               <a:lnSpc>
                 <a:spcPts val="1500"/>
               </a:lnSpc>
@@ -4285,7 +4064,7 @@
             <a:endParaRPr lang="en-US" sz="1200" dirty="0"/>
           </a:p>
           <a:p>
-            <a:pPr algn="ctr" indent="0" marL="0">
+            <a:pPr marL="0" indent="0" algn="ctr">
               <a:lnSpc>
                 <a:spcPts val="1500"/>
               </a:lnSpc>
@@ -4327,7 +4106,7 @@
           </a:solidFill>
           <a:ln/>
           <a:effectLst>
-            <a:outerShdw sx="100000" sy="100000" kx="0" ky="0" algn="bl" rotWithShape="0" blurRad="76200" dist="25400" dir="5400000">
+            <a:outerShdw blurRad="76200" dist="25400" dir="5400000" algn="bl" rotWithShape="0">
               <a:srgbClr val="000000">
                 <a:alpha val="12000"/>
               </a:srgbClr>
@@ -4376,7 +4155,7 @@
           <a:bodyPr wrap="square" rtlCol="0" anchor="ctr"/>
           <a:lstStyle/>
           <a:p>
-            <a:pPr algn="ctr" indent="0" marL="0">
+            <a:pPr marL="0" indent="0" algn="ctr">
               <a:buNone/>
             </a:pPr>
             <a:r>
@@ -4415,7 +4194,7 @@
           <a:bodyPr wrap="square" rtlCol="0" anchor="ctr"/>
           <a:lstStyle/>
           <a:p>
-            <a:pPr indent="0" marL="0">
+            <a:pPr marL="0" indent="0">
               <a:buNone/>
             </a:pPr>
             <a:r>
@@ -4454,7 +4233,7 @@
           <a:bodyPr wrap="square" rtlCol="0" anchor="ctr"/>
           <a:lstStyle/>
           <a:p>
-            <a:pPr indent="0" marL="0">
+            <a:pPr marL="0" indent="0">
               <a:lnSpc>
                 <a:spcPts val="1400"/>
               </a:lnSpc>
@@ -4496,7 +4275,7 @@
           <a:bodyPr wrap="square" rtlCol="0" anchor="ctr"/>
           <a:lstStyle/>
           <a:p>
-            <a:pPr algn="ctr" indent="0" marL="0">
+            <a:pPr marL="0" indent="0" algn="ctr">
               <a:lnSpc>
                 <a:spcPts val="1500"/>
               </a:lnSpc>
@@ -4516,7 +4295,7 @@
             <a:endParaRPr lang="en-US" sz="1200" dirty="0"/>
           </a:p>
           <a:p>
-            <a:pPr algn="ctr" indent="0" marL="0">
+            <a:pPr marL="0" indent="0" algn="ctr">
               <a:lnSpc>
                 <a:spcPts val="1500"/>
               </a:lnSpc>
@@ -4558,7 +4337,7 @@
           </a:solidFill>
           <a:ln/>
           <a:effectLst>
-            <a:outerShdw sx="100000" sy="100000" kx="0" ky="0" algn="bl" rotWithShape="0" blurRad="76200" dist="25400" dir="5400000">
+            <a:outerShdw blurRad="76200" dist="25400" dir="5400000" algn="bl" rotWithShape="0">
               <a:srgbClr val="000000">
                 <a:alpha val="12000"/>
               </a:srgbClr>
@@ -4607,7 +4386,7 @@
           <a:bodyPr wrap="square" rtlCol="0" anchor="ctr"/>
           <a:lstStyle/>
           <a:p>
-            <a:pPr algn="ctr" indent="0" marL="0">
+            <a:pPr marL="0" indent="0" algn="ctr">
               <a:buNone/>
             </a:pPr>
             <a:r>
@@ -4646,7 +4425,7 @@
           <a:bodyPr wrap="square" rtlCol="0" anchor="ctr"/>
           <a:lstStyle/>
           <a:p>
-            <a:pPr indent="0" marL="0">
+            <a:pPr marL="0" indent="0">
               <a:buNone/>
             </a:pPr>
             <a:r>
@@ -4685,7 +4464,7 @@
           <a:bodyPr wrap="square" rtlCol="0" anchor="ctr"/>
           <a:lstStyle/>
           <a:p>
-            <a:pPr indent="0" marL="0">
+            <a:pPr marL="0" indent="0">
               <a:lnSpc>
                 <a:spcPts val="1400"/>
               </a:lnSpc>
@@ -4727,7 +4506,7 @@
           <a:bodyPr wrap="square" rtlCol="0" anchor="ctr"/>
           <a:lstStyle/>
           <a:p>
-            <a:pPr algn="ctr" indent="0" marL="0">
+            <a:pPr marL="0" indent="0" algn="ctr">
               <a:lnSpc>
                 <a:spcPts val="1500"/>
               </a:lnSpc>
@@ -4747,7 +4526,7 @@
             <a:endParaRPr lang="en-US" sz="1200" dirty="0"/>
           </a:p>
           <a:p>
-            <a:pPr algn="ctr" indent="0" marL="0">
+            <a:pPr marL="0" indent="0" algn="ctr">
               <a:lnSpc>
                 <a:spcPts val="1500"/>
               </a:lnSpc>
@@ -4789,7 +4568,7 @@
           <a:bodyPr wrap="square" rtlCol="0" anchor="ctr"/>
           <a:lstStyle/>
           <a:p>
-            <a:pPr algn="ctr" indent="0" marL="0">
+            <a:pPr marL="0" indent="0" algn="ctr">
               <a:buNone/>
             </a:pPr>
             <a:r>
@@ -4828,7 +4607,7 @@
           <a:bodyPr wrap="square" rtlCol="0" anchor="ctr"/>
           <a:lstStyle/>
           <a:p>
-            <a:pPr algn="r" indent="0" marL="0">
+            <a:pPr marL="0" indent="0" algn="r">
               <a:buNone/>
             </a:pPr>
             <a:r>
@@ -4862,6 +4641,7 @@
         <a:solidFill>
           <a:srgbClr val="17212B"/>
         </a:solidFill>
+        <a:effectLst/>
       </p:bgPr>
     </p:bg>
     <p:spTree>
@@ -4899,11 +4679,11 @@
           <a:bodyPr wrap="square" rtlCol="0" anchor="ctr"/>
           <a:lstStyle/>
           <a:p>
-            <a:pPr indent="0" marL="0">
-              <a:buNone/>
-            </a:pPr>
-            <a:r>
-              <a:rPr lang="en-US" sz="1200" b="1" spc="200" kern="0" dirty="0">
+            <a:pPr marL="0" indent="0">
+              <a:buNone/>
+            </a:pPr>
+            <a:r>
+              <a:rPr lang="en-US" sz="1200" b="1" kern="0" spc="200" dirty="0">
                 <a:solidFill>
                   <a:srgbClr val="B8863B"/>
                 </a:solidFill>
@@ -4938,7 +4718,7 @@
           <a:bodyPr wrap="square" rtlCol="0" anchor="ctr"/>
           <a:lstStyle/>
           <a:p>
-            <a:pPr algn="l" indent="0" marL="0">
+            <a:pPr marL="0" indent="0" algn="l">
               <a:buNone/>
             </a:pPr>
             <a:r>
@@ -4977,7 +4757,7 @@
           </a:solidFill>
           <a:ln/>
           <a:effectLst>
-            <a:outerShdw sx="100000" sy="100000" kx="0" ky="0" algn="bl" rotWithShape="0" blurRad="76200" dist="25400" dir="5400000">
+            <a:outerShdw blurRad="76200" dist="25400" dir="5400000" algn="bl" rotWithShape="0">
               <a:srgbClr val="000000">
                 <a:alpha val="12000"/>
               </a:srgbClr>
@@ -5006,11 +4786,11 @@
           <a:bodyPr wrap="square" rtlCol="0" anchor="ctr"/>
           <a:lstStyle/>
           <a:p>
-            <a:pPr indent="0" marL="0">
-              <a:buNone/>
-            </a:pPr>
-            <a:r>
-              <a:rPr lang="en-US" sz="1300" b="1" spc="150" kern="0" dirty="0">
+            <a:pPr marL="0" indent="0">
+              <a:buNone/>
+            </a:pPr>
+            <a:r>
+              <a:rPr lang="en-US" sz="1300" b="1" kern="0" spc="150" dirty="0">
                 <a:solidFill>
                   <a:srgbClr val="2B6E62"/>
                 </a:solidFill>
@@ -5045,7 +4825,7 @@
           <a:bodyPr wrap="square" rtlCol="0" anchor="ctr"/>
           <a:lstStyle/>
           <a:p>
-            <a:pPr algn="l" indent="0" marL="0">
+            <a:pPr marL="0" indent="0" algn="l">
               <a:buNone/>
             </a:pPr>
             <a:r>
@@ -5104,7 +4884,7 @@
           <a:bodyPr wrap="square" rtlCol="0" anchor="ctr"/>
           <a:lstStyle/>
           <a:p>
-            <a:pPr algn="l" indent="0" marL="0">
+            <a:pPr marL="0" indent="0" algn="l">
               <a:buNone/>
             </a:pPr>
             <a:r>
@@ -5143,7 +4923,7 @@
           <a:bodyPr wrap="square" rtlCol="0" anchor="ctr"/>
           <a:lstStyle/>
           <a:p>
-            <a:pPr indent="0" marL="0">
+            <a:pPr marL="0" indent="0">
               <a:buNone/>
             </a:pPr>
             <a:r>
@@ -5182,7 +4962,7 @@
           </a:solidFill>
           <a:ln/>
           <a:effectLst>
-            <a:outerShdw sx="100000" sy="100000" kx="0" ky="0" algn="bl" rotWithShape="0" blurRad="76200" dist="25400" dir="5400000">
+            <a:outerShdw blurRad="76200" dist="25400" dir="5400000" algn="bl" rotWithShape="0">
               <a:srgbClr val="000000">
                 <a:alpha val="12000"/>
               </a:srgbClr>
@@ -5211,11 +4991,11 @@
           <a:bodyPr wrap="square" rtlCol="0" anchor="ctr"/>
           <a:lstStyle/>
           <a:p>
-            <a:pPr indent="0" marL="0">
-              <a:buNone/>
-            </a:pPr>
-            <a:r>
-              <a:rPr lang="en-US" sz="1300" b="1" spc="150" kern="0" dirty="0">
+            <a:pPr marL="0" indent="0">
+              <a:buNone/>
+            </a:pPr>
+            <a:r>
+              <a:rPr lang="en-US" sz="1300" b="1" kern="0" spc="150" dirty="0">
                 <a:solidFill>
                   <a:srgbClr val="2B6E62"/>
                 </a:solidFill>
@@ -5250,7 +5030,7 @@
           <a:bodyPr wrap="square" rtlCol="0" anchor="ctr"/>
           <a:lstStyle/>
           <a:p>
-            <a:pPr algn="l" indent="0" marL="0">
+            <a:pPr marL="0" indent="0" algn="l">
               <a:buNone/>
             </a:pPr>
             <a:r>
@@ -5309,7 +5089,7 @@
           <a:bodyPr wrap="square" rtlCol="0" anchor="ctr"/>
           <a:lstStyle/>
           <a:p>
-            <a:pPr algn="l" indent="0" marL="0">
+            <a:pPr marL="0" indent="0" algn="l">
               <a:buNone/>
             </a:pPr>
             <a:r>
@@ -5348,7 +5128,7 @@
           <a:bodyPr wrap="square" rtlCol="0" anchor="ctr"/>
           <a:lstStyle/>
           <a:p>
-            <a:pPr indent="0" marL="0">
+            <a:pPr marL="0" indent="0">
               <a:buNone/>
             </a:pPr>
             <a:r>
@@ -5387,7 +5167,7 @@
           <a:bodyPr wrap="square" rtlCol="0" anchor="ctr"/>
           <a:lstStyle/>
           <a:p>
-            <a:pPr indent="0" marL="0">
+            <a:pPr marL="0" indent="0">
               <a:buNone/>
             </a:pPr>
             <a:r>
@@ -5426,7 +5206,7 @@
           <a:bodyPr wrap="square" rtlCol="0" anchor="ctr"/>
           <a:lstStyle/>
           <a:p>
-            <a:pPr algn="r" indent="0" marL="0">
+            <a:pPr marL="0" indent="0" algn="r">
               <a:buNone/>
             </a:pPr>
             <a:r>
@@ -5460,6 +5240,7 @@
         <a:solidFill>
           <a:srgbClr val="F2F0E9"/>
         </a:solidFill>
+        <a:effectLst/>
       </p:bgPr>
     </p:bg>
     <p:spTree>
@@ -5497,11 +5278,11 @@
           <a:bodyPr wrap="square" rtlCol="0" anchor="ctr"/>
           <a:lstStyle/>
           <a:p>
-            <a:pPr indent="0" marL="0">
-              <a:buNone/>
-            </a:pPr>
-            <a:r>
-              <a:rPr lang="en-US" sz="1200" b="1" spc="200" kern="0" dirty="0">
+            <a:pPr marL="0" indent="0">
+              <a:buNone/>
+            </a:pPr>
+            <a:r>
+              <a:rPr lang="en-US" sz="1200" b="1" kern="0" spc="200" dirty="0">
                 <a:solidFill>
                   <a:srgbClr val="2B6E62"/>
                 </a:solidFill>
@@ -5536,7 +5317,7 @@
           <a:bodyPr wrap="square" rtlCol="0" anchor="ctr"/>
           <a:lstStyle/>
           <a:p>
-            <a:pPr algn="l" indent="0" marL="0">
+            <a:pPr marL="0" indent="0" algn="l">
               <a:buNone/>
             </a:pPr>
             <a:r>
@@ -5575,7 +5356,7 @@
           <a:bodyPr wrap="square" rtlCol="0" anchor="ctr"/>
           <a:lstStyle/>
           <a:p>
-            <a:pPr indent="0" marL="0">
+            <a:pPr marL="0" indent="0">
               <a:buNone/>
             </a:pPr>
             <a:r>
@@ -5656,7 +5437,7 @@
           <a:bodyPr wrap="square" rtlCol="0" anchor="ctr"/>
           <a:lstStyle/>
           <a:p>
-            <a:pPr algn="ctr" indent="0" marL="0">
+            <a:pPr marL="0" indent="0" algn="ctr">
               <a:buNone/>
             </a:pPr>
             <a:r>
@@ -5695,7 +5476,7 @@
           <a:bodyPr wrap="square" rtlCol="0" anchor="ctr"/>
           <a:lstStyle/>
           <a:p>
-            <a:pPr indent="0" marL="0">
+            <a:pPr marL="0" indent="0">
               <a:lnSpc>
                 <a:spcPts val="1500"/>
               </a:lnSpc>
@@ -5737,11 +5518,11 @@
           <a:bodyPr wrap="square" rtlCol="0" anchor="ctr"/>
           <a:lstStyle/>
           <a:p>
-            <a:pPr indent="0" marL="0">
-              <a:buNone/>
-            </a:pPr>
-            <a:r>
-              <a:rPr lang="en-US" sz="1100" b="1" spc="50" kern="0" dirty="0">
+            <a:pPr marL="0" indent="0">
+              <a:buNone/>
+            </a:pPr>
+            <a:r>
+              <a:rPr lang="en-US" sz="1100" b="1" kern="0" spc="50" dirty="0">
                 <a:solidFill>
                   <a:srgbClr val="2B6E62"/>
                 </a:solidFill>
@@ -5776,7 +5557,7 @@
           <a:bodyPr wrap="square" rtlCol="0" anchor="ctr"/>
           <a:lstStyle/>
           <a:p>
-            <a:pPr indent="0" marL="0">
+            <a:pPr marL="0" indent="0">
               <a:lnSpc>
                 <a:spcPts val="1400"/>
               </a:lnSpc>
@@ -5860,7 +5641,7 @@
           <a:bodyPr wrap="square" rtlCol="0" anchor="ctr"/>
           <a:lstStyle/>
           <a:p>
-            <a:pPr algn="ctr" indent="0" marL="0">
+            <a:pPr marL="0" indent="0" algn="ctr">
               <a:buNone/>
             </a:pPr>
             <a:r>
@@ -5899,7 +5680,7 @@
           <a:bodyPr wrap="square" rtlCol="0" anchor="ctr"/>
           <a:lstStyle/>
           <a:p>
-            <a:pPr indent="0" marL="0">
+            <a:pPr marL="0" indent="0">
               <a:lnSpc>
                 <a:spcPts val="1500"/>
               </a:lnSpc>
@@ -5941,11 +5722,11 @@
           <a:bodyPr wrap="square" rtlCol="0" anchor="ctr"/>
           <a:lstStyle/>
           <a:p>
-            <a:pPr indent="0" marL="0">
-              <a:buNone/>
-            </a:pPr>
-            <a:r>
-              <a:rPr lang="en-US" sz="1100" b="1" spc="50" kern="0" dirty="0">
+            <a:pPr marL="0" indent="0">
+              <a:buNone/>
+            </a:pPr>
+            <a:r>
+              <a:rPr lang="en-US" sz="1100" b="1" kern="0" spc="50" dirty="0">
                 <a:solidFill>
                   <a:srgbClr val="2B6E62"/>
                 </a:solidFill>
@@ -5980,7 +5761,7 @@
           <a:bodyPr wrap="square" rtlCol="0" anchor="ctr"/>
           <a:lstStyle/>
           <a:p>
-            <a:pPr indent="0" marL="0">
+            <a:pPr marL="0" indent="0">
               <a:lnSpc>
                 <a:spcPts val="1400"/>
               </a:lnSpc>
@@ -6064,7 +5845,7 @@
           <a:bodyPr wrap="square" rtlCol="0" anchor="ctr"/>
           <a:lstStyle/>
           <a:p>
-            <a:pPr algn="ctr" indent="0" marL="0">
+            <a:pPr marL="0" indent="0" algn="ctr">
               <a:buNone/>
             </a:pPr>
             <a:r>
@@ -6103,7 +5884,7 @@
           <a:bodyPr wrap="square" rtlCol="0" anchor="ctr"/>
           <a:lstStyle/>
           <a:p>
-            <a:pPr indent="0" marL="0">
+            <a:pPr marL="0" indent="0">
               <a:lnSpc>
                 <a:spcPts val="1500"/>
               </a:lnSpc>
@@ -6145,11 +5926,11 @@
           <a:bodyPr wrap="square" rtlCol="0" anchor="ctr"/>
           <a:lstStyle/>
           <a:p>
-            <a:pPr indent="0" marL="0">
-              <a:buNone/>
-            </a:pPr>
-            <a:r>
-              <a:rPr lang="en-US" sz="1100" b="1" spc="50" kern="0" dirty="0">
+            <a:pPr marL="0" indent="0">
+              <a:buNone/>
+            </a:pPr>
+            <a:r>
+              <a:rPr lang="en-US" sz="1100" b="1" kern="0" spc="50" dirty="0">
                 <a:solidFill>
                   <a:srgbClr val="B8863B"/>
                 </a:solidFill>
@@ -6184,7 +5965,7 @@
           <a:bodyPr wrap="square" rtlCol="0" anchor="ctr"/>
           <a:lstStyle/>
           <a:p>
-            <a:pPr indent="0" marL="0">
+            <a:pPr marL="0" indent="0">
               <a:lnSpc>
                 <a:spcPts val="1400"/>
               </a:lnSpc>
@@ -6268,7 +6049,7 @@
           <a:bodyPr wrap="square" rtlCol="0" anchor="ctr"/>
           <a:lstStyle/>
           <a:p>
-            <a:pPr algn="ctr" indent="0" marL="0">
+            <a:pPr marL="0" indent="0" algn="ctr">
               <a:buNone/>
             </a:pPr>
             <a:r>
@@ -6307,7 +6088,7 @@
           <a:bodyPr wrap="square" rtlCol="0" anchor="ctr"/>
           <a:lstStyle/>
           <a:p>
-            <a:pPr indent="0" marL="0">
+            <a:pPr marL="0" indent="0">
               <a:lnSpc>
                 <a:spcPts val="1500"/>
               </a:lnSpc>
@@ -6349,11 +6130,11 @@
           <a:bodyPr wrap="square" rtlCol="0" anchor="ctr"/>
           <a:lstStyle/>
           <a:p>
-            <a:pPr indent="0" marL="0">
-              <a:buNone/>
-            </a:pPr>
-            <a:r>
-              <a:rPr lang="en-US" sz="1100" b="1" spc="50" kern="0" dirty="0">
+            <a:pPr marL="0" indent="0">
+              <a:buNone/>
+            </a:pPr>
+            <a:r>
+              <a:rPr lang="en-US" sz="1100" b="1" kern="0" spc="50" dirty="0">
                 <a:solidFill>
                   <a:srgbClr val="B8863B"/>
                 </a:solidFill>
@@ -6388,7 +6169,7 @@
           <a:bodyPr wrap="square" rtlCol="0" anchor="ctr"/>
           <a:lstStyle/>
           <a:p>
-            <a:pPr indent="0" marL="0">
+            <a:pPr marL="0" indent="0">
               <a:lnSpc>
                 <a:spcPts val="1400"/>
               </a:lnSpc>
@@ -6472,7 +6253,7 @@
           <a:bodyPr wrap="square" rtlCol="0" anchor="ctr"/>
           <a:lstStyle/>
           <a:p>
-            <a:pPr algn="ctr" indent="0" marL="0">
+            <a:pPr marL="0" indent="0" algn="ctr">
               <a:buNone/>
             </a:pPr>
             <a:r>
@@ -6511,7 +6292,7 @@
           <a:bodyPr wrap="square" rtlCol="0" anchor="ctr"/>
           <a:lstStyle/>
           <a:p>
-            <a:pPr indent="0" marL="0">
+            <a:pPr marL="0" indent="0">
               <a:lnSpc>
                 <a:spcPts val="1500"/>
               </a:lnSpc>
@@ -6553,11 +6334,11 @@
           <a:bodyPr wrap="square" rtlCol="0" anchor="ctr"/>
           <a:lstStyle/>
           <a:p>
-            <a:pPr indent="0" marL="0">
-              <a:buNone/>
-            </a:pPr>
-            <a:r>
-              <a:rPr lang="en-US" sz="1100" b="1" spc="50" kern="0" dirty="0">
+            <a:pPr marL="0" indent="0">
+              <a:buNone/>
+            </a:pPr>
+            <a:r>
+              <a:rPr lang="en-US" sz="1100" b="1" kern="0" spc="50" dirty="0">
                 <a:solidFill>
                   <a:srgbClr val="5B6672"/>
                 </a:solidFill>
@@ -6592,7 +6373,7 @@
           <a:bodyPr wrap="square" rtlCol="0" anchor="ctr"/>
           <a:lstStyle/>
           <a:p>
-            <a:pPr indent="0" marL="0">
+            <a:pPr marL="0" indent="0">
               <a:lnSpc>
                 <a:spcPts val="1400"/>
               </a:lnSpc>
@@ -6634,7 +6415,7 @@
           <a:bodyPr wrap="square" rtlCol="0" anchor="ctr"/>
           <a:lstStyle/>
           <a:p>
-            <a:pPr algn="ctr" indent="0" marL="0">
+            <a:pPr marL="0" indent="0" algn="ctr">
               <a:buNone/>
             </a:pPr>
             <a:r>
@@ -6673,7 +6454,7 @@
           <a:bodyPr wrap="square" rtlCol="0" anchor="ctr"/>
           <a:lstStyle/>
           <a:p>
-            <a:pPr algn="r" indent="0" marL="0">
+            <a:pPr marL="0" indent="0" algn="r">
               <a:buNone/>
             </a:pPr>
             <a:r>
@@ -6707,6 +6488,7 @@
         <a:solidFill>
           <a:srgbClr val="F2F0E9"/>
         </a:solidFill>
+        <a:effectLst/>
       </p:bgPr>
     </p:bg>
     <p:spTree>
@@ -6744,11 +6526,11 @@
           <a:bodyPr wrap="square" rtlCol="0" anchor="ctr"/>
           <a:lstStyle/>
           <a:p>
-            <a:pPr indent="0" marL="0">
-              <a:buNone/>
-            </a:pPr>
-            <a:r>
-              <a:rPr lang="en-US" sz="1200" b="1" spc="200" kern="0" dirty="0">
+            <a:pPr marL="0" indent="0">
+              <a:buNone/>
+            </a:pPr>
+            <a:r>
+              <a:rPr lang="en-US" sz="1200" b="1" kern="0" spc="200" dirty="0">
                 <a:solidFill>
                   <a:srgbClr val="2B6E62"/>
                 </a:solidFill>
@@ -6783,7 +6565,7 @@
           <a:bodyPr wrap="square" rtlCol="0" anchor="ctr"/>
           <a:lstStyle/>
           <a:p>
-            <a:pPr algn="l" indent="0" marL="0">
+            <a:pPr marL="0" indent="0" algn="l">
               <a:buNone/>
             </a:pPr>
             <a:r>
@@ -6864,7 +6646,7 @@
           <a:bodyPr wrap="square" rtlCol="0" anchor="ctr"/>
           <a:lstStyle/>
           <a:p>
-            <a:pPr algn="ctr" indent="0" marL="0">
+            <a:pPr marL="0" indent="0" algn="ctr">
               <a:buNone/>
             </a:pPr>
             <a:r>
@@ -6903,7 +6685,7 @@
           <a:bodyPr wrap="square" rtlCol="0" anchor="ctr"/>
           <a:lstStyle/>
           <a:p>
-            <a:pPr indent="0" marL="0">
+            <a:pPr marL="0" indent="0">
               <a:lnSpc>
                 <a:spcPts val="1400"/>
               </a:lnSpc>
@@ -6987,7 +6769,7 @@
           <a:bodyPr wrap="square" rtlCol="0" anchor="ctr"/>
           <a:lstStyle/>
           <a:p>
-            <a:pPr algn="ctr" indent="0" marL="0">
+            <a:pPr marL="0" indent="0" algn="ctr">
               <a:buNone/>
             </a:pPr>
             <a:r>
@@ -7026,7 +6808,7 @@
           <a:bodyPr wrap="square" rtlCol="0" anchor="ctr"/>
           <a:lstStyle/>
           <a:p>
-            <a:pPr indent="0" marL="0">
+            <a:pPr marL="0" indent="0">
               <a:lnSpc>
                 <a:spcPts val="1400"/>
               </a:lnSpc>
@@ -7110,7 +6892,7 @@
           <a:bodyPr wrap="square" rtlCol="0" anchor="ctr"/>
           <a:lstStyle/>
           <a:p>
-            <a:pPr algn="ctr" indent="0" marL="0">
+            <a:pPr marL="0" indent="0" algn="ctr">
               <a:buNone/>
             </a:pPr>
             <a:r>
@@ -7149,7 +6931,7 @@
           <a:bodyPr wrap="square" rtlCol="0" anchor="ctr"/>
           <a:lstStyle/>
           <a:p>
-            <a:pPr indent="0" marL="0">
+            <a:pPr marL="0" indent="0">
               <a:lnSpc>
                 <a:spcPts val="1400"/>
               </a:lnSpc>
@@ -7233,7 +7015,7 @@
           <a:bodyPr wrap="square" rtlCol="0" anchor="ctr"/>
           <a:lstStyle/>
           <a:p>
-            <a:pPr algn="ctr" indent="0" marL="0">
+            <a:pPr marL="0" indent="0" algn="ctr">
               <a:buNone/>
             </a:pPr>
             <a:r>
@@ -7272,7 +7054,7 @@
           <a:bodyPr wrap="square" rtlCol="0" anchor="ctr"/>
           <a:lstStyle/>
           <a:p>
-            <a:pPr indent="0" marL="0">
+            <a:pPr marL="0" indent="0">
               <a:lnSpc>
                 <a:spcPts val="1400"/>
               </a:lnSpc>
@@ -7356,7 +7138,7 @@
           <a:bodyPr wrap="square" rtlCol="0" anchor="ctr"/>
           <a:lstStyle/>
           <a:p>
-            <a:pPr algn="ctr" indent="0" marL="0">
+            <a:pPr marL="0" indent="0" algn="ctr">
               <a:buNone/>
             </a:pPr>
             <a:r>
@@ -7395,7 +7177,7 @@
           <a:bodyPr wrap="square" rtlCol="0" anchor="ctr"/>
           <a:lstStyle/>
           <a:p>
-            <a:pPr indent="0" marL="0">
+            <a:pPr marL="0" indent="0">
               <a:lnSpc>
                 <a:spcPts val="1400"/>
               </a:lnSpc>
@@ -7479,7 +7261,7 @@
           <a:bodyPr wrap="square" rtlCol="0" anchor="ctr"/>
           <a:lstStyle/>
           <a:p>
-            <a:pPr algn="ctr" indent="0" marL="0">
+            <a:pPr marL="0" indent="0" algn="ctr">
               <a:buNone/>
             </a:pPr>
             <a:r>
@@ -7518,7 +7300,7 @@
           <a:bodyPr wrap="square" rtlCol="0" anchor="ctr"/>
           <a:lstStyle/>
           <a:p>
-            <a:pPr indent="0" marL="0">
+            <a:pPr marL="0" indent="0">
               <a:lnSpc>
                 <a:spcPts val="1400"/>
               </a:lnSpc>
@@ -7560,7 +7342,7 @@
           <a:bodyPr wrap="square" rtlCol="0" anchor="ctr"/>
           <a:lstStyle/>
           <a:p>
-            <a:pPr algn="r" indent="0" marL="0">
+            <a:pPr marL="0" indent="0" algn="r">
               <a:buNone/>
             </a:pPr>
             <a:r>
@@ -7594,6 +7376,7 @@
         <a:solidFill>
           <a:srgbClr val="17212B"/>
         </a:solidFill>
+        <a:effectLst/>
       </p:bgPr>
     </p:bg>
     <p:spTree>
@@ -7631,11 +7414,11 @@
           <a:bodyPr wrap="square" rtlCol="0" anchor="ctr"/>
           <a:lstStyle/>
           <a:p>
-            <a:pPr indent="0" marL="0">
-              <a:buNone/>
-            </a:pPr>
-            <a:r>
-              <a:rPr lang="en-US" sz="1200" b="1" spc="200" kern="0" dirty="0">
+            <a:pPr marL="0" indent="0">
+              <a:buNone/>
+            </a:pPr>
+            <a:r>
+              <a:rPr lang="en-US" sz="1200" b="1" kern="0" spc="200" dirty="0">
                 <a:solidFill>
                   <a:srgbClr val="B8863B"/>
                 </a:solidFill>
@@ -7670,7 +7453,7 @@
           <a:bodyPr wrap="square" rtlCol="0" anchor="ctr"/>
           <a:lstStyle/>
           <a:p>
-            <a:pPr algn="l" indent="0" marL="0">
+            <a:pPr marL="0" indent="0" algn="l">
               <a:buNone/>
             </a:pPr>
             <a:r>
@@ -7729,7 +7512,7 @@
           <a:bodyPr wrap="square" rtlCol="0" anchor="ctr"/>
           <a:lstStyle/>
           <a:p>
-            <a:pPr indent="0" marL="0">
+            <a:pPr marL="0" indent="0">
               <a:lnSpc>
                 <a:spcPts val="1800"/>
               </a:lnSpc>
@@ -7791,7 +7574,7 @@
           <a:bodyPr wrap="square" rtlCol="0" anchor="ctr"/>
           <a:lstStyle/>
           <a:p>
-            <a:pPr indent="0" marL="0">
+            <a:pPr marL="0" indent="0">
               <a:lnSpc>
                 <a:spcPts val="1800"/>
               </a:lnSpc>
@@ -7853,7 +7636,7 @@
           <a:bodyPr wrap="square" rtlCol="0" anchor="ctr"/>
           <a:lstStyle/>
           <a:p>
-            <a:pPr indent="0" marL="0">
+            <a:pPr marL="0" indent="0">
               <a:lnSpc>
                 <a:spcPts val="1800"/>
               </a:lnSpc>
@@ -7915,7 +7698,7 @@
           <a:bodyPr wrap="square" rtlCol="0" anchor="ctr"/>
           <a:lstStyle/>
           <a:p>
-            <a:pPr indent="0" marL="0">
+            <a:pPr marL="0" indent="0">
               <a:lnSpc>
                 <a:spcPts val="1800"/>
               </a:lnSpc>
@@ -7977,7 +7760,7 @@
           <a:bodyPr wrap="square" rtlCol="0" anchor="ctr"/>
           <a:lstStyle/>
           <a:p>
-            <a:pPr indent="0" marL="0">
+            <a:pPr marL="0" indent="0">
               <a:lnSpc>
                 <a:spcPts val="1800"/>
               </a:lnSpc>
@@ -8019,7 +7802,7 @@
           <a:bodyPr wrap="square" rtlCol="0" anchor="ctr"/>
           <a:lstStyle/>
           <a:p>
-            <a:pPr algn="r" indent="0" marL="0">
+            <a:pPr marL="0" indent="0" algn="r">
               <a:buNone/>
             </a:pPr>
             <a:r>
@@ -8053,6 +7836,7 @@
         <a:solidFill>
           <a:srgbClr val="17212B"/>
         </a:solidFill>
+        <a:effectLst/>
       </p:bgPr>
     </p:bg>
     <p:spTree>
@@ -8090,7 +7874,7 @@
           <a:bodyPr wrap="square" rtlCol="0" anchor="ctr"/>
           <a:lstStyle/>
           <a:p>
-            <a:pPr indent="0" marL="0">
+            <a:pPr marL="0" indent="0">
               <a:buNone/>
             </a:pPr>
             <a:r>
@@ -8129,7 +7913,7 @@
           <a:bodyPr wrap="square" rtlCol="0" anchor="ctr"/>
           <a:lstStyle/>
           <a:p>
-            <a:pPr indent="0" marL="0">
+            <a:pPr marL="0" indent="0">
               <a:buNone/>
             </a:pPr>
             <a:r>
@@ -8191,7 +7975,7 @@
           <a:bodyPr wrap="square" rtlCol="0" anchor="ctr"/>
           <a:lstStyle/>
           <a:p>
-            <a:pPr indent="0" marL="0">
+            <a:pPr marL="0" indent="0">
               <a:buNone/>
             </a:pPr>
             <a:r>
@@ -8203,7 +7987,29 @@
                 <a:ea typeface="Calibri" pitchFamily="34" charset="-122"/>
                 <a:cs typeface="Calibri" pitchFamily="34" charset="-120"/>
               </a:rPr>
-              <a:t>Nguyễn Đình Đán  •  Nguyễn Văn Vũ  •  Triệu Việt Hoa  •  Hoàng Xuân Sơn  •  Nguyễn Thái Thịnh</a:t>
+              <a:t>Nguyễn Đình Đán  •  Nguyễn Văn Vũ  •  </a:t>
+            </a:r>
+            <a:r>
+              <a:rPr lang="en-US" sz="1400" dirty="0" err="1">
+                <a:solidFill>
+                  <a:srgbClr val="9FB0AB"/>
+                </a:solidFill>
+                <a:latin typeface="Calibri" pitchFamily="34" charset="0"/>
+                <a:ea typeface="Calibri" pitchFamily="34" charset="-122"/>
+                <a:cs typeface="Calibri" pitchFamily="34" charset="-120"/>
+              </a:rPr>
+              <a:t>Trần</a:t>
+            </a:r>
+            <a:r>
+              <a:rPr lang="en-US" sz="1400" dirty="0">
+                <a:solidFill>
+                  <a:srgbClr val="9FB0AB"/>
+                </a:solidFill>
+                <a:latin typeface="Calibri" pitchFamily="34" charset="0"/>
+                <a:ea typeface="Calibri" pitchFamily="34" charset="-122"/>
+                <a:cs typeface="Calibri" pitchFamily="34" charset="-120"/>
+              </a:rPr>
+              <a:t> Việt Hoa  •  Hoàng Xuân Sơn  •  Nguyễn Thái Thịnh</a:t>
             </a:r>
             <a:endParaRPr lang="en-US" sz="1400" dirty="0"/>
           </a:p>
@@ -8225,6 +8031,7 @@
         <a:solidFill>
           <a:srgbClr val="F2F0E9"/>
         </a:solidFill>
+        <a:effectLst/>
       </p:bgPr>
     </p:bg>
     <p:spTree>
@@ -8262,11 +8069,11 @@
           <a:bodyPr wrap="square" rtlCol="0" anchor="ctr"/>
           <a:lstStyle/>
           <a:p>
-            <a:pPr indent="0" marL="0">
-              <a:buNone/>
-            </a:pPr>
-            <a:r>
-              <a:rPr lang="en-US" sz="1200" b="1" spc="200" kern="0" dirty="0">
+            <a:pPr marL="0" indent="0">
+              <a:buNone/>
+            </a:pPr>
+            <a:r>
+              <a:rPr lang="en-US" sz="1200" b="1" kern="0" spc="200" dirty="0">
                 <a:solidFill>
                   <a:srgbClr val="2B6E62"/>
                 </a:solidFill>
@@ -8301,7 +8108,7 @@
           <a:bodyPr wrap="square" rtlCol="0" anchor="ctr"/>
           <a:lstStyle/>
           <a:p>
-            <a:pPr algn="l" indent="0" marL="0">
+            <a:pPr marL="0" indent="0" algn="l">
               <a:buNone/>
             </a:pPr>
             <a:r>
@@ -8340,7 +8147,7 @@
           </a:solidFill>
           <a:ln/>
           <a:effectLst>
-            <a:outerShdw sx="100000" sy="100000" kx="0" ky="0" algn="bl" rotWithShape="0" blurRad="76200" dist="25400" dir="5400000">
+            <a:outerShdw blurRad="76200" dist="25400" dir="5400000" algn="bl" rotWithShape="0">
               <a:srgbClr val="000000">
                 <a:alpha val="12000"/>
               </a:srgbClr>
@@ -8389,7 +8196,7 @@
           <a:bodyPr wrap="square" rtlCol="0" anchor="ctr"/>
           <a:lstStyle/>
           <a:p>
-            <a:pPr algn="ctr" indent="0" marL="0">
+            <a:pPr marL="0" indent="0" algn="ctr">
               <a:buNone/>
             </a:pPr>
             <a:r>
@@ -8428,7 +8235,7 @@
           <a:bodyPr wrap="square" rtlCol="0" anchor="ctr"/>
           <a:lstStyle/>
           <a:p>
-            <a:pPr indent="0" marL="0">
+            <a:pPr marL="0" indent="0">
               <a:buNone/>
             </a:pPr>
             <a:r>
@@ -8467,7 +8274,7 @@
           <a:bodyPr wrap="square" rtlCol="0" anchor="ctr"/>
           <a:lstStyle/>
           <a:p>
-            <a:pPr indent="0" marL="0">
+            <a:pPr marL="0" indent="0">
               <a:lnSpc>
                 <a:spcPts val="1700"/>
               </a:lnSpc>
@@ -8509,7 +8316,7 @@
           </a:solidFill>
           <a:ln/>
           <a:effectLst>
-            <a:outerShdw sx="100000" sy="100000" kx="0" ky="0" algn="bl" rotWithShape="0" blurRad="76200" dist="25400" dir="5400000">
+            <a:outerShdw blurRad="76200" dist="25400" dir="5400000" algn="bl" rotWithShape="0">
               <a:srgbClr val="000000">
                 <a:alpha val="12000"/>
               </a:srgbClr>
@@ -8558,7 +8365,7 @@
           <a:bodyPr wrap="square" rtlCol="0" anchor="ctr"/>
           <a:lstStyle/>
           <a:p>
-            <a:pPr algn="ctr" indent="0" marL="0">
+            <a:pPr marL="0" indent="0" algn="ctr">
               <a:buNone/>
             </a:pPr>
             <a:r>
@@ -8597,7 +8404,7 @@
           <a:bodyPr wrap="square" rtlCol="0" anchor="ctr"/>
           <a:lstStyle/>
           <a:p>
-            <a:pPr indent="0" marL="0">
+            <a:pPr marL="0" indent="0">
               <a:buNone/>
             </a:pPr>
             <a:r>
@@ -8636,7 +8443,7 @@
           <a:bodyPr wrap="square" rtlCol="0" anchor="ctr"/>
           <a:lstStyle/>
           <a:p>
-            <a:pPr indent="0" marL="0">
+            <a:pPr marL="0" indent="0">
               <a:lnSpc>
                 <a:spcPts val="1700"/>
               </a:lnSpc>
@@ -8678,7 +8485,7 @@
           </a:solidFill>
           <a:ln/>
           <a:effectLst>
-            <a:outerShdw sx="100000" sy="100000" kx="0" ky="0" algn="bl" rotWithShape="0" blurRad="76200" dist="25400" dir="5400000">
+            <a:outerShdw blurRad="76200" dist="25400" dir="5400000" algn="bl" rotWithShape="0">
               <a:srgbClr val="000000">
                 <a:alpha val="12000"/>
               </a:srgbClr>
@@ -8727,7 +8534,7 @@
           <a:bodyPr wrap="square" rtlCol="0" anchor="ctr"/>
           <a:lstStyle/>
           <a:p>
-            <a:pPr algn="ctr" indent="0" marL="0">
+            <a:pPr marL="0" indent="0" algn="ctr">
               <a:buNone/>
             </a:pPr>
             <a:r>
@@ -8766,7 +8573,7 @@
           <a:bodyPr wrap="square" rtlCol="0" anchor="ctr"/>
           <a:lstStyle/>
           <a:p>
-            <a:pPr indent="0" marL="0">
+            <a:pPr marL="0" indent="0">
               <a:buNone/>
             </a:pPr>
             <a:r>
@@ -8805,7 +8612,7 @@
           <a:bodyPr wrap="square" rtlCol="0" anchor="ctr"/>
           <a:lstStyle/>
           <a:p>
-            <a:pPr indent="0" marL="0">
+            <a:pPr marL="0" indent="0">
               <a:lnSpc>
                 <a:spcPts val="1700"/>
               </a:lnSpc>
@@ -8847,7 +8654,7 @@
           <a:bodyPr wrap="square" rtlCol="0" anchor="ctr"/>
           <a:lstStyle/>
           <a:p>
-            <a:pPr algn="r" indent="0" marL="0">
+            <a:pPr marL="0" indent="0" algn="r">
               <a:buNone/>
             </a:pPr>
             <a:r>
@@ -8881,6 +8688,7 @@
         <a:solidFill>
           <a:srgbClr val="F2F0E9"/>
         </a:solidFill>
+        <a:effectLst/>
       </p:bgPr>
     </p:bg>
     <p:spTree>
@@ -8918,11 +8726,11 @@
           <a:bodyPr wrap="square" rtlCol="0" anchor="ctr"/>
           <a:lstStyle/>
           <a:p>
-            <a:pPr indent="0" marL="0">
-              <a:buNone/>
-            </a:pPr>
-            <a:r>
-              <a:rPr lang="en-US" sz="1200" b="1" spc="200" kern="0" dirty="0">
+            <a:pPr marL="0" indent="0">
+              <a:buNone/>
+            </a:pPr>
+            <a:r>
+              <a:rPr lang="en-US" sz="1200" b="1" kern="0" spc="200" dirty="0">
                 <a:solidFill>
                   <a:srgbClr val="2B6E62"/>
                 </a:solidFill>
@@ -8957,7 +8765,7 @@
           <a:bodyPr wrap="square" rtlCol="0" anchor="ctr"/>
           <a:lstStyle/>
           <a:p>
-            <a:pPr algn="l" indent="0" marL="0">
+            <a:pPr marL="0" indent="0" algn="l">
               <a:buNone/>
             </a:pPr>
             <a:r>
@@ -8996,7 +8804,7 @@
           </a:solidFill>
           <a:ln/>
           <a:effectLst>
-            <a:outerShdw sx="100000" sy="100000" kx="0" ky="0" algn="bl" rotWithShape="0" blurRad="76200" dist="25400" dir="5400000">
+            <a:outerShdw blurRad="76200" dist="25400" dir="5400000" algn="bl" rotWithShape="0">
               <a:srgbClr val="000000">
                 <a:alpha val="12000"/>
               </a:srgbClr>
@@ -9025,7 +8833,7 @@
           <a:bodyPr wrap="square" rtlCol="0" anchor="ctr"/>
           <a:lstStyle/>
           <a:p>
-            <a:pPr indent="0" marL="0">
+            <a:pPr marL="0" indent="0">
               <a:buNone/>
             </a:pPr>
             <a:r>
@@ -9064,7 +8872,7 @@
           <a:bodyPr wrap="square" rtlCol="0" anchor="ctr"/>
           <a:lstStyle/>
           <a:p>
-            <a:pPr indent="0" marL="0">
+            <a:pPr marL="0" indent="0">
               <a:lnSpc>
                 <a:spcPts val="1900"/>
               </a:lnSpc>
@@ -9106,7 +8914,7 @@
           <a:bodyPr wrap="square" rtlCol="0" anchor="ctr"/>
           <a:lstStyle/>
           <a:p>
-            <a:pPr indent="0" marL="0">
+            <a:pPr marL="0" indent="0">
               <a:buNone/>
             </a:pPr>
             <a:r>
@@ -9145,7 +8953,7 @@
           </a:solidFill>
           <a:ln/>
           <a:effectLst>
-            <a:outerShdw sx="100000" sy="100000" kx="0" ky="0" algn="bl" rotWithShape="0" blurRad="76200" dist="25400" dir="5400000">
+            <a:outerShdw blurRad="76200" dist="25400" dir="5400000" algn="bl" rotWithShape="0">
               <a:srgbClr val="000000">
                 <a:alpha val="12000"/>
               </a:srgbClr>
@@ -9194,7 +9002,7 @@
           <a:bodyPr wrap="square" rtlCol="0" anchor="ctr"/>
           <a:lstStyle/>
           <a:p>
-            <a:pPr algn="ctr" indent="0" marL="0">
+            <a:pPr marL="0" indent="0" algn="ctr">
               <a:buNone/>
             </a:pPr>
             <a:r>
@@ -9233,7 +9041,7 @@
           <a:bodyPr wrap="square" rtlCol="0" anchor="ctr"/>
           <a:lstStyle/>
           <a:p>
-            <a:pPr indent="0" marL="0">
+            <a:pPr marL="0" indent="0">
               <a:buNone/>
             </a:pPr>
             <a:r>
@@ -9272,7 +9080,7 @@
           <a:bodyPr wrap="square" rtlCol="0" anchor="ctr"/>
           <a:lstStyle/>
           <a:p>
-            <a:pPr indent="0" marL="0">
+            <a:pPr marL="0" indent="0">
               <a:lnSpc>
                 <a:spcPts val="1500"/>
               </a:lnSpc>
@@ -9314,7 +9122,7 @@
           </a:solidFill>
           <a:ln/>
           <a:effectLst>
-            <a:outerShdw sx="100000" sy="100000" kx="0" ky="0" algn="bl" rotWithShape="0" blurRad="76200" dist="25400" dir="5400000">
+            <a:outerShdw blurRad="76200" dist="25400" dir="5400000" algn="bl" rotWithShape="0">
               <a:srgbClr val="000000">
                 <a:alpha val="12000"/>
               </a:srgbClr>
@@ -9363,7 +9171,7 @@
           <a:bodyPr wrap="square" rtlCol="0" anchor="ctr"/>
           <a:lstStyle/>
           <a:p>
-            <a:pPr algn="ctr" indent="0" marL="0">
+            <a:pPr marL="0" indent="0" algn="ctr">
               <a:buNone/>
             </a:pPr>
             <a:r>
@@ -9402,7 +9210,7 @@
           <a:bodyPr wrap="square" rtlCol="0" anchor="ctr"/>
           <a:lstStyle/>
           <a:p>
-            <a:pPr indent="0" marL="0">
+            <a:pPr marL="0" indent="0">
               <a:buNone/>
             </a:pPr>
             <a:r>
@@ -9441,7 +9249,7 @@
           <a:bodyPr wrap="square" rtlCol="0" anchor="ctr"/>
           <a:lstStyle/>
           <a:p>
-            <a:pPr indent="0" marL="0">
+            <a:pPr marL="0" indent="0">
               <a:lnSpc>
                 <a:spcPts val="1500"/>
               </a:lnSpc>
@@ -9483,7 +9291,7 @@
           </a:solidFill>
           <a:ln/>
           <a:effectLst>
-            <a:outerShdw sx="100000" sy="100000" kx="0" ky="0" algn="bl" rotWithShape="0" blurRad="76200" dist="25400" dir="5400000">
+            <a:outerShdw blurRad="76200" dist="25400" dir="5400000" algn="bl" rotWithShape="0">
               <a:srgbClr val="000000">
                 <a:alpha val="12000"/>
               </a:srgbClr>
@@ -9532,7 +9340,7 @@
           <a:bodyPr wrap="square" rtlCol="0" anchor="ctr"/>
           <a:lstStyle/>
           <a:p>
-            <a:pPr algn="ctr" indent="0" marL="0">
+            <a:pPr marL="0" indent="0" algn="ctr">
               <a:buNone/>
             </a:pPr>
             <a:r>
@@ -9571,7 +9379,7 @@
           <a:bodyPr wrap="square" rtlCol="0" anchor="ctr"/>
           <a:lstStyle/>
           <a:p>
-            <a:pPr indent="0" marL="0">
+            <a:pPr marL="0" indent="0">
               <a:buNone/>
             </a:pPr>
             <a:r>
@@ -9610,7 +9418,7 @@
           <a:bodyPr wrap="square" rtlCol="0" anchor="ctr"/>
           <a:lstStyle/>
           <a:p>
-            <a:pPr indent="0" marL="0">
+            <a:pPr marL="0" indent="0">
               <a:lnSpc>
                 <a:spcPts val="1500"/>
               </a:lnSpc>
@@ -9652,7 +9460,7 @@
           <a:bodyPr wrap="square" rtlCol="0" anchor="ctr"/>
           <a:lstStyle/>
           <a:p>
-            <a:pPr algn="r" indent="0" marL="0">
+            <a:pPr marL="0" indent="0" algn="r">
               <a:buNone/>
             </a:pPr>
             <a:r>
@@ -9686,6 +9494,7 @@
         <a:solidFill>
           <a:srgbClr val="F2F0E9"/>
         </a:solidFill>
+        <a:effectLst/>
       </p:bgPr>
     </p:bg>
     <p:spTree>
@@ -9723,11 +9532,11 @@
           <a:bodyPr wrap="square" rtlCol="0" anchor="ctr"/>
           <a:lstStyle/>
           <a:p>
-            <a:pPr indent="0" marL="0">
-              <a:buNone/>
-            </a:pPr>
-            <a:r>
-              <a:rPr lang="en-US" sz="1200" b="1" spc="200" kern="0" dirty="0">
+            <a:pPr marL="0" indent="0">
+              <a:buNone/>
+            </a:pPr>
+            <a:r>
+              <a:rPr lang="en-US" sz="1200" b="1" kern="0" spc="200" dirty="0">
                 <a:solidFill>
                   <a:srgbClr val="2B6E62"/>
                 </a:solidFill>
@@ -9762,7 +9571,7 @@
           <a:bodyPr wrap="square" rtlCol="0" anchor="ctr"/>
           <a:lstStyle/>
           <a:p>
-            <a:pPr algn="l" indent="0" marL="0">
+            <a:pPr marL="0" indent="0" algn="l">
               <a:buNone/>
             </a:pPr>
             <a:r>
@@ -9801,7 +9610,7 @@
           </a:solidFill>
           <a:ln/>
           <a:effectLst>
-            <a:outerShdw sx="100000" sy="100000" kx="0" ky="0" algn="bl" rotWithShape="0" blurRad="76200" dist="25400" dir="5400000">
+            <a:outerShdw blurRad="76200" dist="25400" dir="5400000" algn="bl" rotWithShape="0">
               <a:srgbClr val="000000">
                 <a:alpha val="12000"/>
               </a:srgbClr>
@@ -9830,7 +9639,7 @@
           <a:bodyPr wrap="square" rtlCol="0" anchor="ctr"/>
           <a:lstStyle/>
           <a:p>
-            <a:pPr algn="ctr" indent="0" marL="0">
+            <a:pPr marL="0" indent="0" algn="ctr">
               <a:lnSpc>
                 <a:spcPts val="1700"/>
               </a:lnSpc>
@@ -9850,7 +9659,7 @@
             <a:endParaRPr lang="en-US" sz="1350" dirty="0"/>
           </a:p>
           <a:p>
-            <a:pPr algn="ctr" indent="0" marL="0">
+            <a:pPr marL="0" indent="0" algn="ctr">
               <a:lnSpc>
                 <a:spcPts val="1700"/>
               </a:lnSpc>
@@ -9912,7 +9721,7 @@
           </a:solidFill>
           <a:ln/>
           <a:effectLst>
-            <a:outerShdw sx="100000" sy="100000" kx="0" ky="0" algn="bl" rotWithShape="0" blurRad="76200" dist="25400" dir="5400000">
+            <a:outerShdw blurRad="76200" dist="25400" dir="5400000" algn="bl" rotWithShape="0">
               <a:srgbClr val="000000">
                 <a:alpha val="12000"/>
               </a:srgbClr>
@@ -9941,7 +9750,7 @@
           <a:bodyPr wrap="square" rtlCol="0" anchor="ctr"/>
           <a:lstStyle/>
           <a:p>
-            <a:pPr algn="ctr" indent="0" marL="0">
+            <a:pPr marL="0" indent="0" algn="ctr">
               <a:lnSpc>
                 <a:spcPts val="1700"/>
               </a:lnSpc>
@@ -9961,7 +9770,7 @@
             <a:endParaRPr lang="en-US" sz="1350" dirty="0"/>
           </a:p>
           <a:p>
-            <a:pPr algn="ctr" indent="0" marL="0">
+            <a:pPr marL="0" indent="0" algn="ctr">
               <a:lnSpc>
                 <a:spcPts val="1700"/>
               </a:lnSpc>
@@ -10023,7 +9832,7 @@
           </a:solidFill>
           <a:ln/>
           <a:effectLst>
-            <a:outerShdw sx="100000" sy="100000" kx="0" ky="0" algn="bl" rotWithShape="0" blurRad="76200" dist="25400" dir="5400000">
+            <a:outerShdw blurRad="76200" dist="25400" dir="5400000" algn="bl" rotWithShape="0">
               <a:srgbClr val="000000">
                 <a:alpha val="12000"/>
               </a:srgbClr>
@@ -10052,7 +9861,7 @@
           <a:bodyPr wrap="square" rtlCol="0" anchor="ctr"/>
           <a:lstStyle/>
           <a:p>
-            <a:pPr algn="ctr" indent="0" marL="0">
+            <a:pPr marL="0" indent="0" algn="ctr">
               <a:lnSpc>
                 <a:spcPts val="1700"/>
               </a:lnSpc>
@@ -10072,7 +9881,7 @@
             <a:endParaRPr lang="en-US" sz="1350" dirty="0"/>
           </a:p>
           <a:p>
-            <a:pPr algn="ctr" indent="0" marL="0">
+            <a:pPr marL="0" indent="0" algn="ctr">
               <a:lnSpc>
                 <a:spcPts val="1700"/>
               </a:lnSpc>
@@ -10134,7 +9943,7 @@
           </a:solidFill>
           <a:ln/>
           <a:effectLst>
-            <a:outerShdw sx="100000" sy="100000" kx="0" ky="0" algn="bl" rotWithShape="0" blurRad="76200" dist="25400" dir="5400000">
+            <a:outerShdw blurRad="76200" dist="25400" dir="5400000" algn="bl" rotWithShape="0">
               <a:srgbClr val="000000">
                 <a:alpha val="12000"/>
               </a:srgbClr>
@@ -10163,7 +9972,7 @@
           <a:bodyPr wrap="square" rtlCol="0" anchor="ctr"/>
           <a:lstStyle/>
           <a:p>
-            <a:pPr algn="ctr" indent="0" marL="0">
+            <a:pPr marL="0" indent="0" algn="ctr">
               <a:lnSpc>
                 <a:spcPts val="1700"/>
               </a:lnSpc>
@@ -10183,7 +9992,7 @@
             <a:endParaRPr lang="en-US" sz="1350" dirty="0"/>
           </a:p>
           <a:p>
-            <a:pPr algn="ctr" indent="0" marL="0">
+            <a:pPr marL="0" indent="0" algn="ctr">
               <a:lnSpc>
                 <a:spcPts val="1700"/>
               </a:lnSpc>
@@ -10225,7 +10034,7 @@
           </a:solidFill>
           <a:ln/>
           <a:effectLst>
-            <a:outerShdw sx="100000" sy="100000" kx="0" ky="0" algn="bl" rotWithShape="0" blurRad="76200" dist="25400" dir="5400000">
+            <a:outerShdw blurRad="76200" dist="25400" dir="5400000" algn="bl" rotWithShape="0">
               <a:srgbClr val="000000">
                 <a:alpha val="12000"/>
               </a:srgbClr>
@@ -10254,7 +10063,7 @@
           <a:bodyPr wrap="square" rtlCol="0" anchor="ctr"/>
           <a:lstStyle/>
           <a:p>
-            <a:pPr indent="0" marL="0">
+            <a:pPr marL="0" indent="0">
               <a:buNone/>
             </a:pPr>
             <a:r>
@@ -10453,7 +10262,7 @@
           <a:bodyPr wrap="square" rtlCol="0" anchor="ctr"/>
           <a:lstStyle/>
           <a:p>
-            <a:pPr algn="r" indent="0" marL="0">
+            <a:pPr marL="0" indent="0" algn="r">
               <a:buNone/>
             </a:pPr>
             <a:r>
@@ -10487,6 +10296,7 @@
         <a:solidFill>
           <a:srgbClr val="F2F0E9"/>
         </a:solidFill>
+        <a:effectLst/>
       </p:bgPr>
     </p:bg>
     <p:spTree>
@@ -10524,11 +10334,11 @@
           <a:bodyPr wrap="square" rtlCol="0" anchor="ctr"/>
           <a:lstStyle/>
           <a:p>
-            <a:pPr indent="0" marL="0">
-              <a:buNone/>
-            </a:pPr>
-            <a:r>
-              <a:rPr lang="en-US" sz="1200" b="1" spc="200" kern="0" dirty="0">
+            <a:pPr marL="0" indent="0">
+              <a:buNone/>
+            </a:pPr>
+            <a:r>
+              <a:rPr lang="en-US" sz="1200" b="1" kern="0" spc="200" dirty="0">
                 <a:solidFill>
                   <a:srgbClr val="2B6E62"/>
                 </a:solidFill>
@@ -10563,7 +10373,7 @@
           <a:bodyPr wrap="square" rtlCol="0" anchor="ctr"/>
           <a:lstStyle/>
           <a:p>
-            <a:pPr algn="l" indent="0" marL="0">
+            <a:pPr marL="0" indent="0" algn="l">
               <a:buNone/>
             </a:pPr>
             <a:r>
@@ -10602,7 +10412,7 @@
           </a:solidFill>
           <a:ln/>
           <a:effectLst>
-            <a:outerShdw sx="100000" sy="100000" kx="0" ky="0" algn="bl" rotWithShape="0" blurRad="76200" dist="25400" dir="5400000">
+            <a:outerShdw blurRad="76200" dist="25400" dir="5400000" algn="bl" rotWithShape="0">
               <a:srgbClr val="000000">
                 <a:alpha val="12000"/>
               </a:srgbClr>
@@ -10631,7 +10441,7 @@
           <a:bodyPr wrap="square" rtlCol="0" anchor="ctr"/>
           <a:lstStyle/>
           <a:p>
-            <a:pPr algn="ctr" indent="0" marL="0">
+            <a:pPr marL="0" indent="0" algn="ctr">
               <a:lnSpc>
                 <a:spcPts val="1600"/>
               </a:lnSpc>
@@ -10651,7 +10461,7 @@
             <a:endParaRPr lang="en-US" sz="1250" dirty="0"/>
           </a:p>
           <a:p>
-            <a:pPr algn="ctr" indent="0" marL="0">
+            <a:pPr marL="0" indent="0" algn="ctr">
               <a:lnSpc>
                 <a:spcPts val="1600"/>
               </a:lnSpc>
@@ -10713,7 +10523,7 @@
           </a:solidFill>
           <a:ln/>
           <a:effectLst>
-            <a:outerShdw sx="100000" sy="100000" kx="0" ky="0" algn="bl" rotWithShape="0" blurRad="76200" dist="25400" dir="5400000">
+            <a:outerShdw blurRad="76200" dist="25400" dir="5400000" algn="bl" rotWithShape="0">
               <a:srgbClr val="000000">
                 <a:alpha val="12000"/>
               </a:srgbClr>
@@ -10742,7 +10552,7 @@
           <a:bodyPr wrap="square" rtlCol="0" anchor="ctr"/>
           <a:lstStyle/>
           <a:p>
-            <a:pPr algn="ctr" indent="0" marL="0">
+            <a:pPr marL="0" indent="0" algn="ctr">
               <a:lnSpc>
                 <a:spcPts val="1600"/>
               </a:lnSpc>
@@ -10762,7 +10572,7 @@
             <a:endParaRPr lang="en-US" sz="1250" dirty="0"/>
           </a:p>
           <a:p>
-            <a:pPr algn="ctr" indent="0" marL="0">
+            <a:pPr marL="0" indent="0" algn="ctr">
               <a:lnSpc>
                 <a:spcPts val="1600"/>
               </a:lnSpc>
@@ -10782,7 +10592,7 @@
             <a:endParaRPr lang="en-US" sz="1250" dirty="0"/>
           </a:p>
           <a:p>
-            <a:pPr algn="ctr" indent="0" marL="0">
+            <a:pPr marL="0" indent="0" algn="ctr">
               <a:lnSpc>
                 <a:spcPts val="1600"/>
               </a:lnSpc>
@@ -10844,7 +10654,7 @@
           </a:solidFill>
           <a:ln/>
           <a:effectLst>
-            <a:outerShdw sx="100000" sy="100000" kx="0" ky="0" algn="bl" rotWithShape="0" blurRad="76200" dist="25400" dir="5400000">
+            <a:outerShdw blurRad="76200" dist="25400" dir="5400000" algn="bl" rotWithShape="0">
               <a:srgbClr val="000000">
                 <a:alpha val="12000"/>
               </a:srgbClr>
@@ -10873,7 +10683,7 @@
           <a:bodyPr wrap="square" rtlCol="0" anchor="ctr"/>
           <a:lstStyle/>
           <a:p>
-            <a:pPr algn="ctr" indent="0" marL="0">
+            <a:pPr marL="0" indent="0" algn="ctr">
               <a:lnSpc>
                 <a:spcPts val="1600"/>
               </a:lnSpc>
@@ -10893,7 +10703,7 @@
             <a:endParaRPr lang="en-US" sz="1250" dirty="0"/>
           </a:p>
           <a:p>
-            <a:pPr algn="ctr" indent="0" marL="0">
+            <a:pPr marL="0" indent="0" algn="ctr">
               <a:lnSpc>
                 <a:spcPts val="1600"/>
               </a:lnSpc>
@@ -10955,7 +10765,7 @@
           </a:solidFill>
           <a:ln/>
           <a:effectLst>
-            <a:outerShdw sx="100000" sy="100000" kx="0" ky="0" algn="bl" rotWithShape="0" blurRad="76200" dist="25400" dir="5400000">
+            <a:outerShdw blurRad="76200" dist="25400" dir="5400000" algn="bl" rotWithShape="0">
               <a:srgbClr val="000000">
                 <a:alpha val="12000"/>
               </a:srgbClr>
@@ -10984,7 +10794,7 @@
           <a:bodyPr wrap="square" rtlCol="0" anchor="ctr"/>
           <a:lstStyle/>
           <a:p>
-            <a:pPr algn="ctr" indent="0" marL="0">
+            <a:pPr marL="0" indent="0" algn="ctr">
               <a:lnSpc>
                 <a:spcPts val="1600"/>
               </a:lnSpc>
@@ -11004,7 +10814,7 @@
             <a:endParaRPr lang="en-US" sz="1250" dirty="0"/>
           </a:p>
           <a:p>
-            <a:pPr algn="ctr" indent="0" marL="0">
+            <a:pPr marL="0" indent="0" algn="ctr">
               <a:lnSpc>
                 <a:spcPts val="1600"/>
               </a:lnSpc>
@@ -11066,7 +10876,7 @@
           </a:solidFill>
           <a:ln/>
           <a:effectLst>
-            <a:outerShdw sx="100000" sy="100000" kx="0" ky="0" algn="bl" rotWithShape="0" blurRad="76200" dist="25400" dir="5400000">
+            <a:outerShdw blurRad="76200" dist="25400" dir="5400000" algn="bl" rotWithShape="0">
               <a:srgbClr val="000000">
                 <a:alpha val="12000"/>
               </a:srgbClr>
@@ -11095,7 +10905,7 @@
           <a:bodyPr wrap="square" rtlCol="0" anchor="ctr"/>
           <a:lstStyle/>
           <a:p>
-            <a:pPr algn="ctr" indent="0" marL="0">
+            <a:pPr marL="0" indent="0" algn="ctr">
               <a:lnSpc>
                 <a:spcPts val="1600"/>
               </a:lnSpc>
@@ -11115,7 +10925,7 @@
             <a:endParaRPr lang="en-US" sz="1250" dirty="0"/>
           </a:p>
           <a:p>
-            <a:pPr algn="ctr" indent="0" marL="0">
+            <a:pPr marL="0" indent="0" algn="ctr">
               <a:lnSpc>
                 <a:spcPts val="1600"/>
               </a:lnSpc>
@@ -11157,7 +10967,7 @@
           </a:solidFill>
           <a:ln/>
           <a:effectLst>
-            <a:outerShdw sx="100000" sy="100000" kx="0" ky="0" algn="bl" rotWithShape="0" blurRad="76200" dist="25400" dir="5400000">
+            <a:outerShdw blurRad="76200" dist="25400" dir="5400000" algn="bl" rotWithShape="0">
               <a:srgbClr val="000000">
                 <a:alpha val="12000"/>
               </a:srgbClr>
@@ -11186,7 +10996,7 @@
           <a:bodyPr wrap="square" rtlCol="0" anchor="ctr"/>
           <a:lstStyle/>
           <a:p>
-            <a:pPr indent="0" marL="0">
+            <a:pPr marL="0" indent="0">
               <a:buNone/>
             </a:pPr>
             <a:r>
@@ -11225,7 +11035,7 @@
           <a:bodyPr wrap="square" rtlCol="0" anchor="ctr"/>
           <a:lstStyle/>
           <a:p>
-            <a:pPr indent="0" marL="0">
+            <a:pPr marL="0" indent="0">
               <a:lnSpc>
                 <a:spcPts val="1700"/>
               </a:lnSpc>
@@ -11267,7 +11077,7 @@
           </a:solidFill>
           <a:ln/>
           <a:effectLst>
-            <a:outerShdw sx="100000" sy="100000" kx="0" ky="0" algn="bl" rotWithShape="0" blurRad="76200" dist="25400" dir="5400000">
+            <a:outerShdw blurRad="76200" dist="25400" dir="5400000" algn="bl" rotWithShape="0">
               <a:srgbClr val="000000">
                 <a:alpha val="12000"/>
               </a:srgbClr>
@@ -11296,7 +11106,7 @@
           <a:bodyPr wrap="square" rtlCol="0" anchor="ctr"/>
           <a:lstStyle/>
           <a:p>
-            <a:pPr indent="0" marL="0">
+            <a:pPr marL="0" indent="0">
               <a:buNone/>
             </a:pPr>
             <a:r>
@@ -11335,7 +11145,7 @@
           <a:bodyPr wrap="square" rtlCol="0" anchor="ctr"/>
           <a:lstStyle/>
           <a:p>
-            <a:pPr indent="0" marL="0">
+            <a:pPr marL="0" indent="0">
               <a:lnSpc>
                 <a:spcPts val="1400"/>
               </a:lnSpc>
@@ -11377,7 +11187,7 @@
           <a:bodyPr wrap="square" rtlCol="0" anchor="ctr"/>
           <a:lstStyle/>
           <a:p>
-            <a:pPr algn="r" indent="0" marL="0">
+            <a:pPr marL="0" indent="0" algn="r">
               <a:buNone/>
             </a:pPr>
             <a:r>
@@ -11411,6 +11221,7 @@
         <a:solidFill>
           <a:srgbClr val="F2F0E9"/>
         </a:solidFill>
+        <a:effectLst/>
       </p:bgPr>
     </p:bg>
     <p:spTree>
@@ -11448,11 +11259,11 @@
           <a:bodyPr wrap="square" rtlCol="0" anchor="ctr"/>
           <a:lstStyle/>
           <a:p>
-            <a:pPr indent="0" marL="0">
-              <a:buNone/>
-            </a:pPr>
-            <a:r>
-              <a:rPr lang="en-US" sz="1200" b="1" spc="200" kern="0" dirty="0">
+            <a:pPr marL="0" indent="0">
+              <a:buNone/>
+            </a:pPr>
+            <a:r>
+              <a:rPr lang="en-US" sz="1200" b="1" kern="0" spc="200" dirty="0">
                 <a:solidFill>
                   <a:srgbClr val="2B6E62"/>
                 </a:solidFill>
@@ -11487,7 +11298,7 @@
           <a:bodyPr wrap="square" rtlCol="0" anchor="ctr"/>
           <a:lstStyle/>
           <a:p>
-            <a:pPr algn="l" indent="0" marL="0">
+            <a:pPr marL="0" indent="0" algn="l">
               <a:buNone/>
             </a:pPr>
             <a:r>
@@ -11526,7 +11337,7 @@
           </a:solidFill>
           <a:ln/>
           <a:effectLst>
-            <a:outerShdw sx="100000" sy="100000" kx="0" ky="0" algn="bl" rotWithShape="0" blurRad="76200" dist="25400" dir="5400000">
+            <a:outerShdw blurRad="76200" dist="25400" dir="5400000" algn="bl" rotWithShape="0">
               <a:srgbClr val="000000">
                 <a:alpha val="12000"/>
               </a:srgbClr>
@@ -11555,11 +11366,11 @@
           <a:bodyPr wrap="square" rtlCol="0" anchor="ctr"/>
           <a:lstStyle/>
           <a:p>
-            <a:pPr indent="0" marL="0">
-              <a:buNone/>
-            </a:pPr>
-            <a:r>
-              <a:rPr lang="en-US" sz="1300" b="1" spc="150" kern="0" dirty="0">
+            <a:pPr marL="0" indent="0">
+              <a:buNone/>
+            </a:pPr>
+            <a:r>
+              <a:rPr lang="en-US" sz="1300" b="1" kern="0" spc="150" dirty="0">
                 <a:solidFill>
                   <a:srgbClr val="2B6E62"/>
                 </a:solidFill>
@@ -11594,7 +11405,7 @@
           <a:bodyPr wrap="square" rtlCol="0" anchor="ctr"/>
           <a:lstStyle/>
           <a:p>
-            <a:pPr indent="0" marL="0">
+            <a:pPr marL="0" indent="0">
               <a:lnSpc>
                 <a:spcPts val="2300"/>
               </a:lnSpc>
@@ -11636,7 +11447,7 @@
           <a:bodyPr wrap="square" rtlCol="0" anchor="ctr"/>
           <a:lstStyle/>
           <a:p>
-            <a:pPr indent="0" marL="0">
+            <a:pPr marL="0" indent="0">
               <a:lnSpc>
                 <a:spcPts val="1700"/>
               </a:lnSpc>
@@ -11678,7 +11489,7 @@
           </a:solidFill>
           <a:ln/>
           <a:effectLst>
-            <a:outerShdw sx="100000" sy="100000" kx="0" ky="0" algn="bl" rotWithShape="0" blurRad="76200" dist="25400" dir="5400000">
+            <a:outerShdw blurRad="76200" dist="25400" dir="5400000" algn="bl" rotWithShape="0">
               <a:srgbClr val="000000">
                 <a:alpha val="12000"/>
               </a:srgbClr>
@@ -11707,11 +11518,11 @@
           <a:bodyPr wrap="square" rtlCol="0" anchor="ctr"/>
           <a:lstStyle/>
           <a:p>
-            <a:pPr indent="0" marL="0">
-              <a:buNone/>
-            </a:pPr>
-            <a:r>
-              <a:rPr lang="en-US" sz="1300" b="1" spc="150" kern="0" dirty="0">
+            <a:pPr marL="0" indent="0">
+              <a:buNone/>
+            </a:pPr>
+            <a:r>
+              <a:rPr lang="en-US" sz="1300" b="1" kern="0" spc="150" dirty="0">
                 <a:solidFill>
                   <a:srgbClr val="B8863B"/>
                 </a:solidFill>
@@ -11746,7 +11557,7 @@
           <a:bodyPr wrap="square" rtlCol="0" anchor="ctr"/>
           <a:lstStyle/>
           <a:p>
-            <a:pPr indent="0" marL="0">
+            <a:pPr marL="0" indent="0">
               <a:lnSpc>
                 <a:spcPts val="2300"/>
               </a:lnSpc>
@@ -11788,7 +11599,7 @@
           <a:bodyPr wrap="square" rtlCol="0" anchor="ctr"/>
           <a:lstStyle/>
           <a:p>
-            <a:pPr indent="0" marL="0">
+            <a:pPr marL="0" indent="0">
               <a:lnSpc>
                 <a:spcPts val="1700"/>
               </a:lnSpc>
@@ -11830,7 +11641,7 @@
           </a:solidFill>
           <a:ln/>
           <a:effectLst>
-            <a:outerShdw sx="100000" sy="100000" kx="0" ky="0" algn="bl" rotWithShape="0" blurRad="76200" dist="25400" dir="5400000">
+            <a:outerShdw blurRad="76200" dist="25400" dir="5400000" algn="bl" rotWithShape="0">
               <a:srgbClr val="000000">
                 <a:alpha val="12000"/>
               </a:srgbClr>
@@ -11859,11 +11670,11 @@
           <a:bodyPr wrap="square" rtlCol="0" anchor="ctr"/>
           <a:lstStyle/>
           <a:p>
-            <a:pPr indent="0" marL="0">
-              <a:buNone/>
-            </a:pPr>
-            <a:r>
-              <a:rPr lang="en-US" sz="1300" b="1" spc="150" kern="0" dirty="0">
+            <a:pPr marL="0" indent="0">
+              <a:buNone/>
+            </a:pPr>
+            <a:r>
+              <a:rPr lang="en-US" sz="1300" b="1" kern="0" spc="150" dirty="0">
                 <a:solidFill>
                   <a:srgbClr val="5B6672"/>
                 </a:solidFill>
@@ -11898,7 +11709,7 @@
           <a:bodyPr wrap="square" rtlCol="0" anchor="ctr"/>
           <a:lstStyle/>
           <a:p>
-            <a:pPr indent="0" marL="0">
+            <a:pPr marL="0" indent="0">
               <a:lnSpc>
                 <a:spcPts val="2300"/>
               </a:lnSpc>
@@ -11940,7 +11751,7 @@
           <a:bodyPr wrap="square" rtlCol="0" anchor="ctr"/>
           <a:lstStyle/>
           <a:p>
-            <a:pPr indent="0" marL="0">
+            <a:pPr marL="0" indent="0">
               <a:lnSpc>
                 <a:spcPts val="1700"/>
               </a:lnSpc>
@@ -11982,7 +11793,7 @@
           <a:bodyPr wrap="square" rtlCol="0" anchor="ctr"/>
           <a:lstStyle/>
           <a:p>
-            <a:pPr algn="r" indent="0" marL="0">
+            <a:pPr marL="0" indent="0" algn="r">
               <a:buNone/>
             </a:pPr>
             <a:r>
@@ -12016,6 +11827,7 @@
         <a:solidFill>
           <a:srgbClr val="F2F0E9"/>
         </a:solidFill>
+        <a:effectLst/>
       </p:bgPr>
     </p:bg>
     <p:spTree>
@@ -12053,11 +11865,11 @@
           <a:bodyPr wrap="square" rtlCol="0" anchor="ctr"/>
           <a:lstStyle/>
           <a:p>
-            <a:pPr indent="0" marL="0">
-              <a:buNone/>
-            </a:pPr>
-            <a:r>
-              <a:rPr lang="en-US" sz="1200" b="1" spc="200" kern="0" dirty="0">
+            <a:pPr marL="0" indent="0">
+              <a:buNone/>
+            </a:pPr>
+            <a:r>
+              <a:rPr lang="en-US" sz="1200" b="1" kern="0" spc="200" dirty="0">
                 <a:solidFill>
                   <a:srgbClr val="2B6E62"/>
                 </a:solidFill>
@@ -12092,7 +11904,7 @@
           <a:bodyPr wrap="square" rtlCol="0" anchor="ctr"/>
           <a:lstStyle/>
           <a:p>
-            <a:pPr algn="l" indent="0" marL="0">
+            <a:pPr marL="0" indent="0" algn="l">
               <a:buNone/>
             </a:pPr>
             <a:r>
@@ -12131,7 +11943,7 @@
           </a:solidFill>
           <a:ln/>
           <a:effectLst>
-            <a:outerShdw sx="100000" sy="100000" kx="0" ky="0" algn="bl" rotWithShape="0" blurRad="76200" dist="25400" dir="5400000">
+            <a:outerShdw blurRad="76200" dist="25400" dir="5400000" algn="bl" rotWithShape="0">
               <a:srgbClr val="000000">
                 <a:alpha val="12000"/>
               </a:srgbClr>
@@ -12160,7 +11972,7 @@
           <a:bodyPr wrap="square" rtlCol="0" anchor="ctr"/>
           <a:lstStyle/>
           <a:p>
-            <a:pPr indent="0" marL="0">
+            <a:pPr marL="0" indent="0">
               <a:buNone/>
             </a:pPr>
             <a:r>
@@ -12199,7 +12011,7 @@
           <a:bodyPr wrap="square" rtlCol="0" anchor="ctr"/>
           <a:lstStyle/>
           <a:p>
-            <a:pPr indent="0" marL="0">
+            <a:pPr marL="0" indent="0">
               <a:lnSpc>
                 <a:spcPts val="1800"/>
               </a:lnSpc>
@@ -12241,7 +12053,7 @@
           <a:bodyPr wrap="square" rtlCol="0" anchor="ctr"/>
           <a:lstStyle/>
           <a:p>
-            <a:pPr indent="0" marL="0">
+            <a:pPr marL="0" indent="0">
               <a:buNone/>
             </a:pPr>
             <a:r>
@@ -12280,7 +12092,7 @@
           </a:solidFill>
           <a:ln/>
           <a:effectLst>
-            <a:outerShdw sx="100000" sy="100000" kx="0" ky="0" algn="bl" rotWithShape="0" blurRad="76200" dist="25400" dir="5400000">
+            <a:outerShdw blurRad="76200" dist="25400" dir="5400000" algn="bl" rotWithShape="0">
               <a:srgbClr val="000000">
                 <a:alpha val="12000"/>
               </a:srgbClr>
@@ -12309,7 +12121,7 @@
           <a:bodyPr wrap="square" rtlCol="0" anchor="ctr"/>
           <a:lstStyle/>
           <a:p>
-            <a:pPr indent="0" marL="0">
+            <a:pPr marL="0" indent="0">
               <a:buNone/>
             </a:pPr>
             <a:r>
@@ -12348,7 +12160,7 @@
           <a:bodyPr wrap="square" rtlCol="0" anchor="ctr"/>
           <a:lstStyle/>
           <a:p>
-            <a:pPr indent="0" marL="0">
+            <a:pPr marL="0" indent="0">
               <a:lnSpc>
                 <a:spcPts val="1800"/>
               </a:lnSpc>
@@ -12390,7 +12202,7 @@
           <a:bodyPr wrap="square" rtlCol="0" anchor="ctr"/>
           <a:lstStyle/>
           <a:p>
-            <a:pPr indent="0" marL="0">
+            <a:pPr marL="0" indent="0">
               <a:buNone/>
             </a:pPr>
             <a:r>
@@ -12429,7 +12241,7 @@
           <a:bodyPr wrap="square" rtlCol="0" anchor="ctr"/>
           <a:lstStyle/>
           <a:p>
-            <a:pPr algn="r" indent="0" marL="0">
+            <a:pPr marL="0" indent="0" algn="r">
               <a:buNone/>
             </a:pPr>
             <a:r>
@@ -12463,6 +12275,7 @@
         <a:solidFill>
           <a:srgbClr val="F2F0E9"/>
         </a:solidFill>
+        <a:effectLst/>
       </p:bgPr>
     </p:bg>
     <p:spTree>
@@ -12500,11 +12313,11 @@
           <a:bodyPr wrap="square" rtlCol="0" anchor="ctr"/>
           <a:lstStyle/>
           <a:p>
-            <a:pPr indent="0" marL="0">
-              <a:buNone/>
-            </a:pPr>
-            <a:r>
-              <a:rPr lang="en-US" sz="1200" b="1" spc="200" kern="0" dirty="0">
+            <a:pPr marL="0" indent="0">
+              <a:buNone/>
+            </a:pPr>
+            <a:r>
+              <a:rPr lang="en-US" sz="1200" b="1" kern="0" spc="200" dirty="0">
                 <a:solidFill>
                   <a:srgbClr val="2B6E62"/>
                 </a:solidFill>
@@ -12539,7 +12352,7 @@
           <a:bodyPr wrap="square" rtlCol="0" anchor="ctr"/>
           <a:lstStyle/>
           <a:p>
-            <a:pPr algn="l" indent="0" marL="0">
+            <a:pPr marL="0" indent="0" algn="l">
               <a:buNone/>
             </a:pPr>
             <a:r>
@@ -12559,14 +12372,14 @@
       </p:sp>
       <p:pic>
         <p:nvPicPr>
-          <p:cNvPr id="4" name="Image 0" descr="D:\PyCharmProject\DeepLearning\autotender-vn\reports\figures\embedding_vi_bi_encoder_tsne.png">    </p:cNvPr>
+          <p:cNvPr id="4" name="Image 0" descr="D:\PyCharmProject\DeepLearning\autotender-vn\reports\figures\embedding_vi_bi_encoder_tsne.png"/>
           <p:cNvPicPr>
             <a:picLocks noChangeAspect="1"/>
           </p:cNvPicPr>
           <p:nvPr/>
         </p:nvPicPr>
         <p:blipFill>
-          <a:blip r:embed="rId1"/>
+          <a:blip r:embed="rId3"/>
           <a:stretch>
             <a:fillRect/>
           </a:stretch>
@@ -12602,7 +12415,7 @@
           <a:bodyPr wrap="square" rtlCol="0" anchor="ctr"/>
           <a:lstStyle/>
           <a:p>
-            <a:pPr algn="ctr" indent="0" marL="0">
+            <a:pPr marL="0" indent="0" algn="ctr">
               <a:buNone/>
             </a:pPr>
             <a:r>
@@ -12641,7 +12454,7 @@
           </a:solidFill>
           <a:ln/>
           <a:effectLst>
-            <a:outerShdw sx="100000" sy="100000" kx="0" ky="0" algn="bl" rotWithShape="0" blurRad="76200" dist="25400" dir="5400000">
+            <a:outerShdw blurRad="76200" dist="25400" dir="5400000" algn="bl" rotWithShape="0">
               <a:srgbClr val="000000">
                 <a:alpha val="12000"/>
               </a:srgbClr>
@@ -12670,7 +12483,7 @@
           <a:bodyPr wrap="square" rtlCol="0" anchor="ctr"/>
           <a:lstStyle/>
           <a:p>
-            <a:pPr indent="0" marL="0">
+            <a:pPr marL="0" indent="0">
               <a:buNone/>
             </a:pPr>
             <a:r>
@@ -12709,7 +12522,7 @@
           <a:bodyPr wrap="square" rtlCol="0" anchor="ctr"/>
           <a:lstStyle/>
           <a:p>
-            <a:pPr indent="0" marL="0">
+            <a:pPr marL="0" indent="0">
               <a:lnSpc>
                 <a:spcPts val="1800"/>
               </a:lnSpc>
@@ -12729,7 +12542,7 @@
             <a:endParaRPr lang="en-US" sz="1250" dirty="0"/>
           </a:p>
           <a:p>
-            <a:pPr indent="0" marL="0">
+            <a:pPr marL="0" indent="0">
               <a:lnSpc>
                 <a:spcPts val="1800"/>
               </a:lnSpc>
@@ -12738,7 +12551,7 @@
             <a:endParaRPr lang="en-US" sz="1250" dirty="0"/>
           </a:p>
           <a:p>
-            <a:pPr indent="0" marL="0">
+            <a:pPr marL="0" indent="0">
               <a:lnSpc>
                 <a:spcPts val="1800"/>
               </a:lnSpc>
@@ -12758,7 +12571,7 @@
             <a:endParaRPr lang="en-US" sz="1250" dirty="0"/>
           </a:p>
           <a:p>
-            <a:pPr indent="0" marL="0">
+            <a:pPr marL="0" indent="0">
               <a:lnSpc>
                 <a:spcPts val="1800"/>
               </a:lnSpc>
@@ -12767,7 +12580,7 @@
             <a:endParaRPr lang="en-US" sz="1250" dirty="0"/>
           </a:p>
           <a:p>
-            <a:pPr indent="0" marL="0">
+            <a:pPr marL="0" indent="0">
               <a:lnSpc>
                 <a:spcPts val="1800"/>
               </a:lnSpc>
@@ -12809,7 +12622,7 @@
           <a:bodyPr wrap="square" rtlCol="0" anchor="ctr"/>
           <a:lstStyle/>
           <a:p>
-            <a:pPr algn="r" indent="0" marL="0">
+            <a:pPr marL="0" indent="0" algn="r">
               <a:buNone/>
             </a:pPr>
             <a:r>
@@ -12843,6 +12656,7 @@
         <a:solidFill>
           <a:srgbClr val="F2F0E9"/>
         </a:solidFill>
+        <a:effectLst/>
       </p:bgPr>
     </p:bg>
     <p:spTree>
@@ -12880,11 +12694,11 @@
           <a:bodyPr wrap="square" rtlCol="0" anchor="ctr"/>
           <a:lstStyle/>
           <a:p>
-            <a:pPr indent="0" marL="0">
-              <a:buNone/>
-            </a:pPr>
-            <a:r>
-              <a:rPr lang="en-US" sz="1200" b="1" spc="200" kern="0" dirty="0">
+            <a:pPr marL="0" indent="0">
+              <a:buNone/>
+            </a:pPr>
+            <a:r>
+              <a:rPr lang="en-US" sz="1200" b="1" kern="0" spc="200" dirty="0">
                 <a:solidFill>
                   <a:srgbClr val="2B6E62"/>
                 </a:solidFill>
@@ -12919,7 +12733,7 @@
           <a:bodyPr wrap="square" rtlCol="0" anchor="ctr"/>
           <a:lstStyle/>
           <a:p>
-            <a:pPr algn="l" indent="0" marL="0">
+            <a:pPr marL="0" indent="0" algn="l">
               <a:buNone/>
             </a:pPr>
             <a:r>
@@ -12939,7 +12753,7 @@
       </p:sp>
       <p:graphicFrame>
         <p:nvGraphicFramePr>
-          <p:cNvPr id="4" name="Chart 0" descr=""/>
+          <p:cNvPr id="4" name="Chart 0"/>
           <p:cNvGraphicFramePr/>
           <p:nvPr/>
         </p:nvGraphicFramePr>
@@ -12947,9 +12761,9 @@
           <a:off x="640080" y="2286000"/>
           <a:ext cx="5669280" cy="3840480"/>
         </p:xfrm>
-        <a:graphic xmlns:a="http://schemas.openxmlformats.org/drawingml/2006/main">
+        <a:graphic>
           <a:graphicData uri="http://schemas.openxmlformats.org/drawingml/2006/chart">
-            <c:chart xmlns:c="http://schemas.openxmlformats.org/drawingml/2006/chart" r:id="rId1"/>
+            <c:chart xmlns:c="http://schemas.openxmlformats.org/drawingml/2006/chart" xmlns:r="http://schemas.openxmlformats.org/officeDocument/2006/relationships" r:id="rId3"/>
           </a:graphicData>
         </a:graphic>
       </p:graphicFrame>
@@ -12974,7 +12788,7 @@
           </a:solidFill>
           <a:ln/>
           <a:effectLst>
-            <a:outerShdw sx="100000" sy="100000" kx="0" ky="0" algn="bl" rotWithShape="0" blurRad="76200" dist="25400" dir="5400000">
+            <a:outerShdw blurRad="76200" dist="25400" dir="5400000" algn="bl" rotWithShape="0">
               <a:srgbClr val="000000">
                 <a:alpha val="12000"/>
               </a:srgbClr>
@@ -13003,7 +12817,7 @@
           <a:bodyPr wrap="square" rtlCol="0" anchor="ctr"/>
           <a:lstStyle/>
           <a:p>
-            <a:pPr indent="0" marL="0">
+            <a:pPr marL="0" indent="0">
               <a:buNone/>
             </a:pPr>
             <a:r>
@@ -13042,7 +12856,7 @@
           <a:bodyPr wrap="square" rtlCol="0" anchor="ctr"/>
           <a:lstStyle/>
           <a:p>
-            <a:pPr indent="0" marL="0">
+            <a:pPr marL="0" indent="0">
               <a:lnSpc>
                 <a:spcPts val="1600"/>
               </a:lnSpc>
@@ -13084,7 +12898,7 @@
           <a:bodyPr wrap="square" rtlCol="0" anchor="ctr"/>
           <a:lstStyle/>
           <a:p>
-            <a:pPr indent="0" marL="0">
+            <a:pPr marL="0" indent="0">
               <a:lnSpc>
                 <a:spcPts val="1600"/>
               </a:lnSpc>
@@ -13126,7 +12940,7 @@
           <a:bodyPr wrap="square" rtlCol="0" anchor="ctr"/>
           <a:lstStyle/>
           <a:p>
-            <a:pPr indent="0" marL="0">
+            <a:pPr marL="0" indent="0">
               <a:lnSpc>
                 <a:spcPts val="1600"/>
               </a:lnSpc>
@@ -13168,7 +12982,7 @@
           <a:bodyPr wrap="square" rtlCol="0" anchor="ctr"/>
           <a:lstStyle/>
           <a:p>
-            <a:pPr algn="r" indent="0" marL="0">
+            <a:pPr marL="0" indent="0" algn="r">
               <a:buNone/>
             </a:pPr>
             <a:r>
@@ -13487,4 +13301,299 @@
     </a:ext>
   </a:extLst>
 </a:theme>
+</file>
+
+<file path=ppt/theme/theme2.xml><?xml version="1.0" encoding="utf-8"?>
+<a:theme xmlns:a="http://schemas.openxmlformats.org/drawingml/2006/main" name="Office Theme">
+  <a:themeElements>
+    <a:clrScheme name="Office">
+      <a:dk1>
+        <a:sysClr val="windowText" lastClr="000000"/>
+      </a:dk1>
+      <a:lt1>
+        <a:sysClr val="window" lastClr="FFFFFF"/>
+      </a:lt1>
+      <a:dk2>
+        <a:srgbClr val="44546A"/>
+      </a:dk2>
+      <a:lt2>
+        <a:srgbClr val="E7E6E6"/>
+      </a:lt2>
+      <a:accent1>
+        <a:srgbClr val="4472C4"/>
+      </a:accent1>
+      <a:accent2>
+        <a:srgbClr val="ED7D31"/>
+      </a:accent2>
+      <a:accent3>
+        <a:srgbClr val="A5A5A5"/>
+      </a:accent3>
+      <a:accent4>
+        <a:srgbClr val="FFC000"/>
+      </a:accent4>
+      <a:accent5>
+        <a:srgbClr val="5B9BD5"/>
+      </a:accent5>
+      <a:accent6>
+        <a:srgbClr val="70AD47"/>
+      </a:accent6>
+      <a:hlink>
+        <a:srgbClr val="0563C1"/>
+      </a:hlink>
+      <a:folHlink>
+        <a:srgbClr val="954F72"/>
+      </a:folHlink>
+    </a:clrScheme>
+    <a:fontScheme name="Office">
+      <a:majorFont>
+        <a:latin typeface="Calibri Light" panose="020F0302020204030204"/>
+        <a:ea typeface=""/>
+        <a:cs typeface=""/>
+        <a:font script="Jpan" typeface="游ゴシック Light"/>
+        <a:font script="Hang" typeface="맑은 고딕"/>
+        <a:font script="Hans" typeface="等线 Light"/>
+        <a:font script="Hant" typeface="新細明體"/>
+        <a:font script="Arab" typeface="Times New Roman"/>
+        <a:font script="Hebr" typeface="Times New Roman"/>
+        <a:font script="Thai" typeface="Angsana New"/>
+        <a:font script="Ethi" typeface="Nyala"/>
+        <a:font script="Beng" typeface="Vrinda"/>
+        <a:font script="Gujr" typeface="Shruti"/>
+        <a:font script="Khmr" typeface="MoolBoran"/>
+        <a:font script="Knda" typeface="Tunga"/>
+        <a:font script="Guru" typeface="Raavi"/>
+        <a:font script="Cans" typeface="Euphemia"/>
+        <a:font script="Cher" typeface="Plantagenet Cherokee"/>
+        <a:font script="Yiii" typeface="Microsoft Yi Baiti"/>
+        <a:font script="Tibt" typeface="Microsoft Himalaya"/>
+        <a:font script="Thaa" typeface="MV Boli"/>
+        <a:font script="Deva" typeface="Mangal"/>
+        <a:font script="Telu" typeface="Gautami"/>
+        <a:font script="Taml" typeface="Latha"/>
+        <a:font script="Syrc" typeface="Estrangelo Edessa"/>
+        <a:font script="Orya" typeface="Kalinga"/>
+        <a:font script="Mlym" typeface="Kartika"/>
+        <a:font script="Laoo" typeface="DokChampa"/>
+        <a:font script="Sinh" typeface="Iskoola Pota"/>
+        <a:font script="Mong" typeface="Mongolian Baiti"/>
+        <a:font script="Viet" typeface="Times New Roman"/>
+        <a:font script="Uigh" typeface="Microsoft Uighur"/>
+        <a:font script="Geor" typeface="Sylfaen"/>
+        <a:font script="Armn" typeface="Arial"/>
+        <a:font script="Bugi" typeface="Leelawadee UI"/>
+        <a:font script="Bopo" typeface="Microsoft JhengHei"/>
+        <a:font script="Java" typeface="Javanese Text"/>
+        <a:font script="Lisu" typeface="Segoe UI"/>
+        <a:font script="Mymr" typeface="Myanmar Text"/>
+        <a:font script="Nkoo" typeface="Ebrima"/>
+        <a:font script="Olck" typeface="Nirmala UI"/>
+        <a:font script="Osma" typeface="Ebrima"/>
+        <a:font script="Phag" typeface="Phagspa"/>
+        <a:font script="Syrn" typeface="Estrangelo Edessa"/>
+        <a:font script="Syrj" typeface="Estrangelo Edessa"/>
+        <a:font script="Syre" typeface="Estrangelo Edessa"/>
+        <a:font script="Sora" typeface="Nirmala UI"/>
+        <a:font script="Tale" typeface="Microsoft Tai Le"/>
+        <a:font script="Talu" typeface="Microsoft New Tai Lue"/>
+        <a:font script="Tfng" typeface="Ebrima"/>
+      </a:majorFont>
+      <a:minorFont>
+        <a:latin typeface="Calibri" panose="020F0502020204030204"/>
+        <a:ea typeface=""/>
+        <a:cs typeface=""/>
+        <a:font script="Jpan" typeface="游ゴシック"/>
+        <a:font script="Hang" typeface="맑은 고딕"/>
+        <a:font script="Hans" typeface="等线"/>
+        <a:font script="Hant" typeface="新細明體"/>
+        <a:font script="Arab" typeface="Arial"/>
+        <a:font script="Hebr" typeface="Arial"/>
+        <a:font script="Thai" typeface="Cordia New"/>
+        <a:font script="Ethi" typeface="Nyala"/>
+        <a:font script="Beng" typeface="Vrinda"/>
+        <a:font script="Gujr" typeface="Shruti"/>
+        <a:font script="Khmr" typeface="DaunPenh"/>
+        <a:font script="Knda" typeface="Tunga"/>
+        <a:font script="Guru" typeface="Raavi"/>
+        <a:font script="Cans" typeface="Euphemia"/>
+        <a:font script="Cher" typeface="Plantagenet Cherokee"/>
+        <a:font script="Yiii" typeface="Microsoft Yi Baiti"/>
+        <a:font script="Tibt" typeface="Microsoft Himalaya"/>
+        <a:font script="Thaa" typeface="MV Boli"/>
+        <a:font script="Deva" typeface="Mangal"/>
+        <a:font script="Telu" typeface="Gautami"/>
+        <a:font script="Taml" typeface="Latha"/>
+        <a:font script="Syrc" typeface="Estrangelo Edessa"/>
+        <a:font script="Orya" typeface="Kalinga"/>
+        <a:font script="Mlym" typeface="Kartika"/>
+        <a:font script="Laoo" typeface="DokChampa"/>
+        <a:font script="Sinh" typeface="Iskoola Pota"/>
+        <a:font script="Mong" typeface="Mongolian Baiti"/>
+        <a:font script="Viet" typeface="Arial"/>
+        <a:font script="Uigh" typeface="Microsoft Uighur"/>
+        <a:font script="Geor" typeface="Sylfaen"/>
+        <a:font script="Armn" typeface="Arial"/>
+        <a:font script="Bugi" typeface="Leelawadee UI"/>
+        <a:font script="Bopo" typeface="Microsoft JhengHei"/>
+        <a:font script="Java" typeface="Javanese Text"/>
+        <a:font script="Lisu" typeface="Segoe UI"/>
+        <a:font script="Mymr" typeface="Myanmar Text"/>
+        <a:font script="Nkoo" typeface="Ebrima"/>
+        <a:font script="Olck" typeface="Nirmala UI"/>
+        <a:font script="Osma" typeface="Ebrima"/>
+        <a:font script="Phag" typeface="Phagspa"/>
+        <a:font script="Syrn" typeface="Estrangelo Edessa"/>
+        <a:font script="Syrj" typeface="Estrangelo Edessa"/>
+        <a:font script="Syre" typeface="Estrangelo Edessa"/>
+        <a:font script="Sora" typeface="Nirmala UI"/>
+        <a:font script="Tale" typeface="Microsoft Tai Le"/>
+        <a:font script="Talu" typeface="Microsoft New Tai Lue"/>
+        <a:font script="Tfng" typeface="Ebrima"/>
+      </a:minorFont>
+    </a:fontScheme>
+    <a:fmtScheme name="Office">
+      <a:fillStyleLst>
+        <a:solidFill>
+          <a:schemeClr val="phClr"/>
+        </a:solidFill>
+        <a:gradFill rotWithShape="1">
+          <a:gsLst>
+            <a:gs pos="0">
+              <a:schemeClr val="phClr">
+                <a:lumMod val="110000"/>
+                <a:satMod val="105000"/>
+                <a:tint val="67000"/>
+              </a:schemeClr>
+            </a:gs>
+            <a:gs pos="50000">
+              <a:schemeClr val="phClr">
+                <a:lumMod val="105000"/>
+                <a:satMod val="103000"/>
+                <a:tint val="73000"/>
+              </a:schemeClr>
+            </a:gs>
+            <a:gs pos="100000">
+              <a:schemeClr val="phClr">
+                <a:lumMod val="105000"/>
+                <a:satMod val="109000"/>
+                <a:tint val="81000"/>
+              </a:schemeClr>
+            </a:gs>
+          </a:gsLst>
+          <a:lin ang="5400000" scaled="0"/>
+        </a:gradFill>
+        <a:gradFill rotWithShape="1">
+          <a:gsLst>
+            <a:gs pos="0">
+              <a:schemeClr val="phClr">
+                <a:satMod val="103000"/>
+                <a:lumMod val="102000"/>
+                <a:tint val="94000"/>
+              </a:schemeClr>
+            </a:gs>
+            <a:gs pos="50000">
+              <a:schemeClr val="phClr">
+                <a:satMod val="110000"/>
+                <a:lumMod val="100000"/>
+                <a:shade val="100000"/>
+              </a:schemeClr>
+            </a:gs>
+            <a:gs pos="100000">
+              <a:schemeClr val="phClr">
+                <a:lumMod val="99000"/>
+                <a:satMod val="120000"/>
+                <a:shade val="78000"/>
+              </a:schemeClr>
+            </a:gs>
+          </a:gsLst>
+          <a:lin ang="5400000" scaled="0"/>
+        </a:gradFill>
+      </a:fillStyleLst>
+      <a:lnStyleLst>
+        <a:ln w="6350" cap="flat" cmpd="sng" algn="ctr">
+          <a:solidFill>
+            <a:schemeClr val="phClr"/>
+          </a:solidFill>
+          <a:prstDash val="solid"/>
+          <a:miter lim="800000"/>
+        </a:ln>
+        <a:ln w="12700" cap="flat" cmpd="sng" algn="ctr">
+          <a:solidFill>
+            <a:schemeClr val="phClr"/>
+          </a:solidFill>
+          <a:prstDash val="solid"/>
+          <a:miter lim="800000"/>
+        </a:ln>
+        <a:ln w="19050" cap="flat" cmpd="sng" algn="ctr">
+          <a:solidFill>
+            <a:schemeClr val="phClr"/>
+          </a:solidFill>
+          <a:prstDash val="solid"/>
+          <a:miter lim="800000"/>
+        </a:ln>
+      </a:lnStyleLst>
+      <a:effectStyleLst>
+        <a:effectStyle>
+          <a:effectLst/>
+        </a:effectStyle>
+        <a:effectStyle>
+          <a:effectLst/>
+        </a:effectStyle>
+        <a:effectStyle>
+          <a:effectLst>
+            <a:outerShdw blurRad="57150" dist="19050" dir="5400000" algn="ctr" rotWithShape="0">
+              <a:srgbClr val="000000">
+                <a:alpha val="63000"/>
+              </a:srgbClr>
+            </a:outerShdw>
+          </a:effectLst>
+        </a:effectStyle>
+      </a:effectStyleLst>
+      <a:bgFillStyleLst>
+        <a:solidFill>
+          <a:schemeClr val="phClr"/>
+        </a:solidFill>
+        <a:solidFill>
+          <a:schemeClr val="phClr">
+            <a:tint val="95000"/>
+            <a:satMod val="170000"/>
+          </a:schemeClr>
+        </a:solidFill>
+        <a:gradFill rotWithShape="1">
+          <a:gsLst>
+            <a:gs pos="0">
+              <a:schemeClr val="phClr">
+                <a:tint val="93000"/>
+                <a:satMod val="150000"/>
+                <a:shade val="98000"/>
+                <a:lumMod val="102000"/>
+              </a:schemeClr>
+            </a:gs>
+            <a:gs pos="50000">
+              <a:schemeClr val="phClr">
+                <a:tint val="98000"/>
+                <a:satMod val="130000"/>
+                <a:shade val="90000"/>
+                <a:lumMod val="103000"/>
+              </a:schemeClr>
+            </a:gs>
+            <a:gs pos="100000">
+              <a:schemeClr val="phClr">
+                <a:shade val="63000"/>
+                <a:satMod val="120000"/>
+              </a:schemeClr>
+            </a:gs>
+          </a:gsLst>
+          <a:lin ang="5400000" scaled="0"/>
+        </a:gradFill>
+      </a:bgFillStyleLst>
+    </a:fmtScheme>
+  </a:themeElements>
+  <a:objectDefaults/>
+  <a:extraClrSchemeLst/>
+  <a:extLst>
+    <a:ext uri="{05A4C25C-085E-4340-85A3-A5531E510DB2}">
+      <thm15:themeFamily xmlns:thm15="http://schemas.microsoft.com/office/thememl/2012/main" name="Office Theme" id="{62F939B6-93AF-4DB8-9C6B-D6C7DFDC589F}" vid="{4A3C46E8-61CC-4603-A589-7422A47A8E4A}"/>
+    </a:ext>
+  </a:extLst>
+</a:theme>
 </file>
</xml_diff>